<commit_message>
docs: dark theme and higher-contrast charts for the banking proposal
All slides use navy surfaces; doughnut and bar charts render on a dark
plot with teal/sky/amber series and light labels instead of a white box.
</commit_message>
<xml_diff>
--- a/docs/Propuesta_Callcenter_Bancario.pptx
+++ b/docs/Propuesta_Callcenter_Bancario.pptx
@@ -160,7 +160,7 @@
             <c:bubble3D val="0"/>
             <c:spPr>
               <a:solidFill>
-                <a:srgbClr val="F59E0B"/>
+                <a:srgbClr val="FBBF24"/>
               </a:solidFill>
               <a:effectLst/>
             </c:spPr>
@@ -170,7 +170,7 @@
             <c:bubble3D val="0"/>
             <c:spPr>
               <a:solidFill>
-                <a:srgbClr val="64748B"/>
+                <a:srgbClr val="94A3B8"/>
               </a:solidFill>
               <a:effectLst/>
             </c:spPr>
@@ -180,7 +180,7 @@
             <c:bubble3D val="0"/>
             <c:spPr>
               <a:solidFill>
-                <a:srgbClr val="EF4444"/>
+                <a:srgbClr val="FB7185"/>
               </a:solidFill>
               <a:effectLst/>
             </c:spPr>
@@ -190,7 +190,7 @@
             <c:bubble3D val="0"/>
             <c:spPr>
               <a:solidFill>
-                <a:srgbClr val="0D9488"/>
+                <a:srgbClr val="2DD4BF"/>
               </a:solidFill>
               <a:effectLst/>
             </c:spPr>
@@ -205,11 +205,11 @@
                 <a:lstStyle/>
                 <a:p>
                   <a:pPr>
-                    <a:defRPr sz="1200" b="0" i="0" u="none" strike="noStrike">
+                    <a:defRPr sz="1200" b="1" i="0" u="none" strike="noStrike">
                       <a:solidFill>
-                        <a:srgbClr val="000000"/>
+                        <a:srgbClr val="F8FAFC"/>
                       </a:solidFill>
-                      <a:latin typeface="Arial"/>
+                      <a:latin typeface="Calibri"/>
                     </a:defRPr>
                   </a:pPr>
                 </a:p>
@@ -230,11 +230,11 @@
                 <a:lstStyle/>
                 <a:p>
                   <a:pPr>
-                    <a:defRPr sz="1200" b="0" i="0" u="none" strike="noStrike">
+                    <a:defRPr sz="1200" b="1" i="0" u="none" strike="noStrike">
                       <a:solidFill>
-                        <a:srgbClr val="000000"/>
+                        <a:srgbClr val="F8FAFC"/>
                       </a:solidFill>
-                      <a:latin typeface="Arial"/>
+                      <a:latin typeface="Calibri"/>
                     </a:defRPr>
                   </a:pPr>
                 </a:p>
@@ -255,11 +255,11 @@
                 <a:lstStyle/>
                 <a:p>
                   <a:pPr>
-                    <a:defRPr sz="1200" b="0" i="0" u="none" strike="noStrike">
+                    <a:defRPr sz="1200" b="1" i="0" u="none" strike="noStrike">
                       <a:solidFill>
-                        <a:srgbClr val="000000"/>
+                        <a:srgbClr val="F8FAFC"/>
                       </a:solidFill>
-                      <a:latin typeface="Arial"/>
+                      <a:latin typeface="Calibri"/>
                     </a:defRPr>
                   </a:pPr>
                 </a:p>
@@ -280,11 +280,11 @@
                 <a:lstStyle/>
                 <a:p>
                   <a:pPr>
-                    <a:defRPr sz="1200" b="0" i="0" u="none" strike="noStrike">
+                    <a:defRPr sz="1200" b="1" i="0" u="none" strike="noStrike">
                       <a:solidFill>
-                        <a:srgbClr val="000000"/>
+                        <a:srgbClr val="F8FAFC"/>
                       </a:solidFill>
-                      <a:latin typeface="Arial"/>
+                      <a:latin typeface="Calibri"/>
                     </a:defRPr>
                   </a:pPr>
                 </a:p>
@@ -302,7 +302,7 @@
               <a:lstStyle/>
               <a:p>
                 <a:pPr>
-                  <a:defRPr sz="1800" b="0" i="0" u="none" strike="noStrike">
+                  <a:defRPr sz="1800" b="1" i="0" u="none" strike="noStrike">
                     <a:solidFill>
                       <a:srgbClr val="000000"/>
                     </a:solidFill>
@@ -361,11 +361,11 @@
           </c:val>
         </c:ser>
         <c:firstSliceAng val="0"/>
-        <c:holeSize val="50"/>
+        <c:holeSize val="58"/>
       </c:doughnutChart>
       <c:spPr>
         <a:solidFill>
-          <a:srgbClr val="FFFFFF"/>
+          <a:srgbClr val="070B14"/>
         </a:solidFill>
         <a:ln>
           <a:noFill/>
@@ -381,9 +381,9 @@
         <a:lstStyle/>
         <a:p>
           <a:pPr>
-            <a:defRPr sz="1100">
+            <a:defRPr sz="1200">
               <a:solidFill>
-                <a:srgbClr val="475569"/>
+                <a:srgbClr val="CBD5E1"/>
               </a:solidFill>
               <a:latin typeface="Calibri"/>
               <a:cs typeface="Calibri"/>
@@ -398,7 +398,7 @@
   </c:chart>
   <c:spPr>
     <a:solidFill>
-      <a:srgbClr val="FFFFFF"/>
+      <a:srgbClr val="070B14"/>
     </a:solidFill>
     <a:ln>
       <a:noFill/>
@@ -439,7 +439,7 @@
           </c:tx>
           <c:spPr>
             <a:solidFill>
-              <a:srgbClr val="0D9488"/>
+              <a:srgbClr val="2DD4BF"/>
             </a:solidFill>
             <a:effectLst/>
           </c:spPr>
@@ -451,9 +451,9 @@
               <a:lstStyle/>
               <a:p>
                 <a:pPr>
-                  <a:defRPr b="0" i="0" strike="noStrike" sz="1200" u="none">
+                  <a:defRPr b="1" i="0" strike="noStrike" sz="1300" u="none">
                     <a:solidFill>
-                      <a:srgbClr val="0A1628"/>
+                      <a:srgbClr val="5EEAD4"/>
                     </a:solidFill>
                     <a:latin typeface="Calibri"/>
                   </a:defRPr>
@@ -519,9 +519,9 @@
             <a:lstStyle/>
             <a:p>
               <a:pPr>
-                <a:defRPr b="0" i="0" strike="noStrike" sz="1200" u="none">
+                <a:defRPr b="1" i="0" strike="noStrike" sz="1300" u="none">
                   <a:solidFill>
-                    <a:srgbClr val="0A1628"/>
+                    <a:srgbClr val="5EEAD4"/>
                   </a:solidFill>
                   <a:latin typeface="Calibri"/>
                 </a:defRPr>
@@ -567,9 +567,9 @@
           <a:lstStyle/>
           <a:p>
             <a:pPr>
-              <a:defRPr sz="1100" b="0" i="0" u="none" strike="noStrike">
-                <a:solidFill>
-                  <a:srgbClr val="64748B"/>
+              <a:defRPr sz="1200" b="0" i="0" u="none" strike="noStrike">
+                <a:solidFill>
+                  <a:srgbClr val="CBD5E1"/>
                 </a:solidFill>
                 <a:latin typeface="Calibri"/>
               </a:defRPr>
@@ -592,9 +592,9 @@
         <c:axPos val="b"/>
         <c:majorGridlines>
           <c:spPr>
-            <a:ln w="6350" cap="flat">
+            <a:ln w="9525" cap="flat">
               <a:solidFill>
-                <a:srgbClr val="E2E8F0"/>
+                <a:srgbClr val="2A4060"/>
               </a:solidFill>
               <a:prstDash val="solid"/>
               <a:round/>
@@ -621,7 +621,7 @@
             <a:pPr>
               <a:defRPr sz="1100" b="0" i="0" u="none" strike="noStrike">
                 <a:solidFill>
-                  <a:srgbClr val="64748B"/>
+                  <a:srgbClr val="94A3B8"/>
                 </a:solidFill>
                 <a:latin typeface="Calibri"/>
               </a:defRPr>
@@ -635,7 +635,7 @@
       </c:valAx>
       <c:spPr>
         <a:solidFill>
-          <a:srgbClr val="FFFFFF"/>
+          <a:srgbClr val="070B14"/>
         </a:solidFill>
         <a:ln>
           <a:noFill/>
@@ -648,7 +648,7 @@
   </c:chart>
   <c:spPr>
     <a:solidFill>
-      <a:srgbClr val="FFFFFF"/>
+      <a:srgbClr val="070B14"/>
     </a:solidFill>
     <a:ln>
       <a:noFill/>
@@ -703,7 +703,7 @@
             <c:bubble3D val="0"/>
             <c:spPr>
               <a:solidFill>
-                <a:srgbClr val="0D9488"/>
+                <a:srgbClr val="2DD4BF"/>
               </a:solidFill>
               <a:effectLst/>
             </c:spPr>
@@ -713,7 +713,7 @@
             <c:bubble3D val="0"/>
             <c:spPr>
               <a:solidFill>
-                <a:srgbClr val="0A1628"/>
+                <a:srgbClr val="38BDF8"/>
               </a:solidFill>
               <a:effectLst/>
             </c:spPr>
@@ -723,7 +723,7 @@
             <c:bubble3D val="0"/>
             <c:spPr>
               <a:solidFill>
-                <a:srgbClr val="F59E0B"/>
+                <a:srgbClr val="FBBF24"/>
               </a:solidFill>
               <a:effectLst/>
             </c:spPr>
@@ -733,7 +733,7 @@
             <c:bubble3D val="0"/>
             <c:spPr>
               <a:solidFill>
-                <a:srgbClr val="64748B"/>
+                <a:srgbClr val="94A3B8"/>
               </a:solidFill>
               <a:effectLst/>
             </c:spPr>
@@ -748,11 +748,11 @@
                 <a:lstStyle/>
                 <a:p>
                   <a:pPr>
-                    <a:defRPr sz="1200" b="0" i="0" u="none" strike="noStrike">
+                    <a:defRPr sz="1200" b="1" i="0" u="none" strike="noStrike">
                       <a:solidFill>
-                        <a:srgbClr val="000000"/>
+                        <a:srgbClr val="F8FAFC"/>
                       </a:solidFill>
-                      <a:latin typeface="Arial"/>
+                      <a:latin typeface="Calibri"/>
                     </a:defRPr>
                   </a:pPr>
                 </a:p>
@@ -773,11 +773,11 @@
                 <a:lstStyle/>
                 <a:p>
                   <a:pPr>
-                    <a:defRPr sz="1200" b="0" i="0" u="none" strike="noStrike">
+                    <a:defRPr sz="1200" b="1" i="0" u="none" strike="noStrike">
                       <a:solidFill>
-                        <a:srgbClr val="000000"/>
+                        <a:srgbClr val="F8FAFC"/>
                       </a:solidFill>
-                      <a:latin typeface="Arial"/>
+                      <a:latin typeface="Calibri"/>
                     </a:defRPr>
                   </a:pPr>
                 </a:p>
@@ -798,11 +798,11 @@
                 <a:lstStyle/>
                 <a:p>
                   <a:pPr>
-                    <a:defRPr sz="1200" b="0" i="0" u="none" strike="noStrike">
+                    <a:defRPr sz="1200" b="1" i="0" u="none" strike="noStrike">
                       <a:solidFill>
-                        <a:srgbClr val="000000"/>
+                        <a:srgbClr val="F8FAFC"/>
                       </a:solidFill>
-                      <a:latin typeface="Arial"/>
+                      <a:latin typeface="Calibri"/>
                     </a:defRPr>
                   </a:pPr>
                 </a:p>
@@ -823,11 +823,11 @@
                 <a:lstStyle/>
                 <a:p>
                   <a:pPr>
-                    <a:defRPr sz="1200" b="0" i="0" u="none" strike="noStrike">
+                    <a:defRPr sz="1200" b="1" i="0" u="none" strike="noStrike">
                       <a:solidFill>
-                        <a:srgbClr val="000000"/>
+                        <a:srgbClr val="F8FAFC"/>
                       </a:solidFill>
-                      <a:latin typeface="Arial"/>
+                      <a:latin typeface="Calibri"/>
                     </a:defRPr>
                   </a:pPr>
                 </a:p>
@@ -845,7 +845,7 @@
               <a:lstStyle/>
               <a:p>
                 <a:pPr>
-                  <a:defRPr sz="1800" b="0" i="0" u="none" strike="noStrike">
+                  <a:defRPr sz="1800" b="1" i="0" u="none" strike="noStrike">
                     <a:solidFill>
                       <a:srgbClr val="000000"/>
                     </a:solidFill>
@@ -904,11 +904,11 @@
           </c:val>
         </c:ser>
         <c:firstSliceAng val="0"/>
-        <c:holeSize val="50"/>
+        <c:holeSize val="62"/>
       </c:doughnutChart>
       <c:spPr>
         <a:solidFill>
-          <a:srgbClr val="FFFFFF"/>
+          <a:srgbClr val="070B14"/>
         </a:solidFill>
         <a:ln>
           <a:noFill/>
@@ -926,7 +926,7 @@
           <a:pPr>
             <a:defRPr sz="1200">
               <a:solidFill>
-                <a:srgbClr val="475569"/>
+                <a:srgbClr val="CBD5E1"/>
               </a:solidFill>
               <a:latin typeface="Calibri"/>
               <a:cs typeface="Calibri"/>
@@ -941,7 +941,7 @@
   </c:chart>
   <c:spPr>
     <a:solidFill>
-      <a:srgbClr val="FFFFFF"/>
+      <a:srgbClr val="070B14"/>
     </a:solidFill>
     <a:ln>
       <a:noFill/>
@@ -994,9 +994,9 @@
               <a:lstStyle/>
               <a:p>
                 <a:pPr>
-                  <a:defRPr b="0" i="0" strike="noStrike" sz="1000" u="none">
+                  <a:defRPr b="1" i="0" strike="noStrike" sz="1100" u="none">
                     <a:solidFill>
-                      <a:srgbClr val="0A1628"/>
+                      <a:srgbClr val="F8FAFC"/>
                     </a:solidFill>
                     <a:latin typeface="Calibri"/>
                   </a:defRPr>
@@ -1071,7 +1071,7 @@
           </c:tx>
           <c:spPr>
             <a:solidFill>
-              <a:srgbClr val="0D9488"/>
+              <a:srgbClr val="2DD4BF"/>
             </a:solidFill>
             <a:effectLst/>
           </c:spPr>
@@ -1083,9 +1083,9 @@
               <a:lstStyle/>
               <a:p>
                 <a:pPr>
-                  <a:defRPr b="0" i="0" strike="noStrike" sz="1000" u="none">
+                  <a:defRPr b="1" i="0" strike="noStrike" sz="1100" u="none">
                     <a:solidFill>
-                      <a:srgbClr val="0A1628"/>
+                      <a:srgbClr val="F8FAFC"/>
                     </a:solidFill>
                     <a:latin typeface="Calibri"/>
                   </a:defRPr>
@@ -1151,9 +1151,9 @@
             <a:lstStyle/>
             <a:p>
               <a:pPr>
-                <a:defRPr b="0" i="0" strike="noStrike" sz="1000" u="none">
+                <a:defRPr b="1" i="0" strike="noStrike" sz="1100" u="none">
                   <a:solidFill>
-                    <a:srgbClr val="0A1628"/>
+                    <a:srgbClr val="F8FAFC"/>
                   </a:solidFill>
                   <a:latin typeface="Calibri"/>
                 </a:defRPr>
@@ -1199,9 +1199,9 @@
           <a:lstStyle/>
           <a:p>
             <a:pPr>
-              <a:defRPr sz="1100" b="0" i="0" u="none" strike="noStrike">
-                <a:solidFill>
-                  <a:srgbClr val="64748B"/>
+              <a:defRPr sz="1200" b="0" i="0" u="none" strike="noStrike">
+                <a:solidFill>
+                  <a:srgbClr val="CBD5E1"/>
                 </a:solidFill>
                 <a:latin typeface="Calibri"/>
               </a:defRPr>
@@ -1224,9 +1224,9 @@
         <c:axPos val="l"/>
         <c:majorGridlines>
           <c:spPr>
-            <a:ln w="6350" cap="flat">
+            <a:ln w="9525" cap="flat">
               <a:solidFill>
-                <a:srgbClr val="E2E8F0"/>
+                <a:srgbClr val="2A4060"/>
               </a:solidFill>
               <a:prstDash val="solid"/>
               <a:round/>
@@ -1253,7 +1253,7 @@
             <a:pPr>
               <a:defRPr sz="1100" b="0" i="0" u="none" strike="noStrike">
                 <a:solidFill>
-                  <a:srgbClr val="64748B"/>
+                  <a:srgbClr val="94A3B8"/>
                 </a:solidFill>
                 <a:latin typeface="Calibri"/>
               </a:defRPr>
@@ -1267,7 +1267,7 @@
       </c:valAx>
       <c:spPr>
         <a:solidFill>
-          <a:srgbClr val="FFFFFF"/>
+          <a:srgbClr val="070B14"/>
         </a:solidFill>
         <a:ln>
           <a:noFill/>
@@ -1283,9 +1283,9 @@
         <a:lstStyle/>
         <a:p>
           <a:pPr>
-            <a:defRPr sz="1200">
+            <a:defRPr sz="1300">
               <a:solidFill>
-                <a:srgbClr val="475569"/>
+                <a:srgbClr val="CBD5E1"/>
               </a:solidFill>
               <a:latin typeface="Calibri"/>
               <a:cs typeface="Calibri"/>
@@ -1300,7 +1300,7 @@
   </c:chart>
   <c:spPr>
     <a:solidFill>
-      <a:srgbClr val="FFFFFF"/>
+      <a:srgbClr val="070B14"/>
     </a:solidFill>
     <a:ln>
       <a:noFill/>
@@ -3031,7 +3031,7 @@
     <p:bg>
       <p:bgPr>
         <a:solidFill>
-          <a:srgbClr val="0A1628"/>
+          <a:srgbClr val="070B14"/>
         </a:solidFill>
       </p:bgPr>
     </p:bg>
@@ -3104,7 +3104,7 @@
             <a:avLst/>
           </a:prstGeom>
           <a:solidFill>
-            <a:srgbClr val="0D9488"/>
+            <a:srgbClr val="2DD4BF"/>
           </a:solidFill>
           <a:ln/>
         </p:spPr>
@@ -3199,7 +3199,7 @@
             <a:r>
               <a:rPr lang="en-US" sz="3400" b="1" dirty="0">
                 <a:solidFill>
-                  <a:srgbClr val="FFFFFF"/>
+                  <a:srgbClr val="F8FAFC"/>
                 </a:solidFill>
                 <a:latin typeface="Calibri" pitchFamily="34" charset="0"/>
                 <a:ea typeface="Calibri" pitchFamily="34" charset="-122"/>
@@ -3216,7 +3216,7 @@
             <a:r>
               <a:rPr lang="en-US" sz="3400" b="1" dirty="0">
                 <a:solidFill>
-                  <a:srgbClr val="FFFFFF"/>
+                  <a:srgbClr val="F8FAFC"/>
                 </a:solidFill>
                 <a:latin typeface="Calibri" pitchFamily="34" charset="0"/>
                 <a:ea typeface="Calibri" pitchFamily="34" charset="-122"/>
@@ -3282,7 +3282,7 @@
             <a:avLst/>
           </a:prstGeom>
           <a:solidFill>
-            <a:srgbClr val="122A45"/>
+            <a:srgbClr val="101827"/>
           </a:solidFill>
           <a:ln/>
         </p:spPr>
@@ -3302,7 +3302,7 @@
             <a:avLst/>
           </a:prstGeom>
           <a:solidFill>
-            <a:srgbClr val="0D9488"/>
+            <a:srgbClr val="2DD4BF"/>
           </a:solidFill>
           <a:ln/>
         </p:spPr>
@@ -3417,7 +3417,7 @@
             <a:avLst/>
           </a:prstGeom>
           <a:solidFill>
-            <a:srgbClr val="122A45"/>
+            <a:srgbClr val="101827"/>
           </a:solidFill>
           <a:ln/>
         </p:spPr>
@@ -3437,7 +3437,7 @@
             <a:avLst/>
           </a:prstGeom>
           <a:solidFill>
-            <a:srgbClr val="0D9488"/>
+            <a:srgbClr val="2DD4BF"/>
           </a:solidFill>
           <a:ln/>
         </p:spPr>
@@ -3552,7 +3552,7 @@
             <a:avLst/>
           </a:prstGeom>
           <a:solidFill>
-            <a:srgbClr val="122A45"/>
+            <a:srgbClr val="101827"/>
           </a:solidFill>
           <a:ln/>
         </p:spPr>
@@ -3572,7 +3572,7 @@
             <a:avLst/>
           </a:prstGeom>
           <a:solidFill>
-            <a:srgbClr val="0D9488"/>
+            <a:srgbClr val="2DD4BF"/>
           </a:solidFill>
           <a:ln/>
         </p:spPr>
@@ -3699,7 +3699,7 @@
             <a:r>
               <a:rPr lang="en-US" sz="1200" b="1" dirty="0">
                 <a:solidFill>
-                  <a:srgbClr val="0D9488"/>
+                  <a:srgbClr val="2DD4BF"/>
                 </a:solidFill>
                 <a:latin typeface="Calibri" pitchFamily="34" charset="0"/>
                 <a:ea typeface="Calibri" pitchFamily="34" charset="-122"/>
@@ -3725,7 +3725,7 @@
     <p:bg>
       <p:bgPr>
         <a:solidFill>
-          <a:srgbClr val="F4F7FB"/>
+          <a:srgbClr val="070B14"/>
         </a:solidFill>
       </p:bgPr>
     </p:bg>
@@ -3758,7 +3758,7 @@
             <a:avLst/>
           </a:prstGeom>
           <a:solidFill>
-            <a:srgbClr val="0D9488"/>
+            <a:srgbClr val="2DD4BF"/>
           </a:solidFill>
           <a:ln/>
         </p:spPr>
@@ -3790,7 +3790,7 @@
             <a:r>
               <a:rPr lang="en-US" sz="1100" b="1" spc="220" kern="0" dirty="0">
                 <a:solidFill>
-                  <a:srgbClr val="0D9488"/>
+                  <a:srgbClr val="2DD4BF"/>
                 </a:solidFill>
                 <a:latin typeface="Calibri" pitchFamily="34" charset="0"/>
                 <a:ea typeface="Calibri" pitchFamily="34" charset="-122"/>
@@ -3829,7 +3829,7 @@
             <a:r>
               <a:rPr lang="en-US" sz="2600" b="1" dirty="0">
                 <a:solidFill>
-                  <a:srgbClr val="0A1628"/>
+                  <a:srgbClr val="F8FAFC"/>
                 </a:solidFill>
                 <a:latin typeface="Calibri" pitchFamily="34" charset="0"/>
                 <a:ea typeface="Calibri" pitchFamily="34" charset="-122"/>
@@ -3856,18 +3856,18 @@
             <a:avLst/>
           </a:prstGeom>
           <a:solidFill>
-            <a:srgbClr val="FFFFFF"/>
+            <a:srgbClr val="152033"/>
           </a:solidFill>
           <a:ln w="12700">
             <a:solidFill>
-              <a:srgbClr val="E2E8F0"/>
+              <a:srgbClr val="2A4060"/>
             </a:solidFill>
             <a:prstDash val="solid"/>
           </a:ln>
           <a:effectLst>
-            <a:outerShdw sx="100000" sy="100000" kx="0" ky="0" algn="bl" rotWithShape="0" blurRad="127000" dist="38100" dir="8100000">
-              <a:srgbClr val="0A1628">
-                <a:alpha val="8000"/>
+            <a:outerShdw sx="100000" sy="100000" kx="0" ky="0" algn="bl" rotWithShape="0" blurRad="152400" dist="25400" dir="8100000">
+              <a:srgbClr val="000000">
+                <a:alpha val="35000"/>
               </a:srgbClr>
             </a:outerShdw>
           </a:effectLst>
@@ -3888,7 +3888,7 @@
             <a:avLst/>
           </a:prstGeom>
           <a:solidFill>
-            <a:srgbClr val="0D9488"/>
+            <a:srgbClr val="2DD4BF"/>
           </a:solidFill>
           <a:ln/>
         </p:spPr>
@@ -3944,7 +3944,7 @@
             <a:r>
               <a:rPr lang="en-US" sz="1800" b="1" dirty="0">
                 <a:solidFill>
-                  <a:srgbClr val="0A1628"/>
+                  <a:srgbClr val="F8FAFC"/>
                 </a:solidFill>
                 <a:latin typeface="Calibri" pitchFamily="34" charset="0"/>
                 <a:ea typeface="Calibri" pitchFamily="34" charset="-122"/>
@@ -3983,7 +3983,7 @@
             <a:r>
               <a:rPr lang="en-US" sz="1500" dirty="0">
                 <a:solidFill>
-                  <a:srgbClr val="475569"/>
+                  <a:srgbClr val="CBD5E1"/>
                 </a:solidFill>
                 <a:latin typeface="Calibri" pitchFamily="34" charset="0"/>
                 <a:ea typeface="Calibri" pitchFamily="34" charset="-122"/>
@@ -4010,18 +4010,18 @@
             <a:avLst/>
           </a:prstGeom>
           <a:solidFill>
-            <a:srgbClr val="FFFFFF"/>
+            <a:srgbClr val="152033"/>
           </a:solidFill>
           <a:ln w="12700">
             <a:solidFill>
-              <a:srgbClr val="E2E8F0"/>
+              <a:srgbClr val="2A4060"/>
             </a:solidFill>
             <a:prstDash val="solid"/>
           </a:ln>
           <a:effectLst>
-            <a:outerShdw sx="100000" sy="100000" kx="0" ky="0" algn="bl" rotWithShape="0" blurRad="127000" dist="38100" dir="8100000">
-              <a:srgbClr val="0A1628">
-                <a:alpha val="8000"/>
+            <a:outerShdw sx="100000" sy="100000" kx="0" ky="0" algn="bl" rotWithShape="0" blurRad="152400" dist="25400" dir="8100000">
+              <a:srgbClr val="000000">
+                <a:alpha val="35000"/>
               </a:srgbClr>
             </a:outerShdw>
           </a:effectLst>
@@ -4042,7 +4042,7 @@
             <a:avLst/>
           </a:prstGeom>
           <a:solidFill>
-            <a:srgbClr val="0D9488"/>
+            <a:srgbClr val="2DD4BF"/>
           </a:solidFill>
           <a:ln/>
         </p:spPr>
@@ -4098,7 +4098,7 @@
             <a:r>
               <a:rPr lang="en-US" sz="1800" b="1" dirty="0">
                 <a:solidFill>
-                  <a:srgbClr val="0A1628"/>
+                  <a:srgbClr val="F8FAFC"/>
                 </a:solidFill>
                 <a:latin typeface="Calibri" pitchFamily="34" charset="0"/>
                 <a:ea typeface="Calibri" pitchFamily="34" charset="-122"/>
@@ -4137,7 +4137,7 @@
             <a:r>
               <a:rPr lang="en-US" sz="1500" dirty="0">
                 <a:solidFill>
-                  <a:srgbClr val="475569"/>
+                  <a:srgbClr val="CBD5E1"/>
                 </a:solidFill>
                 <a:latin typeface="Calibri" pitchFamily="34" charset="0"/>
                 <a:ea typeface="Calibri" pitchFamily="34" charset="-122"/>
@@ -4164,18 +4164,18 @@
             <a:avLst/>
           </a:prstGeom>
           <a:solidFill>
-            <a:srgbClr val="FFFFFF"/>
+            <a:srgbClr val="152033"/>
           </a:solidFill>
           <a:ln w="12700">
             <a:solidFill>
-              <a:srgbClr val="E2E8F0"/>
+              <a:srgbClr val="2A4060"/>
             </a:solidFill>
             <a:prstDash val="solid"/>
           </a:ln>
           <a:effectLst>
-            <a:outerShdw sx="100000" sy="100000" kx="0" ky="0" algn="bl" rotWithShape="0" blurRad="127000" dist="38100" dir="8100000">
-              <a:srgbClr val="0A1628">
-                <a:alpha val="8000"/>
+            <a:outerShdw sx="100000" sy="100000" kx="0" ky="0" algn="bl" rotWithShape="0" blurRad="152400" dist="25400" dir="8100000">
+              <a:srgbClr val="000000">
+                <a:alpha val="35000"/>
               </a:srgbClr>
             </a:outerShdw>
           </a:effectLst>
@@ -4196,7 +4196,7 @@
             <a:avLst/>
           </a:prstGeom>
           <a:solidFill>
-            <a:srgbClr val="0D9488"/>
+            <a:srgbClr val="2DD4BF"/>
           </a:solidFill>
           <a:ln/>
         </p:spPr>
@@ -4252,7 +4252,7 @@
             <a:r>
               <a:rPr lang="en-US" sz="1800" b="1" dirty="0">
                 <a:solidFill>
-                  <a:srgbClr val="0A1628"/>
+                  <a:srgbClr val="F8FAFC"/>
                 </a:solidFill>
                 <a:latin typeface="Calibri" pitchFamily="34" charset="0"/>
                 <a:ea typeface="Calibri" pitchFamily="34" charset="-122"/>
@@ -4291,7 +4291,7 @@
             <a:r>
               <a:rPr lang="en-US" sz="1500" dirty="0">
                 <a:solidFill>
-                  <a:srgbClr val="475569"/>
+                  <a:srgbClr val="CBD5E1"/>
                 </a:solidFill>
                 <a:latin typeface="Calibri" pitchFamily="34" charset="0"/>
                 <a:ea typeface="Calibri" pitchFamily="34" charset="-122"/>
@@ -4318,18 +4318,18 @@
             <a:avLst/>
           </a:prstGeom>
           <a:solidFill>
-            <a:srgbClr val="FFFFFF"/>
+            <a:srgbClr val="152033"/>
           </a:solidFill>
           <a:ln w="12700">
             <a:solidFill>
-              <a:srgbClr val="E2E8F0"/>
+              <a:srgbClr val="2A4060"/>
             </a:solidFill>
             <a:prstDash val="solid"/>
           </a:ln>
           <a:effectLst>
-            <a:outerShdw sx="100000" sy="100000" kx="0" ky="0" algn="bl" rotWithShape="0" blurRad="127000" dist="38100" dir="8100000">
-              <a:srgbClr val="0A1628">
-                <a:alpha val="8000"/>
+            <a:outerShdw sx="100000" sy="100000" kx="0" ky="0" algn="bl" rotWithShape="0" blurRad="152400" dist="25400" dir="8100000">
+              <a:srgbClr val="000000">
+                <a:alpha val="35000"/>
               </a:srgbClr>
             </a:outerShdw>
           </a:effectLst>
@@ -4350,7 +4350,7 @@
             <a:avLst/>
           </a:prstGeom>
           <a:solidFill>
-            <a:srgbClr val="0D9488"/>
+            <a:srgbClr val="2DD4BF"/>
           </a:solidFill>
           <a:ln/>
         </p:spPr>
@@ -4406,7 +4406,7 @@
             <a:r>
               <a:rPr lang="en-US" sz="1800" b="1" dirty="0">
                 <a:solidFill>
-                  <a:srgbClr val="0A1628"/>
+                  <a:srgbClr val="F8FAFC"/>
                 </a:solidFill>
                 <a:latin typeface="Calibri" pitchFamily="34" charset="0"/>
                 <a:ea typeface="Calibri" pitchFamily="34" charset="-122"/>
@@ -4445,7 +4445,7 @@
             <a:r>
               <a:rPr lang="en-US" sz="1500" dirty="0">
                 <a:solidFill>
-                  <a:srgbClr val="475569"/>
+                  <a:srgbClr val="CBD5E1"/>
                 </a:solidFill>
                 <a:latin typeface="Calibri" pitchFamily="34" charset="0"/>
                 <a:ea typeface="Calibri" pitchFamily="34" charset="-122"/>
@@ -4484,7 +4484,7 @@
             <a:r>
               <a:rPr lang="en-US" sz="1000" i="1" dirty="0">
                 <a:solidFill>
-                  <a:srgbClr val="64748B"/>
+                  <a:srgbClr val="94A3B8"/>
                 </a:solidFill>
                 <a:latin typeface="Calibri" pitchFamily="34" charset="0"/>
                 <a:ea typeface="Calibri" pitchFamily="34" charset="-122"/>
@@ -4523,7 +4523,7 @@
             <a:r>
               <a:rPr lang="en-US" sz="1100" b="1" dirty="0">
                 <a:solidFill>
-                  <a:srgbClr val="0D9488"/>
+                  <a:srgbClr val="2DD4BF"/>
                 </a:solidFill>
                 <a:latin typeface="Calibri" pitchFamily="34" charset="0"/>
                 <a:ea typeface="Calibri" pitchFamily="34" charset="-122"/>
@@ -4549,7 +4549,7 @@
     <p:bg>
       <p:bgPr>
         <a:solidFill>
-          <a:srgbClr val="F4F7FB"/>
+          <a:srgbClr val="070B14"/>
         </a:solidFill>
       </p:bgPr>
     </p:bg>
@@ -4582,7 +4582,7 @@
             <a:avLst/>
           </a:prstGeom>
           <a:solidFill>
-            <a:srgbClr val="0D9488"/>
+            <a:srgbClr val="2DD4BF"/>
           </a:solidFill>
           <a:ln/>
         </p:spPr>
@@ -4614,7 +4614,7 @@
             <a:r>
               <a:rPr lang="en-US" sz="1100" b="1" spc="220" kern="0" dirty="0">
                 <a:solidFill>
-                  <a:srgbClr val="0D9488"/>
+                  <a:srgbClr val="2DD4BF"/>
                 </a:solidFill>
                 <a:latin typeface="Calibri" pitchFamily="34" charset="0"/>
                 <a:ea typeface="Calibri" pitchFamily="34" charset="-122"/>
@@ -4653,7 +4653,7 @@
             <a:r>
               <a:rPr lang="en-US" sz="2600" b="1" dirty="0">
                 <a:solidFill>
-                  <a:srgbClr val="0A1628"/>
+                  <a:srgbClr val="F8FAFC"/>
                 </a:solidFill>
                 <a:latin typeface="Calibri" pitchFamily="34" charset="0"/>
                 <a:ea typeface="Calibri" pitchFamily="34" charset="-122"/>
@@ -4680,7 +4680,7 @@
             <a:avLst/>
           </a:prstGeom>
           <a:solidFill>
-            <a:srgbClr val="0A1628"/>
+            <a:srgbClr val="101827"/>
           </a:solidFill>
           <a:ln/>
         </p:spPr>
@@ -4712,7 +4712,7 @@
             <a:r>
               <a:rPr lang="en-US" sz="1800" b="1" dirty="0">
                 <a:solidFill>
-                  <a:srgbClr val="FFFFFF"/>
+                  <a:srgbClr val="F8FAFC"/>
                 </a:solidFill>
                 <a:latin typeface="Calibri" pitchFamily="34" charset="0"/>
                 <a:ea typeface="Calibri" pitchFamily="34" charset="-122"/>
@@ -4739,11 +4739,11 @@
             <a:avLst/>
           </a:prstGeom>
           <a:solidFill>
-            <a:srgbClr val="FFFFFF"/>
+            <a:srgbClr val="152033"/>
           </a:solidFill>
           <a:ln w="12700">
             <a:solidFill>
-              <a:srgbClr val="E2E8F0"/>
+              <a:srgbClr val="2A4060"/>
             </a:solidFill>
             <a:prstDash val="solid"/>
           </a:ln>
@@ -4776,7 +4776,7 @@
             <a:r>
               <a:rPr lang="en-US" sz="1600" b="1" dirty="0">
                 <a:solidFill>
-                  <a:srgbClr val="0A1628"/>
+                  <a:srgbClr val="F8FAFC"/>
                 </a:solidFill>
                 <a:latin typeface="Calibri" pitchFamily="34" charset="0"/>
                 <a:ea typeface="Calibri" pitchFamily="34" charset="-122"/>
@@ -4815,7 +4815,7 @@
             <a:r>
               <a:rPr lang="en-US" sz="1400" dirty="0">
                 <a:solidFill>
-                  <a:srgbClr val="475569"/>
+                  <a:srgbClr val="CBD5E1"/>
                 </a:solidFill>
                 <a:latin typeface="Calibri" pitchFamily="34" charset="0"/>
                 <a:ea typeface="Calibri" pitchFamily="34" charset="-122"/>
@@ -4842,7 +4842,7 @@
             <a:avLst/>
           </a:prstGeom>
           <a:solidFill>
-            <a:srgbClr val="0A1628"/>
+            <a:srgbClr val="101827"/>
           </a:solidFill>
           <a:ln/>
         </p:spPr>
@@ -4874,7 +4874,7 @@
             <a:r>
               <a:rPr lang="en-US" sz="1800" b="1" dirty="0">
                 <a:solidFill>
-                  <a:srgbClr val="FFFFFF"/>
+                  <a:srgbClr val="F8FAFC"/>
                 </a:solidFill>
                 <a:latin typeface="Calibri" pitchFamily="34" charset="0"/>
                 <a:ea typeface="Calibri" pitchFamily="34" charset="-122"/>
@@ -4901,11 +4901,11 @@
             <a:avLst/>
           </a:prstGeom>
           <a:solidFill>
-            <a:srgbClr val="FFFFFF"/>
+            <a:srgbClr val="152033"/>
           </a:solidFill>
           <a:ln w="12700">
             <a:solidFill>
-              <a:srgbClr val="E2E8F0"/>
+              <a:srgbClr val="2A4060"/>
             </a:solidFill>
             <a:prstDash val="solid"/>
           </a:ln>
@@ -4938,7 +4938,7 @@
             <a:r>
               <a:rPr lang="en-US" sz="1600" b="1" dirty="0">
                 <a:solidFill>
-                  <a:srgbClr val="0A1628"/>
+                  <a:srgbClr val="F8FAFC"/>
                 </a:solidFill>
                 <a:latin typeface="Calibri" pitchFamily="34" charset="0"/>
                 <a:ea typeface="Calibri" pitchFamily="34" charset="-122"/>
@@ -4977,7 +4977,7 @@
             <a:r>
               <a:rPr lang="en-US" sz="1400" dirty="0">
                 <a:solidFill>
-                  <a:srgbClr val="475569"/>
+                  <a:srgbClr val="CBD5E1"/>
                 </a:solidFill>
                 <a:latin typeface="Calibri" pitchFamily="34" charset="0"/>
                 <a:ea typeface="Calibri" pitchFamily="34" charset="-122"/>
@@ -5004,7 +5004,7 @@
             <a:avLst/>
           </a:prstGeom>
           <a:solidFill>
-            <a:srgbClr val="0A1628"/>
+            <a:srgbClr val="101827"/>
           </a:solidFill>
           <a:ln/>
         </p:spPr>
@@ -5036,7 +5036,7 @@
             <a:r>
               <a:rPr lang="en-US" sz="1800" b="1" dirty="0">
                 <a:solidFill>
-                  <a:srgbClr val="FFFFFF"/>
+                  <a:srgbClr val="F8FAFC"/>
                 </a:solidFill>
                 <a:latin typeface="Calibri" pitchFamily="34" charset="0"/>
                 <a:ea typeface="Calibri" pitchFamily="34" charset="-122"/>
@@ -5063,11 +5063,11 @@
             <a:avLst/>
           </a:prstGeom>
           <a:solidFill>
-            <a:srgbClr val="FFFFFF"/>
+            <a:srgbClr val="152033"/>
           </a:solidFill>
           <a:ln w="12700">
             <a:solidFill>
-              <a:srgbClr val="E2E8F0"/>
+              <a:srgbClr val="2A4060"/>
             </a:solidFill>
             <a:prstDash val="solid"/>
           </a:ln>
@@ -5100,7 +5100,7 @@
             <a:r>
               <a:rPr lang="en-US" sz="1600" b="1" dirty="0">
                 <a:solidFill>
-                  <a:srgbClr val="0A1628"/>
+                  <a:srgbClr val="F8FAFC"/>
                 </a:solidFill>
                 <a:latin typeface="Calibri" pitchFamily="34" charset="0"/>
                 <a:ea typeface="Calibri" pitchFamily="34" charset="-122"/>
@@ -5139,7 +5139,7 @@
             <a:r>
               <a:rPr lang="en-US" sz="1400" dirty="0">
                 <a:solidFill>
-                  <a:srgbClr val="475569"/>
+                  <a:srgbClr val="CBD5E1"/>
                 </a:solidFill>
                 <a:latin typeface="Calibri" pitchFamily="34" charset="0"/>
                 <a:ea typeface="Calibri" pitchFamily="34" charset="-122"/>
@@ -5166,7 +5166,7 @@
             <a:avLst/>
           </a:prstGeom>
           <a:solidFill>
-            <a:srgbClr val="0A1628"/>
+            <a:srgbClr val="101827"/>
           </a:solidFill>
           <a:ln/>
         </p:spPr>
@@ -5198,7 +5198,7 @@
             <a:r>
               <a:rPr lang="en-US" sz="1800" b="1" dirty="0">
                 <a:solidFill>
-                  <a:srgbClr val="FFFFFF"/>
+                  <a:srgbClr val="F8FAFC"/>
                 </a:solidFill>
                 <a:latin typeface="Calibri" pitchFamily="34" charset="0"/>
                 <a:ea typeface="Calibri" pitchFamily="34" charset="-122"/>
@@ -5225,11 +5225,11 @@
             <a:avLst/>
           </a:prstGeom>
           <a:solidFill>
-            <a:srgbClr val="FFFFFF"/>
+            <a:srgbClr val="152033"/>
           </a:solidFill>
           <a:ln w="12700">
             <a:solidFill>
-              <a:srgbClr val="E2E8F0"/>
+              <a:srgbClr val="2A4060"/>
             </a:solidFill>
             <a:prstDash val="solid"/>
           </a:ln>
@@ -5262,7 +5262,7 @@
             <a:r>
               <a:rPr lang="en-US" sz="1600" b="1" dirty="0">
                 <a:solidFill>
-                  <a:srgbClr val="0A1628"/>
+                  <a:srgbClr val="F8FAFC"/>
                 </a:solidFill>
                 <a:latin typeface="Calibri" pitchFamily="34" charset="0"/>
                 <a:ea typeface="Calibri" pitchFamily="34" charset="-122"/>
@@ -5301,7 +5301,7 @@
             <a:r>
               <a:rPr lang="en-US" sz="1400" dirty="0">
                 <a:solidFill>
-                  <a:srgbClr val="475569"/>
+                  <a:srgbClr val="CBD5E1"/>
                 </a:solidFill>
                 <a:latin typeface="Calibri" pitchFamily="34" charset="0"/>
                 <a:ea typeface="Calibri" pitchFamily="34" charset="-122"/>
@@ -5340,7 +5340,7 @@
             <a:r>
               <a:rPr lang="en-US" sz="1000" i="1" dirty="0">
                 <a:solidFill>
-                  <a:srgbClr val="64748B"/>
+                  <a:srgbClr val="94A3B8"/>
                 </a:solidFill>
                 <a:latin typeface="Calibri" pitchFamily="34" charset="0"/>
                 <a:ea typeface="Calibri" pitchFamily="34" charset="-122"/>
@@ -5379,7 +5379,7 @@
             <a:r>
               <a:rPr lang="en-US" sz="1100" b="1" dirty="0">
                 <a:solidFill>
-                  <a:srgbClr val="0D9488"/>
+                  <a:srgbClr val="2DD4BF"/>
                 </a:solidFill>
                 <a:latin typeface="Calibri" pitchFamily="34" charset="0"/>
                 <a:ea typeface="Calibri" pitchFamily="34" charset="-122"/>
@@ -5405,7 +5405,7 @@
     <p:bg>
       <p:bgPr>
         <a:solidFill>
-          <a:srgbClr val="0A1628"/>
+          <a:srgbClr val="070B14"/>
         </a:solidFill>
       </p:bgPr>
     </p:bg>
@@ -5438,7 +5438,7 @@
             <a:avLst/>
           </a:prstGeom>
           <a:solidFill>
-            <a:srgbClr val="0D9488"/>
+            <a:srgbClr val="2DD4BF"/>
           </a:solidFill>
           <a:ln/>
         </p:spPr>
@@ -5509,7 +5509,7 @@
             <a:r>
               <a:rPr lang="en-US" sz="2800" b="1" dirty="0">
                 <a:solidFill>
-                  <a:srgbClr val="FFFFFF"/>
+                  <a:srgbClr val="F8FAFC"/>
                 </a:solidFill>
                 <a:latin typeface="Calibri" pitchFamily="34" charset="0"/>
                 <a:ea typeface="Calibri" pitchFamily="34" charset="-122"/>
@@ -5526,7 +5526,7 @@
             <a:r>
               <a:rPr lang="en-US" sz="2800" b="1" dirty="0">
                 <a:solidFill>
-                  <a:srgbClr val="FFFFFF"/>
+                  <a:srgbClr val="F8FAFC"/>
                 </a:solidFill>
                 <a:latin typeface="Calibri" pitchFamily="34" charset="0"/>
                 <a:ea typeface="Calibri" pitchFamily="34" charset="-122"/>
@@ -5553,7 +5553,7 @@
             <a:avLst/>
           </a:prstGeom>
           <a:solidFill>
-            <a:srgbClr val="0D9488"/>
+            <a:srgbClr val="2DD4BF"/>
           </a:solidFill>
           <a:ln/>
         </p:spPr>
@@ -5585,7 +5585,7 @@
             <a:r>
               <a:rPr lang="en-US" sz="1400" b="1" dirty="0">
                 <a:solidFill>
-                  <a:srgbClr val="FFFFFF"/>
+                  <a:srgbClr val="F8FAFC"/>
                 </a:solidFill>
                 <a:latin typeface="Calibri" pitchFamily="34" charset="0"/>
                 <a:ea typeface="Calibri" pitchFamily="34" charset="-122"/>
@@ -5651,7 +5651,7 @@
             <a:avLst/>
           </a:prstGeom>
           <a:solidFill>
-            <a:srgbClr val="0D9488"/>
+            <a:srgbClr val="2DD4BF"/>
           </a:solidFill>
           <a:ln/>
         </p:spPr>
@@ -5683,7 +5683,7 @@
             <a:r>
               <a:rPr lang="en-US" sz="1400" b="1" dirty="0">
                 <a:solidFill>
-                  <a:srgbClr val="FFFFFF"/>
+                  <a:srgbClr val="F8FAFC"/>
                 </a:solidFill>
                 <a:latin typeface="Calibri" pitchFamily="34" charset="0"/>
                 <a:ea typeface="Calibri" pitchFamily="34" charset="-122"/>
@@ -5749,7 +5749,7 @@
             <a:avLst/>
           </a:prstGeom>
           <a:solidFill>
-            <a:srgbClr val="0D9488"/>
+            <a:srgbClr val="2DD4BF"/>
           </a:solidFill>
           <a:ln/>
         </p:spPr>
@@ -5781,7 +5781,7 @@
             <a:r>
               <a:rPr lang="en-US" sz="1400" b="1" dirty="0">
                 <a:solidFill>
-                  <a:srgbClr val="FFFFFF"/>
+                  <a:srgbClr val="F8FAFC"/>
                 </a:solidFill>
                 <a:latin typeface="Calibri" pitchFamily="34" charset="0"/>
                 <a:ea typeface="Calibri" pitchFamily="34" charset="-122"/>
@@ -5847,7 +5847,7 @@
             <a:avLst/>
           </a:prstGeom>
           <a:solidFill>
-            <a:srgbClr val="0D9488"/>
+            <a:srgbClr val="2DD4BF"/>
           </a:solidFill>
           <a:ln/>
         </p:spPr>
@@ -5879,7 +5879,7 @@
             <a:r>
               <a:rPr lang="en-US" sz="1400" b="1" dirty="0">
                 <a:solidFill>
-                  <a:srgbClr val="FFFFFF"/>
+                  <a:srgbClr val="F8FAFC"/>
                 </a:solidFill>
                 <a:latin typeface="Calibri" pitchFamily="34" charset="0"/>
                 <a:ea typeface="Calibri" pitchFamily="34" charset="-122"/>
@@ -5945,7 +5945,7 @@
             <a:avLst/>
           </a:prstGeom>
           <a:solidFill>
-            <a:srgbClr val="122A45"/>
+            <a:srgbClr val="101827"/>
           </a:solidFill>
           <a:ln/>
         </p:spPr>
@@ -5965,7 +5965,7 @@
             <a:avLst/>
           </a:prstGeom>
           <a:solidFill>
-            <a:srgbClr val="0D9488"/>
+            <a:srgbClr val="2DD4BF"/>
           </a:solidFill>
           <a:ln/>
         </p:spPr>
@@ -6080,7 +6080,7 @@
             <a:avLst/>
           </a:prstGeom>
           <a:solidFill>
-            <a:srgbClr val="122A45"/>
+            <a:srgbClr val="101827"/>
           </a:solidFill>
           <a:ln/>
         </p:spPr>
@@ -6100,7 +6100,7 @@
             <a:avLst/>
           </a:prstGeom>
           <a:solidFill>
-            <a:srgbClr val="0D9488"/>
+            <a:srgbClr val="2DD4BF"/>
           </a:solidFill>
           <a:ln/>
         </p:spPr>
@@ -6215,7 +6215,7 @@
             <a:avLst/>
           </a:prstGeom>
           <a:solidFill>
-            <a:srgbClr val="122A45"/>
+            <a:srgbClr val="101827"/>
           </a:solidFill>
           <a:ln/>
         </p:spPr>
@@ -6235,7 +6235,7 @@
             <a:avLst/>
           </a:prstGeom>
           <a:solidFill>
-            <a:srgbClr val="0D9488"/>
+            <a:srgbClr val="2DD4BF"/>
           </a:solidFill>
           <a:ln/>
         </p:spPr>
@@ -6362,7 +6362,7 @@
             <a:r>
               <a:rPr lang="en-US" sz="1100" i="1" dirty="0">
                 <a:solidFill>
-                  <a:srgbClr val="64748B"/>
+                  <a:srgbClr val="94A3B8"/>
                 </a:solidFill>
                 <a:latin typeface="Calibri" pitchFamily="34" charset="0"/>
                 <a:ea typeface="Calibri" pitchFamily="34" charset="-122"/>
@@ -6401,7 +6401,7 @@
             <a:r>
               <a:rPr lang="en-US" sz="1200" b="1" dirty="0">
                 <a:solidFill>
-                  <a:srgbClr val="0D9488"/>
+                  <a:srgbClr val="2DD4BF"/>
                 </a:solidFill>
                 <a:latin typeface="Calibri" pitchFamily="34" charset="0"/>
                 <a:ea typeface="Calibri" pitchFamily="34" charset="-122"/>
@@ -6427,7 +6427,7 @@
     <p:bg>
       <p:bgPr>
         <a:solidFill>
-          <a:srgbClr val="F4F7FB"/>
+          <a:srgbClr val="070B14"/>
         </a:solidFill>
       </p:bgPr>
     </p:bg>
@@ -6460,7 +6460,7 @@
             <a:avLst/>
           </a:prstGeom>
           <a:solidFill>
-            <a:srgbClr val="0D9488"/>
+            <a:srgbClr val="2DD4BF"/>
           </a:solidFill>
           <a:ln/>
         </p:spPr>
@@ -6492,7 +6492,7 @@
             <a:r>
               <a:rPr lang="en-US" sz="1100" b="1" spc="220" kern="0" dirty="0">
                 <a:solidFill>
-                  <a:srgbClr val="0D9488"/>
+                  <a:srgbClr val="2DD4BF"/>
                 </a:solidFill>
                 <a:latin typeface="Calibri" pitchFamily="34" charset="0"/>
                 <a:ea typeface="Calibri" pitchFamily="34" charset="-122"/>
@@ -6531,7 +6531,7 @@
             <a:r>
               <a:rPr lang="en-US" sz="2600" b="1" dirty="0">
                 <a:solidFill>
-                  <a:srgbClr val="0A1628"/>
+                  <a:srgbClr val="F8FAFC"/>
                 </a:solidFill>
                 <a:latin typeface="Calibri" pitchFamily="34" charset="0"/>
                 <a:ea typeface="Calibri" pitchFamily="34" charset="-122"/>
@@ -6570,7 +6570,7 @@
             <a:r>
               <a:rPr lang="en-US" sz="1400" dirty="0">
                 <a:solidFill>
-                  <a:srgbClr val="475569"/>
+                  <a:srgbClr val="CBD5E1"/>
                 </a:solidFill>
                 <a:latin typeface="Calibri" pitchFamily="34" charset="0"/>
                 <a:ea typeface="Calibri" pitchFamily="34" charset="-122"/>
@@ -6597,18 +6597,18 @@
             <a:avLst/>
           </a:prstGeom>
           <a:solidFill>
-            <a:srgbClr val="FFFFFF"/>
+            <a:srgbClr val="152033"/>
           </a:solidFill>
           <a:ln w="12700">
             <a:solidFill>
-              <a:srgbClr val="E2E8F0"/>
+              <a:srgbClr val="2A4060"/>
             </a:solidFill>
             <a:prstDash val="solid"/>
           </a:ln>
           <a:effectLst>
-            <a:outerShdw sx="100000" sy="100000" kx="0" ky="0" algn="bl" rotWithShape="0" blurRad="127000" dist="38100" dir="8100000">
-              <a:srgbClr val="0A1628">
-                <a:alpha val="8000"/>
+            <a:outerShdw sx="100000" sy="100000" kx="0" ky="0" algn="bl" rotWithShape="0" blurRad="152400" dist="25400" dir="8100000">
+              <a:srgbClr val="000000">
+                <a:alpha val="35000"/>
               </a:srgbClr>
             </a:outerShdw>
           </a:effectLst>
@@ -6665,7 +6665,7 @@
             <a:r>
               <a:rPr lang="en-US" sz="1600" b="1" dirty="0">
                 <a:solidFill>
-                  <a:srgbClr val="0A1628"/>
+                  <a:srgbClr val="F8FAFC"/>
                 </a:solidFill>
                 <a:latin typeface="Calibri" pitchFamily="34" charset="0"/>
                 <a:ea typeface="Calibri" pitchFamily="34" charset="-122"/>
@@ -6704,7 +6704,7 @@
             <a:r>
               <a:rPr lang="en-US" sz="1300" dirty="0">
                 <a:solidFill>
-                  <a:srgbClr val="475569"/>
+                  <a:srgbClr val="CBD5E1"/>
                 </a:solidFill>
                 <a:latin typeface="Calibri" pitchFamily="34" charset="0"/>
                 <a:ea typeface="Calibri" pitchFamily="34" charset="-122"/>
@@ -6731,18 +6731,18 @@
             <a:avLst/>
           </a:prstGeom>
           <a:solidFill>
-            <a:srgbClr val="FFFFFF"/>
+            <a:srgbClr val="152033"/>
           </a:solidFill>
           <a:ln w="12700">
             <a:solidFill>
-              <a:srgbClr val="E2E8F0"/>
+              <a:srgbClr val="2A4060"/>
             </a:solidFill>
             <a:prstDash val="solid"/>
           </a:ln>
           <a:effectLst>
-            <a:outerShdw sx="100000" sy="100000" kx="0" ky="0" algn="bl" rotWithShape="0" blurRad="127000" dist="38100" dir="8100000">
-              <a:srgbClr val="0A1628">
-                <a:alpha val="8000"/>
+            <a:outerShdw sx="100000" sy="100000" kx="0" ky="0" algn="bl" rotWithShape="0" blurRad="152400" dist="25400" dir="8100000">
+              <a:srgbClr val="000000">
+                <a:alpha val="35000"/>
               </a:srgbClr>
             </a:outerShdw>
           </a:effectLst>
@@ -6799,7 +6799,7 @@
             <a:r>
               <a:rPr lang="en-US" sz="1600" b="1" dirty="0">
                 <a:solidFill>
-                  <a:srgbClr val="0A1628"/>
+                  <a:srgbClr val="F8FAFC"/>
                 </a:solidFill>
                 <a:latin typeface="Calibri" pitchFamily="34" charset="0"/>
                 <a:ea typeface="Calibri" pitchFamily="34" charset="-122"/>
@@ -6838,7 +6838,7 @@
             <a:r>
               <a:rPr lang="en-US" sz="1300" dirty="0">
                 <a:solidFill>
-                  <a:srgbClr val="475569"/>
+                  <a:srgbClr val="CBD5E1"/>
                 </a:solidFill>
                 <a:latin typeface="Calibri" pitchFamily="34" charset="0"/>
                 <a:ea typeface="Calibri" pitchFamily="34" charset="-122"/>
@@ -6865,18 +6865,18 @@
             <a:avLst/>
           </a:prstGeom>
           <a:solidFill>
-            <a:srgbClr val="FFFFFF"/>
+            <a:srgbClr val="152033"/>
           </a:solidFill>
           <a:ln w="12700">
             <a:solidFill>
-              <a:srgbClr val="E2E8F0"/>
+              <a:srgbClr val="2A4060"/>
             </a:solidFill>
             <a:prstDash val="solid"/>
           </a:ln>
           <a:effectLst>
-            <a:outerShdw sx="100000" sy="100000" kx="0" ky="0" algn="bl" rotWithShape="0" blurRad="127000" dist="38100" dir="8100000">
-              <a:srgbClr val="0A1628">
-                <a:alpha val="8000"/>
+            <a:outerShdw sx="100000" sy="100000" kx="0" ky="0" algn="bl" rotWithShape="0" blurRad="152400" dist="25400" dir="8100000">
+              <a:srgbClr val="000000">
+                <a:alpha val="35000"/>
               </a:srgbClr>
             </a:outerShdw>
           </a:effectLst>
@@ -6933,7 +6933,7 @@
             <a:r>
               <a:rPr lang="en-US" sz="1600" b="1" dirty="0">
                 <a:solidFill>
-                  <a:srgbClr val="0A1628"/>
+                  <a:srgbClr val="F8FAFC"/>
                 </a:solidFill>
                 <a:latin typeface="Calibri" pitchFamily="34" charset="0"/>
                 <a:ea typeface="Calibri" pitchFamily="34" charset="-122"/>
@@ -6972,7 +6972,7 @@
             <a:r>
               <a:rPr lang="en-US" sz="1300" dirty="0">
                 <a:solidFill>
-                  <a:srgbClr val="475569"/>
+                  <a:srgbClr val="CBD5E1"/>
                 </a:solidFill>
                 <a:latin typeface="Calibri" pitchFamily="34" charset="0"/>
                 <a:ea typeface="Calibri" pitchFamily="34" charset="-122"/>
@@ -6999,18 +6999,18 @@
             <a:avLst/>
           </a:prstGeom>
           <a:solidFill>
-            <a:srgbClr val="FFFFFF"/>
+            <a:srgbClr val="152033"/>
           </a:solidFill>
           <a:ln w="12700">
             <a:solidFill>
-              <a:srgbClr val="E2E8F0"/>
+              <a:srgbClr val="2A4060"/>
             </a:solidFill>
             <a:prstDash val="solid"/>
           </a:ln>
           <a:effectLst>
-            <a:outerShdw sx="100000" sy="100000" kx="0" ky="0" algn="bl" rotWithShape="0" blurRad="127000" dist="38100" dir="8100000">
-              <a:srgbClr val="0A1628">
-                <a:alpha val="8000"/>
+            <a:outerShdw sx="100000" sy="100000" kx="0" ky="0" algn="bl" rotWithShape="0" blurRad="152400" dist="25400" dir="8100000">
+              <a:srgbClr val="000000">
+                <a:alpha val="35000"/>
               </a:srgbClr>
             </a:outerShdw>
           </a:effectLst>
@@ -7067,7 +7067,7 @@
             <a:r>
               <a:rPr lang="en-US" sz="1600" b="1" dirty="0">
                 <a:solidFill>
-                  <a:srgbClr val="0A1628"/>
+                  <a:srgbClr val="F8FAFC"/>
                 </a:solidFill>
                 <a:latin typeface="Calibri" pitchFamily="34" charset="0"/>
                 <a:ea typeface="Calibri" pitchFamily="34" charset="-122"/>
@@ -7106,7 +7106,7 @@
             <a:r>
               <a:rPr lang="en-US" sz="1300" dirty="0">
                 <a:solidFill>
-                  <a:srgbClr val="475569"/>
+                  <a:srgbClr val="CBD5E1"/>
                 </a:solidFill>
                 <a:latin typeface="Calibri" pitchFamily="34" charset="0"/>
                 <a:ea typeface="Calibri" pitchFamily="34" charset="-122"/>
@@ -7145,7 +7145,7 @@
             <a:r>
               <a:rPr lang="en-US" sz="1100" b="1" spc="120" kern="0" dirty="0">
                 <a:solidFill>
-                  <a:srgbClr val="0D9488"/>
+                  <a:srgbClr val="2DD4BF"/>
                 </a:solidFill>
                 <a:latin typeface="Calibri" pitchFamily="34" charset="0"/>
                 <a:ea typeface="Calibri" pitchFamily="34" charset="-122"/>
@@ -7200,7 +7200,7 @@
             <a:r>
               <a:rPr lang="en-US" sz="1000" i="1" dirty="0">
                 <a:solidFill>
-                  <a:srgbClr val="64748B"/>
+                  <a:srgbClr val="94A3B8"/>
                 </a:solidFill>
                 <a:latin typeface="Calibri" pitchFamily="34" charset="0"/>
                 <a:ea typeface="Calibri" pitchFamily="34" charset="-122"/>
@@ -7239,7 +7239,7 @@
             <a:r>
               <a:rPr lang="en-US" sz="1100" b="1" dirty="0">
                 <a:solidFill>
-                  <a:srgbClr val="0D9488"/>
+                  <a:srgbClr val="2DD4BF"/>
                 </a:solidFill>
                 <a:latin typeface="Calibri" pitchFamily="34" charset="0"/>
                 <a:ea typeface="Calibri" pitchFamily="34" charset="-122"/>
@@ -7265,7 +7265,7 @@
     <p:bg>
       <p:bgPr>
         <a:solidFill>
-          <a:srgbClr val="F4F7FB"/>
+          <a:srgbClr val="070B14"/>
         </a:solidFill>
       </p:bgPr>
     </p:bg>
@@ -7298,7 +7298,7 @@
             <a:avLst/>
           </a:prstGeom>
           <a:solidFill>
-            <a:srgbClr val="0D9488"/>
+            <a:srgbClr val="2DD4BF"/>
           </a:solidFill>
           <a:ln/>
         </p:spPr>
@@ -7330,7 +7330,7 @@
             <a:r>
               <a:rPr lang="en-US" sz="1100" b="1" spc="220" kern="0" dirty="0">
                 <a:solidFill>
-                  <a:srgbClr val="0D9488"/>
+                  <a:srgbClr val="2DD4BF"/>
                 </a:solidFill>
                 <a:latin typeface="Calibri" pitchFamily="34" charset="0"/>
                 <a:ea typeface="Calibri" pitchFamily="34" charset="-122"/>
@@ -7369,7 +7369,7 @@
             <a:r>
               <a:rPr lang="en-US" sz="2600" b="1" dirty="0">
                 <a:solidFill>
-                  <a:srgbClr val="0A1628"/>
+                  <a:srgbClr val="F8FAFC"/>
                 </a:solidFill>
                 <a:latin typeface="Calibri" pitchFamily="34" charset="0"/>
                 <a:ea typeface="Calibri" pitchFamily="34" charset="-122"/>
@@ -7396,18 +7396,18 @@
             <a:avLst/>
           </a:prstGeom>
           <a:solidFill>
-            <a:srgbClr val="FFFFFF"/>
+            <a:srgbClr val="152033"/>
           </a:solidFill>
           <a:ln w="12700">
             <a:solidFill>
-              <a:srgbClr val="E2E8F0"/>
+              <a:srgbClr val="2A4060"/>
             </a:solidFill>
             <a:prstDash val="solid"/>
           </a:ln>
           <a:effectLst>
-            <a:outerShdw sx="100000" sy="100000" kx="0" ky="0" algn="bl" rotWithShape="0" blurRad="127000" dist="38100" dir="8100000">
-              <a:srgbClr val="0A1628">
-                <a:alpha val="8000"/>
+            <a:outerShdw sx="100000" sy="100000" kx="0" ky="0" algn="bl" rotWithShape="0" blurRad="152400" dist="25400" dir="8100000">
+              <a:srgbClr val="000000">
+                <a:alpha val="35000"/>
               </a:srgbClr>
             </a:outerShdw>
           </a:effectLst>
@@ -7428,7 +7428,7 @@
             <a:avLst/>
           </a:prstGeom>
           <a:solidFill>
-            <a:srgbClr val="0D9488"/>
+            <a:srgbClr val="2DD4BF"/>
           </a:solidFill>
           <a:ln/>
         </p:spPr>
@@ -7460,7 +7460,7 @@
             <a:r>
               <a:rPr lang="en-US" sz="2000" b="1" dirty="0">
                 <a:solidFill>
-                  <a:srgbClr val="0D9488"/>
+                  <a:srgbClr val="2DD4BF"/>
                 </a:solidFill>
                 <a:latin typeface="Calibri" pitchFamily="34" charset="0"/>
                 <a:ea typeface="Calibri" pitchFamily="34" charset="-122"/>
@@ -7499,7 +7499,7 @@
             <a:r>
               <a:rPr lang="en-US" sz="2000" b="1" dirty="0">
                 <a:solidFill>
-                  <a:srgbClr val="0A1628"/>
+                  <a:srgbClr val="F8FAFC"/>
                 </a:solidFill>
                 <a:latin typeface="Calibri" pitchFamily="34" charset="0"/>
                 <a:ea typeface="Calibri" pitchFamily="34" charset="-122"/>
@@ -7538,7 +7538,7 @@
             <a:r>
               <a:rPr lang="en-US" sz="1500" dirty="0">
                 <a:solidFill>
-                  <a:srgbClr val="475569"/>
+                  <a:srgbClr val="CBD5E1"/>
                 </a:solidFill>
                 <a:latin typeface="Calibri" pitchFamily="34" charset="0"/>
                 <a:ea typeface="Calibri" pitchFamily="34" charset="-122"/>
@@ -7565,18 +7565,18 @@
             <a:avLst/>
           </a:prstGeom>
           <a:solidFill>
-            <a:srgbClr val="FFFFFF"/>
+            <a:srgbClr val="152033"/>
           </a:solidFill>
           <a:ln w="12700">
             <a:solidFill>
-              <a:srgbClr val="E2E8F0"/>
+              <a:srgbClr val="2A4060"/>
             </a:solidFill>
             <a:prstDash val="solid"/>
           </a:ln>
           <a:effectLst>
-            <a:outerShdw sx="100000" sy="100000" kx="0" ky="0" algn="bl" rotWithShape="0" blurRad="127000" dist="38100" dir="8100000">
-              <a:srgbClr val="0A1628">
-                <a:alpha val="8000"/>
+            <a:outerShdw sx="100000" sy="100000" kx="0" ky="0" algn="bl" rotWithShape="0" blurRad="152400" dist="25400" dir="8100000">
+              <a:srgbClr val="000000">
+                <a:alpha val="35000"/>
               </a:srgbClr>
             </a:outerShdw>
           </a:effectLst>
@@ -7597,7 +7597,7 @@
             <a:avLst/>
           </a:prstGeom>
           <a:solidFill>
-            <a:srgbClr val="0D9488"/>
+            <a:srgbClr val="2DD4BF"/>
           </a:solidFill>
           <a:ln/>
         </p:spPr>
@@ -7629,7 +7629,7 @@
             <a:r>
               <a:rPr lang="en-US" sz="2000" b="1" dirty="0">
                 <a:solidFill>
-                  <a:srgbClr val="0D9488"/>
+                  <a:srgbClr val="2DD4BF"/>
                 </a:solidFill>
                 <a:latin typeface="Calibri" pitchFamily="34" charset="0"/>
                 <a:ea typeface="Calibri" pitchFamily="34" charset="-122"/>
@@ -7668,7 +7668,7 @@
             <a:r>
               <a:rPr lang="en-US" sz="2000" b="1" dirty="0">
                 <a:solidFill>
-                  <a:srgbClr val="0A1628"/>
+                  <a:srgbClr val="F8FAFC"/>
                 </a:solidFill>
                 <a:latin typeface="Calibri" pitchFamily="34" charset="0"/>
                 <a:ea typeface="Calibri" pitchFamily="34" charset="-122"/>
@@ -7707,7 +7707,7 @@
             <a:r>
               <a:rPr lang="en-US" sz="1500" dirty="0">
                 <a:solidFill>
-                  <a:srgbClr val="475569"/>
+                  <a:srgbClr val="CBD5E1"/>
                 </a:solidFill>
                 <a:latin typeface="Calibri" pitchFamily="34" charset="0"/>
                 <a:ea typeface="Calibri" pitchFamily="34" charset="-122"/>
@@ -7734,18 +7734,18 @@
             <a:avLst/>
           </a:prstGeom>
           <a:solidFill>
-            <a:srgbClr val="FFFFFF"/>
+            <a:srgbClr val="152033"/>
           </a:solidFill>
           <a:ln w="12700">
             <a:solidFill>
-              <a:srgbClr val="E2E8F0"/>
+              <a:srgbClr val="2A4060"/>
             </a:solidFill>
             <a:prstDash val="solid"/>
           </a:ln>
           <a:effectLst>
-            <a:outerShdw sx="100000" sy="100000" kx="0" ky="0" algn="bl" rotWithShape="0" blurRad="127000" dist="38100" dir="8100000">
-              <a:srgbClr val="0A1628">
-                <a:alpha val="8000"/>
+            <a:outerShdw sx="100000" sy="100000" kx="0" ky="0" algn="bl" rotWithShape="0" blurRad="152400" dist="25400" dir="8100000">
+              <a:srgbClr val="000000">
+                <a:alpha val="35000"/>
               </a:srgbClr>
             </a:outerShdw>
           </a:effectLst>
@@ -7766,7 +7766,7 @@
             <a:avLst/>
           </a:prstGeom>
           <a:solidFill>
-            <a:srgbClr val="0D9488"/>
+            <a:srgbClr val="2DD4BF"/>
           </a:solidFill>
           <a:ln/>
         </p:spPr>
@@ -7798,7 +7798,7 @@
             <a:r>
               <a:rPr lang="en-US" sz="2000" b="1" dirty="0">
                 <a:solidFill>
-                  <a:srgbClr val="0D9488"/>
+                  <a:srgbClr val="2DD4BF"/>
                 </a:solidFill>
                 <a:latin typeface="Calibri" pitchFamily="34" charset="0"/>
                 <a:ea typeface="Calibri" pitchFamily="34" charset="-122"/>
@@ -7837,7 +7837,7 @@
             <a:r>
               <a:rPr lang="en-US" sz="2000" b="1" dirty="0">
                 <a:solidFill>
-                  <a:srgbClr val="0A1628"/>
+                  <a:srgbClr val="F8FAFC"/>
                 </a:solidFill>
                 <a:latin typeface="Calibri" pitchFamily="34" charset="0"/>
                 <a:ea typeface="Calibri" pitchFamily="34" charset="-122"/>
@@ -7876,7 +7876,7 @@
             <a:r>
               <a:rPr lang="en-US" sz="1500" dirty="0">
                 <a:solidFill>
-                  <a:srgbClr val="475569"/>
+                  <a:srgbClr val="CBD5E1"/>
                 </a:solidFill>
                 <a:latin typeface="Calibri" pitchFamily="34" charset="0"/>
                 <a:ea typeface="Calibri" pitchFamily="34" charset="-122"/>
@@ -7903,18 +7903,18 @@
             <a:avLst/>
           </a:prstGeom>
           <a:solidFill>
-            <a:srgbClr val="FFFFFF"/>
+            <a:srgbClr val="152033"/>
           </a:solidFill>
           <a:ln w="12700">
             <a:solidFill>
-              <a:srgbClr val="E2E8F0"/>
+              <a:srgbClr val="2A4060"/>
             </a:solidFill>
             <a:prstDash val="solid"/>
           </a:ln>
           <a:effectLst>
-            <a:outerShdw sx="100000" sy="100000" kx="0" ky="0" algn="bl" rotWithShape="0" blurRad="127000" dist="38100" dir="8100000">
-              <a:srgbClr val="0A1628">
-                <a:alpha val="8000"/>
+            <a:outerShdw sx="100000" sy="100000" kx="0" ky="0" algn="bl" rotWithShape="0" blurRad="152400" dist="25400" dir="8100000">
+              <a:srgbClr val="000000">
+                <a:alpha val="35000"/>
               </a:srgbClr>
             </a:outerShdw>
           </a:effectLst>
@@ -7935,7 +7935,7 @@
             <a:avLst/>
           </a:prstGeom>
           <a:solidFill>
-            <a:srgbClr val="0D9488"/>
+            <a:srgbClr val="2DD4BF"/>
           </a:solidFill>
           <a:ln/>
         </p:spPr>
@@ -7967,7 +7967,7 @@
             <a:r>
               <a:rPr lang="en-US" sz="2000" b="1" dirty="0">
                 <a:solidFill>
-                  <a:srgbClr val="0D9488"/>
+                  <a:srgbClr val="2DD4BF"/>
                 </a:solidFill>
                 <a:latin typeface="Calibri" pitchFamily="34" charset="0"/>
                 <a:ea typeface="Calibri" pitchFamily="34" charset="-122"/>
@@ -8006,7 +8006,7 @@
             <a:r>
               <a:rPr lang="en-US" sz="2000" b="1" dirty="0">
                 <a:solidFill>
-                  <a:srgbClr val="0A1628"/>
+                  <a:srgbClr val="F8FAFC"/>
                 </a:solidFill>
                 <a:latin typeface="Calibri" pitchFamily="34" charset="0"/>
                 <a:ea typeface="Calibri" pitchFamily="34" charset="-122"/>
@@ -8045,7 +8045,7 @@
             <a:r>
               <a:rPr lang="en-US" sz="1500" dirty="0">
                 <a:solidFill>
-                  <a:srgbClr val="475569"/>
+                  <a:srgbClr val="CBD5E1"/>
                 </a:solidFill>
                 <a:latin typeface="Calibri" pitchFamily="34" charset="0"/>
                 <a:ea typeface="Calibri" pitchFamily="34" charset="-122"/>
@@ -8084,7 +8084,7 @@
             <a:r>
               <a:rPr lang="en-US" sz="1000" i="1" dirty="0">
                 <a:solidFill>
-                  <a:srgbClr val="64748B"/>
+                  <a:srgbClr val="94A3B8"/>
                 </a:solidFill>
                 <a:latin typeface="Calibri" pitchFamily="34" charset="0"/>
                 <a:ea typeface="Calibri" pitchFamily="34" charset="-122"/>
@@ -8123,7 +8123,7 @@
             <a:r>
               <a:rPr lang="en-US" sz="1100" b="1" dirty="0">
                 <a:solidFill>
-                  <a:srgbClr val="0D9488"/>
+                  <a:srgbClr val="2DD4BF"/>
                 </a:solidFill>
                 <a:latin typeface="Calibri" pitchFamily="34" charset="0"/>
                 <a:ea typeface="Calibri" pitchFamily="34" charset="-122"/>
@@ -8149,7 +8149,7 @@
     <p:bg>
       <p:bgPr>
         <a:solidFill>
-          <a:srgbClr val="F4F7FB"/>
+          <a:srgbClr val="070B14"/>
         </a:solidFill>
       </p:bgPr>
     </p:bg>
@@ -8182,7 +8182,7 @@
             <a:avLst/>
           </a:prstGeom>
           <a:solidFill>
-            <a:srgbClr val="0D9488"/>
+            <a:srgbClr val="2DD4BF"/>
           </a:solidFill>
           <a:ln/>
         </p:spPr>
@@ -8214,7 +8214,7 @@
             <a:r>
               <a:rPr lang="en-US" sz="1100" b="1" spc="220" kern="0" dirty="0">
                 <a:solidFill>
-                  <a:srgbClr val="0D9488"/>
+                  <a:srgbClr val="2DD4BF"/>
                 </a:solidFill>
                 <a:latin typeface="Calibri" pitchFamily="34" charset="0"/>
                 <a:ea typeface="Calibri" pitchFamily="34" charset="-122"/>
@@ -8253,7 +8253,7 @@
             <a:r>
               <a:rPr lang="en-US" sz="2600" b="1" dirty="0">
                 <a:solidFill>
-                  <a:srgbClr val="0A1628"/>
+                  <a:srgbClr val="F8FAFC"/>
                 </a:solidFill>
                 <a:latin typeface="Calibri" pitchFamily="34" charset="0"/>
                 <a:ea typeface="Calibri" pitchFamily="34" charset="-122"/>
@@ -8280,7 +8280,7 @@
             <a:avLst/>
           </a:prstGeom>
           <a:solidFill>
-            <a:srgbClr val="0D9488"/>
+            <a:srgbClr val="2DD4BF"/>
           </a:solidFill>
           <a:ln/>
         </p:spPr>
@@ -8312,7 +8312,7 @@
             <a:r>
               <a:rPr lang="en-US" sz="1600" b="1" dirty="0">
                 <a:solidFill>
-                  <a:srgbClr val="FFFFFF"/>
+                  <a:srgbClr val="F8FAFC"/>
                 </a:solidFill>
                 <a:latin typeface="Calibri" pitchFamily="34" charset="0"/>
                 <a:ea typeface="Calibri" pitchFamily="34" charset="-122"/>
@@ -8339,7 +8339,7 @@
             <a:avLst/>
           </a:prstGeom>
           <a:solidFill>
-            <a:srgbClr val="E2E8F0"/>
+            <a:srgbClr val="2A4060"/>
           </a:solidFill>
           <a:ln/>
         </p:spPr>
@@ -8359,18 +8359,18 @@
             <a:avLst/>
           </a:prstGeom>
           <a:solidFill>
-            <a:srgbClr val="FFFFFF"/>
+            <a:srgbClr val="152033"/>
           </a:solidFill>
           <a:ln w="12700">
             <a:solidFill>
-              <a:srgbClr val="E2E8F0"/>
+              <a:srgbClr val="2A4060"/>
             </a:solidFill>
             <a:prstDash val="solid"/>
           </a:ln>
           <a:effectLst>
-            <a:outerShdw sx="100000" sy="100000" kx="0" ky="0" algn="bl" rotWithShape="0" blurRad="127000" dist="38100" dir="8100000">
-              <a:srgbClr val="0A1628">
-                <a:alpha val="8000"/>
+            <a:outerShdw sx="100000" sy="100000" kx="0" ky="0" algn="bl" rotWithShape="0" blurRad="152400" dist="25400" dir="8100000">
+              <a:srgbClr val="000000">
+                <a:alpha val="35000"/>
               </a:srgbClr>
             </a:outerShdw>
           </a:effectLst>
@@ -8403,7 +8403,7 @@
             <a:r>
               <a:rPr lang="en-US" sz="1800" b="1" dirty="0">
                 <a:solidFill>
-                  <a:srgbClr val="0A1628"/>
+                  <a:srgbClr val="F8FAFC"/>
                 </a:solidFill>
                 <a:latin typeface="Calibri" pitchFamily="34" charset="0"/>
                 <a:ea typeface="Calibri" pitchFamily="34" charset="-122"/>
@@ -8442,7 +8442,7 @@
             <a:r>
               <a:rPr lang="en-US" sz="1400" dirty="0">
                 <a:solidFill>
-                  <a:srgbClr val="475569"/>
+                  <a:srgbClr val="CBD5E1"/>
                 </a:solidFill>
                 <a:latin typeface="Calibri" pitchFamily="34" charset="0"/>
                 <a:ea typeface="Calibri" pitchFamily="34" charset="-122"/>
@@ -8469,7 +8469,7 @@
             <a:avLst/>
           </a:prstGeom>
           <a:solidFill>
-            <a:srgbClr val="0D9488"/>
+            <a:srgbClr val="2DD4BF"/>
           </a:solidFill>
           <a:ln/>
         </p:spPr>
@@ -8501,7 +8501,7 @@
             <a:r>
               <a:rPr lang="en-US" sz="1600" b="1" dirty="0">
                 <a:solidFill>
-                  <a:srgbClr val="FFFFFF"/>
+                  <a:srgbClr val="F8FAFC"/>
                 </a:solidFill>
                 <a:latin typeface="Calibri" pitchFamily="34" charset="0"/>
                 <a:ea typeface="Calibri" pitchFamily="34" charset="-122"/>
@@ -8528,7 +8528,7 @@
             <a:avLst/>
           </a:prstGeom>
           <a:solidFill>
-            <a:srgbClr val="E2E8F0"/>
+            <a:srgbClr val="2A4060"/>
           </a:solidFill>
           <a:ln/>
         </p:spPr>
@@ -8548,18 +8548,18 @@
             <a:avLst/>
           </a:prstGeom>
           <a:solidFill>
-            <a:srgbClr val="FFFFFF"/>
+            <a:srgbClr val="152033"/>
           </a:solidFill>
           <a:ln w="12700">
             <a:solidFill>
-              <a:srgbClr val="E2E8F0"/>
+              <a:srgbClr val="2A4060"/>
             </a:solidFill>
             <a:prstDash val="solid"/>
           </a:ln>
           <a:effectLst>
-            <a:outerShdw sx="100000" sy="100000" kx="0" ky="0" algn="bl" rotWithShape="0" blurRad="127000" dist="38100" dir="8100000">
-              <a:srgbClr val="0A1628">
-                <a:alpha val="8000"/>
+            <a:outerShdw sx="100000" sy="100000" kx="0" ky="0" algn="bl" rotWithShape="0" blurRad="152400" dist="25400" dir="8100000">
+              <a:srgbClr val="000000">
+                <a:alpha val="35000"/>
               </a:srgbClr>
             </a:outerShdw>
           </a:effectLst>
@@ -8592,7 +8592,7 @@
             <a:r>
               <a:rPr lang="en-US" sz="1800" b="1" dirty="0">
                 <a:solidFill>
-                  <a:srgbClr val="0A1628"/>
+                  <a:srgbClr val="F8FAFC"/>
                 </a:solidFill>
                 <a:latin typeface="Calibri" pitchFamily="34" charset="0"/>
                 <a:ea typeface="Calibri" pitchFamily="34" charset="-122"/>
@@ -8631,7 +8631,7 @@
             <a:r>
               <a:rPr lang="en-US" sz="1400" dirty="0">
                 <a:solidFill>
-                  <a:srgbClr val="475569"/>
+                  <a:srgbClr val="CBD5E1"/>
                 </a:solidFill>
                 <a:latin typeface="Calibri" pitchFamily="34" charset="0"/>
                 <a:ea typeface="Calibri" pitchFamily="34" charset="-122"/>
@@ -8658,7 +8658,7 @@
             <a:avLst/>
           </a:prstGeom>
           <a:solidFill>
-            <a:srgbClr val="0D9488"/>
+            <a:srgbClr val="2DD4BF"/>
           </a:solidFill>
           <a:ln/>
         </p:spPr>
@@ -8690,7 +8690,7 @@
             <a:r>
               <a:rPr lang="en-US" sz="1600" b="1" dirty="0">
                 <a:solidFill>
-                  <a:srgbClr val="FFFFFF"/>
+                  <a:srgbClr val="F8FAFC"/>
                 </a:solidFill>
                 <a:latin typeface="Calibri" pitchFamily="34" charset="0"/>
                 <a:ea typeface="Calibri" pitchFamily="34" charset="-122"/>
@@ -8717,7 +8717,7 @@
             <a:avLst/>
           </a:prstGeom>
           <a:solidFill>
-            <a:srgbClr val="E2E8F0"/>
+            <a:srgbClr val="2A4060"/>
           </a:solidFill>
           <a:ln/>
         </p:spPr>
@@ -8737,18 +8737,18 @@
             <a:avLst/>
           </a:prstGeom>
           <a:solidFill>
-            <a:srgbClr val="FFFFFF"/>
+            <a:srgbClr val="152033"/>
           </a:solidFill>
           <a:ln w="12700">
             <a:solidFill>
-              <a:srgbClr val="E2E8F0"/>
+              <a:srgbClr val="2A4060"/>
             </a:solidFill>
             <a:prstDash val="solid"/>
           </a:ln>
           <a:effectLst>
-            <a:outerShdw sx="100000" sy="100000" kx="0" ky="0" algn="bl" rotWithShape="0" blurRad="127000" dist="38100" dir="8100000">
-              <a:srgbClr val="0A1628">
-                <a:alpha val="8000"/>
+            <a:outerShdw sx="100000" sy="100000" kx="0" ky="0" algn="bl" rotWithShape="0" blurRad="152400" dist="25400" dir="8100000">
+              <a:srgbClr val="000000">
+                <a:alpha val="35000"/>
               </a:srgbClr>
             </a:outerShdw>
           </a:effectLst>
@@ -8781,7 +8781,7 @@
             <a:r>
               <a:rPr lang="en-US" sz="1800" b="1" dirty="0">
                 <a:solidFill>
-                  <a:srgbClr val="0A1628"/>
+                  <a:srgbClr val="F8FAFC"/>
                 </a:solidFill>
                 <a:latin typeface="Calibri" pitchFamily="34" charset="0"/>
                 <a:ea typeface="Calibri" pitchFamily="34" charset="-122"/>
@@ -8820,7 +8820,7 @@
             <a:r>
               <a:rPr lang="en-US" sz="1400" dirty="0">
                 <a:solidFill>
-                  <a:srgbClr val="475569"/>
+                  <a:srgbClr val="CBD5E1"/>
                 </a:solidFill>
                 <a:latin typeface="Calibri" pitchFamily="34" charset="0"/>
                 <a:ea typeface="Calibri" pitchFamily="34" charset="-122"/>
@@ -8847,7 +8847,7 @@
             <a:avLst/>
           </a:prstGeom>
           <a:solidFill>
-            <a:srgbClr val="0D9488"/>
+            <a:srgbClr val="2DD4BF"/>
           </a:solidFill>
           <a:ln/>
         </p:spPr>
@@ -8879,7 +8879,7 @@
             <a:r>
               <a:rPr lang="en-US" sz="1600" b="1" dirty="0">
                 <a:solidFill>
-                  <a:srgbClr val="FFFFFF"/>
+                  <a:srgbClr val="F8FAFC"/>
                 </a:solidFill>
                 <a:latin typeface="Calibri" pitchFamily="34" charset="0"/>
                 <a:ea typeface="Calibri" pitchFamily="34" charset="-122"/>
@@ -8906,7 +8906,7 @@
             <a:avLst/>
           </a:prstGeom>
           <a:solidFill>
-            <a:srgbClr val="E2E8F0"/>
+            <a:srgbClr val="2A4060"/>
           </a:solidFill>
           <a:ln/>
         </p:spPr>
@@ -8926,18 +8926,18 @@
             <a:avLst/>
           </a:prstGeom>
           <a:solidFill>
-            <a:srgbClr val="FFFFFF"/>
+            <a:srgbClr val="152033"/>
           </a:solidFill>
           <a:ln w="12700">
             <a:solidFill>
-              <a:srgbClr val="E2E8F0"/>
+              <a:srgbClr val="2A4060"/>
             </a:solidFill>
             <a:prstDash val="solid"/>
           </a:ln>
           <a:effectLst>
-            <a:outerShdw sx="100000" sy="100000" kx="0" ky="0" algn="bl" rotWithShape="0" blurRad="127000" dist="38100" dir="8100000">
-              <a:srgbClr val="0A1628">
-                <a:alpha val="8000"/>
+            <a:outerShdw sx="100000" sy="100000" kx="0" ky="0" algn="bl" rotWithShape="0" blurRad="152400" dist="25400" dir="8100000">
+              <a:srgbClr val="000000">
+                <a:alpha val="35000"/>
               </a:srgbClr>
             </a:outerShdw>
           </a:effectLst>
@@ -8970,7 +8970,7 @@
             <a:r>
               <a:rPr lang="en-US" sz="1800" b="1" dirty="0">
                 <a:solidFill>
-                  <a:srgbClr val="0A1628"/>
+                  <a:srgbClr val="F8FAFC"/>
                 </a:solidFill>
                 <a:latin typeface="Calibri" pitchFamily="34" charset="0"/>
                 <a:ea typeface="Calibri" pitchFamily="34" charset="-122"/>
@@ -9009,7 +9009,7 @@
             <a:r>
               <a:rPr lang="en-US" sz="1400" dirty="0">
                 <a:solidFill>
-                  <a:srgbClr val="475569"/>
+                  <a:srgbClr val="CBD5E1"/>
                 </a:solidFill>
                 <a:latin typeface="Calibri" pitchFamily="34" charset="0"/>
                 <a:ea typeface="Calibri" pitchFamily="34" charset="-122"/>
@@ -9036,7 +9036,7 @@
             <a:avLst/>
           </a:prstGeom>
           <a:solidFill>
-            <a:srgbClr val="0D9488"/>
+            <a:srgbClr val="2DD4BF"/>
           </a:solidFill>
           <a:ln/>
         </p:spPr>
@@ -9068,7 +9068,7 @@
             <a:r>
               <a:rPr lang="en-US" sz="1600" b="1" dirty="0">
                 <a:solidFill>
-                  <a:srgbClr val="FFFFFF"/>
+                  <a:srgbClr val="F8FAFC"/>
                 </a:solidFill>
                 <a:latin typeface="Calibri" pitchFamily="34" charset="0"/>
                 <a:ea typeface="Calibri" pitchFamily="34" charset="-122"/>
@@ -9095,18 +9095,18 @@
             <a:avLst/>
           </a:prstGeom>
           <a:solidFill>
-            <a:srgbClr val="FFFFFF"/>
+            <a:srgbClr val="152033"/>
           </a:solidFill>
           <a:ln w="12700">
             <a:solidFill>
-              <a:srgbClr val="E2E8F0"/>
+              <a:srgbClr val="2A4060"/>
             </a:solidFill>
             <a:prstDash val="solid"/>
           </a:ln>
           <a:effectLst>
-            <a:outerShdw sx="100000" sy="100000" kx="0" ky="0" algn="bl" rotWithShape="0" blurRad="127000" dist="38100" dir="8100000">
-              <a:srgbClr val="0A1628">
-                <a:alpha val="8000"/>
+            <a:outerShdw sx="100000" sy="100000" kx="0" ky="0" algn="bl" rotWithShape="0" blurRad="152400" dist="25400" dir="8100000">
+              <a:srgbClr val="000000">
+                <a:alpha val="35000"/>
               </a:srgbClr>
             </a:outerShdw>
           </a:effectLst>
@@ -9139,7 +9139,7 @@
             <a:r>
               <a:rPr lang="en-US" sz="1800" b="1" dirty="0">
                 <a:solidFill>
-                  <a:srgbClr val="0A1628"/>
+                  <a:srgbClr val="F8FAFC"/>
                 </a:solidFill>
                 <a:latin typeface="Calibri" pitchFamily="34" charset="0"/>
                 <a:ea typeface="Calibri" pitchFamily="34" charset="-122"/>
@@ -9178,7 +9178,7 @@
             <a:r>
               <a:rPr lang="en-US" sz="1400" dirty="0">
                 <a:solidFill>
-                  <a:srgbClr val="475569"/>
+                  <a:srgbClr val="CBD5E1"/>
                 </a:solidFill>
                 <a:latin typeface="Calibri" pitchFamily="34" charset="0"/>
                 <a:ea typeface="Calibri" pitchFamily="34" charset="-122"/>
@@ -9217,7 +9217,7 @@
             <a:r>
               <a:rPr lang="en-US" sz="1000" i="1" dirty="0">
                 <a:solidFill>
-                  <a:srgbClr val="64748B"/>
+                  <a:srgbClr val="94A3B8"/>
                 </a:solidFill>
                 <a:latin typeface="Calibri" pitchFamily="34" charset="0"/>
                 <a:ea typeface="Calibri" pitchFamily="34" charset="-122"/>
@@ -9256,7 +9256,7 @@
             <a:r>
               <a:rPr lang="en-US" sz="1100" b="1" dirty="0">
                 <a:solidFill>
-                  <a:srgbClr val="0D9488"/>
+                  <a:srgbClr val="2DD4BF"/>
                 </a:solidFill>
                 <a:latin typeface="Calibri" pitchFamily="34" charset="0"/>
                 <a:ea typeface="Calibri" pitchFamily="34" charset="-122"/>
@@ -9282,7 +9282,7 @@
     <p:bg>
       <p:bgPr>
         <a:solidFill>
-          <a:srgbClr val="F4F7FB"/>
+          <a:srgbClr val="070B14"/>
         </a:solidFill>
       </p:bgPr>
     </p:bg>
@@ -9315,7 +9315,7 @@
             <a:avLst/>
           </a:prstGeom>
           <a:solidFill>
-            <a:srgbClr val="0D9488"/>
+            <a:srgbClr val="2DD4BF"/>
           </a:solidFill>
           <a:ln/>
         </p:spPr>
@@ -9347,7 +9347,7 @@
             <a:r>
               <a:rPr lang="en-US" sz="1100" b="1" spc="220" kern="0" dirty="0">
                 <a:solidFill>
-                  <a:srgbClr val="0D9488"/>
+                  <a:srgbClr val="2DD4BF"/>
                 </a:solidFill>
                 <a:latin typeface="Calibri" pitchFamily="34" charset="0"/>
                 <a:ea typeface="Calibri" pitchFamily="34" charset="-122"/>
@@ -9386,7 +9386,7 @@
             <a:r>
               <a:rPr lang="en-US" sz="2600" b="1" dirty="0">
                 <a:solidFill>
-                  <a:srgbClr val="0A1628"/>
+                  <a:srgbClr val="F8FAFC"/>
                 </a:solidFill>
                 <a:latin typeface="Calibri" pitchFamily="34" charset="0"/>
                 <a:ea typeface="Calibri" pitchFamily="34" charset="-122"/>
@@ -9425,7 +9425,7 @@
             <a:r>
               <a:rPr lang="en-US" sz="1400" dirty="0">
                 <a:solidFill>
-                  <a:srgbClr val="475569"/>
+                  <a:srgbClr val="CBD5E1"/>
                 </a:solidFill>
                 <a:latin typeface="Calibri" pitchFamily="34" charset="0"/>
                 <a:ea typeface="Calibri" pitchFamily="34" charset="-122"/>
@@ -9452,18 +9452,18 @@
             <a:avLst/>
           </a:prstGeom>
           <a:solidFill>
-            <a:srgbClr val="FFFFFF"/>
+            <a:srgbClr val="152033"/>
           </a:solidFill>
           <a:ln w="12700">
             <a:solidFill>
-              <a:srgbClr val="E2E8F0"/>
+              <a:srgbClr val="2A4060"/>
             </a:solidFill>
             <a:prstDash val="solid"/>
           </a:ln>
           <a:effectLst>
-            <a:outerShdw sx="100000" sy="100000" kx="0" ky="0" algn="bl" rotWithShape="0" blurRad="127000" dist="38100" dir="8100000">
-              <a:srgbClr val="0A1628">
-                <a:alpha val="8000"/>
+            <a:outerShdw sx="100000" sy="100000" kx="0" ky="0" algn="bl" rotWithShape="0" blurRad="152400" dist="25400" dir="8100000">
+              <a:srgbClr val="000000">
+                <a:alpha val="35000"/>
               </a:srgbClr>
             </a:outerShdw>
           </a:effectLst>
@@ -9520,7 +9520,7 @@
             <a:r>
               <a:rPr lang="en-US" sz="1400" b="1" dirty="0">
                 <a:solidFill>
-                  <a:srgbClr val="0A1628"/>
+                  <a:srgbClr val="F8FAFC"/>
                 </a:solidFill>
                 <a:latin typeface="Calibri" pitchFamily="34" charset="0"/>
                 <a:ea typeface="Calibri" pitchFamily="34" charset="-122"/>
@@ -9559,7 +9559,7 @@
             <a:r>
               <a:rPr lang="en-US" sz="1500" dirty="0">
                 <a:solidFill>
-                  <a:srgbClr val="475569"/>
+                  <a:srgbClr val="CBD5E1"/>
                 </a:solidFill>
                 <a:latin typeface="Calibri" pitchFamily="34" charset="0"/>
                 <a:ea typeface="Calibri" pitchFamily="34" charset="-122"/>
@@ -9586,18 +9586,18 @@
             <a:avLst/>
           </a:prstGeom>
           <a:solidFill>
-            <a:srgbClr val="FFFFFF"/>
+            <a:srgbClr val="152033"/>
           </a:solidFill>
           <a:ln w="12700">
             <a:solidFill>
-              <a:srgbClr val="E2E8F0"/>
+              <a:srgbClr val="2A4060"/>
             </a:solidFill>
             <a:prstDash val="solid"/>
           </a:ln>
           <a:effectLst>
-            <a:outerShdw sx="100000" sy="100000" kx="0" ky="0" algn="bl" rotWithShape="0" blurRad="127000" dist="38100" dir="8100000">
-              <a:srgbClr val="0A1628">
-                <a:alpha val="8000"/>
+            <a:outerShdw sx="100000" sy="100000" kx="0" ky="0" algn="bl" rotWithShape="0" blurRad="152400" dist="25400" dir="8100000">
+              <a:srgbClr val="000000">
+                <a:alpha val="35000"/>
               </a:srgbClr>
             </a:outerShdw>
           </a:effectLst>
@@ -9654,7 +9654,7 @@
             <a:r>
               <a:rPr lang="en-US" sz="1400" b="1" dirty="0">
                 <a:solidFill>
-                  <a:srgbClr val="0A1628"/>
+                  <a:srgbClr val="F8FAFC"/>
                 </a:solidFill>
                 <a:latin typeface="Calibri" pitchFamily="34" charset="0"/>
                 <a:ea typeface="Calibri" pitchFamily="34" charset="-122"/>
@@ -9693,7 +9693,7 @@
             <a:r>
               <a:rPr lang="en-US" sz="1500" dirty="0">
                 <a:solidFill>
-                  <a:srgbClr val="475569"/>
+                  <a:srgbClr val="CBD5E1"/>
                 </a:solidFill>
                 <a:latin typeface="Calibri" pitchFamily="34" charset="0"/>
                 <a:ea typeface="Calibri" pitchFamily="34" charset="-122"/>
@@ -9720,18 +9720,18 @@
             <a:avLst/>
           </a:prstGeom>
           <a:solidFill>
-            <a:srgbClr val="FFFFFF"/>
+            <a:srgbClr val="152033"/>
           </a:solidFill>
           <a:ln w="12700">
             <a:solidFill>
-              <a:srgbClr val="E2E8F0"/>
+              <a:srgbClr val="2A4060"/>
             </a:solidFill>
             <a:prstDash val="solid"/>
           </a:ln>
           <a:effectLst>
-            <a:outerShdw sx="100000" sy="100000" kx="0" ky="0" algn="bl" rotWithShape="0" blurRad="127000" dist="38100" dir="8100000">
-              <a:srgbClr val="0A1628">
-                <a:alpha val="8000"/>
+            <a:outerShdw sx="100000" sy="100000" kx="0" ky="0" algn="bl" rotWithShape="0" blurRad="152400" dist="25400" dir="8100000">
+              <a:srgbClr val="000000">
+                <a:alpha val="35000"/>
               </a:srgbClr>
             </a:outerShdw>
           </a:effectLst>
@@ -9788,7 +9788,7 @@
             <a:r>
               <a:rPr lang="en-US" sz="1400" b="1" dirty="0">
                 <a:solidFill>
-                  <a:srgbClr val="0A1628"/>
+                  <a:srgbClr val="F8FAFC"/>
                 </a:solidFill>
                 <a:latin typeface="Calibri" pitchFamily="34" charset="0"/>
                 <a:ea typeface="Calibri" pitchFamily="34" charset="-122"/>
@@ -9827,7 +9827,7 @@
             <a:r>
               <a:rPr lang="en-US" sz="1500" dirty="0">
                 <a:solidFill>
-                  <a:srgbClr val="475569"/>
+                  <a:srgbClr val="CBD5E1"/>
                 </a:solidFill>
                 <a:latin typeface="Calibri" pitchFamily="34" charset="0"/>
                 <a:ea typeface="Calibri" pitchFamily="34" charset="-122"/>
@@ -9854,18 +9854,18 @@
             <a:avLst/>
           </a:prstGeom>
           <a:solidFill>
-            <a:srgbClr val="FFFFFF"/>
+            <a:srgbClr val="152033"/>
           </a:solidFill>
           <a:ln w="12700">
             <a:solidFill>
-              <a:srgbClr val="E2E8F0"/>
+              <a:srgbClr val="2A4060"/>
             </a:solidFill>
             <a:prstDash val="solid"/>
           </a:ln>
           <a:effectLst>
-            <a:outerShdw sx="100000" sy="100000" kx="0" ky="0" algn="bl" rotWithShape="0" blurRad="127000" dist="38100" dir="8100000">
-              <a:srgbClr val="0A1628">
-                <a:alpha val="8000"/>
+            <a:outerShdw sx="100000" sy="100000" kx="0" ky="0" algn="bl" rotWithShape="0" blurRad="152400" dist="25400" dir="8100000">
+              <a:srgbClr val="000000">
+                <a:alpha val="35000"/>
               </a:srgbClr>
             </a:outerShdw>
           </a:effectLst>
@@ -9922,7 +9922,7 @@
             <a:r>
               <a:rPr lang="en-US" sz="1400" b="1" dirty="0">
                 <a:solidFill>
-                  <a:srgbClr val="0A1628"/>
+                  <a:srgbClr val="F8FAFC"/>
                 </a:solidFill>
                 <a:latin typeface="Calibri" pitchFamily="34" charset="0"/>
                 <a:ea typeface="Calibri" pitchFamily="34" charset="-122"/>
@@ -9961,7 +9961,7 @@
             <a:r>
               <a:rPr lang="en-US" sz="1500" dirty="0">
                 <a:solidFill>
-                  <a:srgbClr val="475569"/>
+                  <a:srgbClr val="CBD5E1"/>
                 </a:solidFill>
                 <a:latin typeface="Calibri" pitchFamily="34" charset="0"/>
                 <a:ea typeface="Calibri" pitchFamily="34" charset="-122"/>
@@ -9988,18 +9988,18 @@
             <a:avLst/>
           </a:prstGeom>
           <a:solidFill>
-            <a:srgbClr val="FFFFFF"/>
+            <a:srgbClr val="152033"/>
           </a:solidFill>
           <a:ln w="12700">
             <a:solidFill>
-              <a:srgbClr val="E2E8F0"/>
+              <a:srgbClr val="2A4060"/>
             </a:solidFill>
             <a:prstDash val="solid"/>
           </a:ln>
           <a:effectLst>
-            <a:outerShdw sx="100000" sy="100000" kx="0" ky="0" algn="bl" rotWithShape="0" blurRad="127000" dist="38100" dir="8100000">
-              <a:srgbClr val="0A1628">
-                <a:alpha val="8000"/>
+            <a:outerShdw sx="100000" sy="100000" kx="0" ky="0" algn="bl" rotWithShape="0" blurRad="152400" dist="25400" dir="8100000">
+              <a:srgbClr val="000000">
+                <a:alpha val="35000"/>
               </a:srgbClr>
             </a:outerShdw>
           </a:effectLst>
@@ -10056,7 +10056,7 @@
             <a:r>
               <a:rPr lang="en-US" sz="1400" b="1" dirty="0">
                 <a:solidFill>
-                  <a:srgbClr val="0A1628"/>
+                  <a:srgbClr val="F8FAFC"/>
                 </a:solidFill>
                 <a:latin typeface="Calibri" pitchFamily="34" charset="0"/>
                 <a:ea typeface="Calibri" pitchFamily="34" charset="-122"/>
@@ -10095,7 +10095,7 @@
             <a:r>
               <a:rPr lang="en-US" sz="1500" dirty="0">
                 <a:solidFill>
-                  <a:srgbClr val="475569"/>
+                  <a:srgbClr val="CBD5E1"/>
                 </a:solidFill>
                 <a:latin typeface="Calibri" pitchFamily="34" charset="0"/>
                 <a:ea typeface="Calibri" pitchFamily="34" charset="-122"/>
@@ -10122,18 +10122,18 @@
             <a:avLst/>
           </a:prstGeom>
           <a:solidFill>
-            <a:srgbClr val="FFFFFF"/>
+            <a:srgbClr val="152033"/>
           </a:solidFill>
           <a:ln w="12700">
             <a:solidFill>
-              <a:srgbClr val="E2E8F0"/>
+              <a:srgbClr val="2A4060"/>
             </a:solidFill>
             <a:prstDash val="solid"/>
           </a:ln>
           <a:effectLst>
-            <a:outerShdw sx="100000" sy="100000" kx="0" ky="0" algn="bl" rotWithShape="0" blurRad="127000" dist="38100" dir="8100000">
-              <a:srgbClr val="0A1628">
-                <a:alpha val="8000"/>
+            <a:outerShdw sx="100000" sy="100000" kx="0" ky="0" algn="bl" rotWithShape="0" blurRad="152400" dist="25400" dir="8100000">
+              <a:srgbClr val="000000">
+                <a:alpha val="35000"/>
               </a:srgbClr>
             </a:outerShdw>
           </a:effectLst>
@@ -10190,7 +10190,7 @@
             <a:r>
               <a:rPr lang="en-US" sz="1400" b="1" dirty="0">
                 <a:solidFill>
-                  <a:srgbClr val="0A1628"/>
+                  <a:srgbClr val="F8FAFC"/>
                 </a:solidFill>
                 <a:latin typeface="Calibri" pitchFamily="34" charset="0"/>
                 <a:ea typeface="Calibri" pitchFamily="34" charset="-122"/>
@@ -10229,7 +10229,7 @@
             <a:r>
               <a:rPr lang="en-US" sz="1500" dirty="0">
                 <a:solidFill>
-                  <a:srgbClr val="475569"/>
+                  <a:srgbClr val="CBD5E1"/>
                 </a:solidFill>
                 <a:latin typeface="Calibri" pitchFamily="34" charset="0"/>
                 <a:ea typeface="Calibri" pitchFamily="34" charset="-122"/>
@@ -10268,7 +10268,7 @@
             <a:r>
               <a:rPr lang="en-US" sz="1000" i="1" dirty="0">
                 <a:solidFill>
-                  <a:srgbClr val="64748B"/>
+                  <a:srgbClr val="94A3B8"/>
                 </a:solidFill>
                 <a:latin typeface="Calibri" pitchFamily="34" charset="0"/>
                 <a:ea typeface="Calibri" pitchFamily="34" charset="-122"/>
@@ -10307,7 +10307,7 @@
             <a:r>
               <a:rPr lang="en-US" sz="1100" b="1" dirty="0">
                 <a:solidFill>
-                  <a:srgbClr val="0D9488"/>
+                  <a:srgbClr val="2DD4BF"/>
                 </a:solidFill>
                 <a:latin typeface="Calibri" pitchFamily="34" charset="0"/>
                 <a:ea typeface="Calibri" pitchFamily="34" charset="-122"/>
@@ -10333,7 +10333,7 @@
     <p:bg>
       <p:bgPr>
         <a:solidFill>
-          <a:srgbClr val="F4F7FB"/>
+          <a:srgbClr val="070B14"/>
         </a:solidFill>
       </p:bgPr>
     </p:bg>
@@ -10366,7 +10366,7 @@
             <a:avLst/>
           </a:prstGeom>
           <a:solidFill>
-            <a:srgbClr val="0D9488"/>
+            <a:srgbClr val="2DD4BF"/>
           </a:solidFill>
           <a:ln/>
         </p:spPr>
@@ -10398,7 +10398,7 @@
             <a:r>
               <a:rPr lang="en-US" sz="1100" b="1" spc="220" kern="0" dirty="0">
                 <a:solidFill>
-                  <a:srgbClr val="0D9488"/>
+                  <a:srgbClr val="2DD4BF"/>
                 </a:solidFill>
                 <a:latin typeface="Calibri" pitchFamily="34" charset="0"/>
                 <a:ea typeface="Calibri" pitchFamily="34" charset="-122"/>
@@ -10437,7 +10437,7 @@
             <a:r>
               <a:rPr lang="en-US" sz="2600" b="1" dirty="0">
                 <a:solidFill>
-                  <a:srgbClr val="0A1628"/>
+                  <a:srgbClr val="F8FAFC"/>
                 </a:solidFill>
                 <a:latin typeface="Calibri" pitchFamily="34" charset="0"/>
                 <a:ea typeface="Calibri" pitchFamily="34" charset="-122"/>
@@ -10476,7 +10476,7 @@
             <a:r>
               <a:rPr lang="en-US" sz="1400" dirty="0">
                 <a:solidFill>
-                  <a:srgbClr val="475569"/>
+                  <a:srgbClr val="CBD5E1"/>
                 </a:solidFill>
                 <a:latin typeface="Calibri" pitchFamily="34" charset="0"/>
                 <a:ea typeface="Calibri" pitchFamily="34" charset="-122"/>
@@ -10519,18 +10519,18 @@
             <a:avLst/>
           </a:prstGeom>
           <a:solidFill>
-            <a:srgbClr val="FFFFFF"/>
+            <a:srgbClr val="152033"/>
           </a:solidFill>
           <a:ln w="12700">
             <a:solidFill>
-              <a:srgbClr val="E2E8F0"/>
+              <a:srgbClr val="2A4060"/>
             </a:solidFill>
             <a:prstDash val="solid"/>
           </a:ln>
           <a:effectLst>
-            <a:outerShdw sx="100000" sy="100000" kx="0" ky="0" algn="bl" rotWithShape="0" blurRad="127000" dist="38100" dir="8100000">
-              <a:srgbClr val="0A1628">
-                <a:alpha val="8000"/>
+            <a:outerShdw sx="100000" sy="100000" kx="0" ky="0" algn="bl" rotWithShape="0" blurRad="152400" dist="25400" dir="8100000">
+              <a:srgbClr val="000000">
+                <a:alpha val="35000"/>
               </a:srgbClr>
             </a:outerShdw>
           </a:effectLst>
@@ -10563,7 +10563,7 @@
             <a:r>
               <a:rPr lang="en-US" sz="1500" b="1" dirty="0">
                 <a:solidFill>
-                  <a:srgbClr val="0A1628"/>
+                  <a:srgbClr val="F8FAFC"/>
                 </a:solidFill>
                 <a:latin typeface="Calibri" pitchFamily="34" charset="0"/>
                 <a:ea typeface="Calibri" pitchFamily="34" charset="-122"/>
@@ -10602,7 +10602,7 @@
             <a:r>
               <a:rPr lang="en-US" sz="1300" dirty="0">
                 <a:solidFill>
-                  <a:srgbClr val="475569"/>
+                  <a:srgbClr val="CBD5E1"/>
                 </a:solidFill>
                 <a:latin typeface="Calibri" pitchFamily="34" charset="0"/>
                 <a:ea typeface="Calibri" pitchFamily="34" charset="-122"/>
@@ -10629,18 +10629,18 @@
             <a:avLst/>
           </a:prstGeom>
           <a:solidFill>
-            <a:srgbClr val="FFFFFF"/>
+            <a:srgbClr val="152033"/>
           </a:solidFill>
           <a:ln w="12700">
             <a:solidFill>
-              <a:srgbClr val="E2E8F0"/>
+              <a:srgbClr val="2A4060"/>
             </a:solidFill>
             <a:prstDash val="solid"/>
           </a:ln>
           <a:effectLst>
-            <a:outerShdw sx="100000" sy="100000" kx="0" ky="0" algn="bl" rotWithShape="0" blurRad="127000" dist="38100" dir="8100000">
-              <a:srgbClr val="0A1628">
-                <a:alpha val="8000"/>
+            <a:outerShdw sx="100000" sy="100000" kx="0" ky="0" algn="bl" rotWithShape="0" blurRad="152400" dist="25400" dir="8100000">
+              <a:srgbClr val="000000">
+                <a:alpha val="35000"/>
               </a:srgbClr>
             </a:outerShdw>
           </a:effectLst>
@@ -10673,7 +10673,7 @@
             <a:r>
               <a:rPr lang="en-US" sz="1500" b="1" dirty="0">
                 <a:solidFill>
-                  <a:srgbClr val="0A1628"/>
+                  <a:srgbClr val="F8FAFC"/>
                 </a:solidFill>
                 <a:latin typeface="Calibri" pitchFamily="34" charset="0"/>
                 <a:ea typeface="Calibri" pitchFamily="34" charset="-122"/>
@@ -10712,7 +10712,7 @@
             <a:r>
               <a:rPr lang="en-US" sz="1300" dirty="0">
                 <a:solidFill>
-                  <a:srgbClr val="475569"/>
+                  <a:srgbClr val="CBD5E1"/>
                 </a:solidFill>
                 <a:latin typeface="Calibri" pitchFamily="34" charset="0"/>
                 <a:ea typeface="Calibri" pitchFamily="34" charset="-122"/>
@@ -10739,18 +10739,18 @@
             <a:avLst/>
           </a:prstGeom>
           <a:solidFill>
-            <a:srgbClr val="FFFFFF"/>
+            <a:srgbClr val="152033"/>
           </a:solidFill>
           <a:ln w="12700">
             <a:solidFill>
-              <a:srgbClr val="E2E8F0"/>
+              <a:srgbClr val="2A4060"/>
             </a:solidFill>
             <a:prstDash val="solid"/>
           </a:ln>
           <a:effectLst>
-            <a:outerShdw sx="100000" sy="100000" kx="0" ky="0" algn="bl" rotWithShape="0" blurRad="127000" dist="38100" dir="8100000">
-              <a:srgbClr val="0A1628">
-                <a:alpha val="8000"/>
+            <a:outerShdw sx="100000" sy="100000" kx="0" ky="0" algn="bl" rotWithShape="0" blurRad="152400" dist="25400" dir="8100000">
+              <a:srgbClr val="000000">
+                <a:alpha val="35000"/>
               </a:srgbClr>
             </a:outerShdw>
           </a:effectLst>
@@ -10783,7 +10783,7 @@
             <a:r>
               <a:rPr lang="en-US" sz="1500" b="1" dirty="0">
                 <a:solidFill>
-                  <a:srgbClr val="0A1628"/>
+                  <a:srgbClr val="F8FAFC"/>
                 </a:solidFill>
                 <a:latin typeface="Calibri" pitchFamily="34" charset="0"/>
                 <a:ea typeface="Calibri" pitchFamily="34" charset="-122"/>
@@ -10822,7 +10822,7 @@
             <a:r>
               <a:rPr lang="en-US" sz="1300" dirty="0">
                 <a:solidFill>
-                  <a:srgbClr val="475569"/>
+                  <a:srgbClr val="CBD5E1"/>
                 </a:solidFill>
                 <a:latin typeface="Calibri" pitchFamily="34" charset="0"/>
                 <a:ea typeface="Calibri" pitchFamily="34" charset="-122"/>
@@ -10861,7 +10861,7 @@
             <a:r>
               <a:rPr lang="en-US" sz="1000" i="1" dirty="0">
                 <a:solidFill>
-                  <a:srgbClr val="64748B"/>
+                  <a:srgbClr val="94A3B8"/>
                 </a:solidFill>
                 <a:latin typeface="Calibri" pitchFamily="34" charset="0"/>
                 <a:ea typeface="Calibri" pitchFamily="34" charset="-122"/>
@@ -10900,7 +10900,7 @@
             <a:r>
               <a:rPr lang="en-US" sz="1100" b="1" dirty="0">
                 <a:solidFill>
-                  <a:srgbClr val="0D9488"/>
+                  <a:srgbClr val="2DD4BF"/>
                 </a:solidFill>
                 <a:latin typeface="Calibri" pitchFamily="34" charset="0"/>
                 <a:ea typeface="Calibri" pitchFamily="34" charset="-122"/>
@@ -10926,7 +10926,7 @@
     <p:bg>
       <p:bgPr>
         <a:solidFill>
-          <a:srgbClr val="F4F7FB"/>
+          <a:srgbClr val="070B14"/>
         </a:solidFill>
       </p:bgPr>
     </p:bg>
@@ -10959,7 +10959,7 @@
             <a:avLst/>
           </a:prstGeom>
           <a:solidFill>
-            <a:srgbClr val="0D9488"/>
+            <a:srgbClr val="2DD4BF"/>
           </a:solidFill>
           <a:ln/>
         </p:spPr>
@@ -10991,7 +10991,7 @@
             <a:r>
               <a:rPr lang="en-US" sz="1100" b="1" spc="220" kern="0" dirty="0">
                 <a:solidFill>
-                  <a:srgbClr val="0D9488"/>
+                  <a:srgbClr val="2DD4BF"/>
                 </a:solidFill>
                 <a:latin typeface="Calibri" pitchFamily="34" charset="0"/>
                 <a:ea typeface="Calibri" pitchFamily="34" charset="-122"/>
@@ -11030,7 +11030,7 @@
             <a:r>
               <a:rPr lang="en-US" sz="2600" b="1" dirty="0">
                 <a:solidFill>
-                  <a:srgbClr val="0A1628"/>
+                  <a:srgbClr val="F8FAFC"/>
                 </a:solidFill>
                 <a:latin typeface="Calibri" pitchFamily="34" charset="0"/>
                 <a:ea typeface="Calibri" pitchFamily="34" charset="-122"/>
@@ -11069,7 +11069,7 @@
             <a:r>
               <a:rPr lang="en-US" sz="1400" dirty="0">
                 <a:solidFill>
-                  <a:srgbClr val="475569"/>
+                  <a:srgbClr val="CBD5E1"/>
                 </a:solidFill>
                 <a:latin typeface="Calibri" pitchFamily="34" charset="0"/>
                 <a:ea typeface="Calibri" pitchFamily="34" charset="-122"/>
@@ -11112,18 +11112,18 @@
             <a:avLst/>
           </a:prstGeom>
           <a:solidFill>
-            <a:srgbClr val="FFFFFF"/>
+            <a:srgbClr val="152033"/>
           </a:solidFill>
           <a:ln w="12700">
             <a:solidFill>
-              <a:srgbClr val="E2E8F0"/>
+              <a:srgbClr val="2A4060"/>
             </a:solidFill>
             <a:prstDash val="solid"/>
           </a:ln>
           <a:effectLst>
-            <a:outerShdw sx="100000" sy="100000" kx="0" ky="0" algn="bl" rotWithShape="0" blurRad="127000" dist="38100" dir="8100000">
-              <a:srgbClr val="0A1628">
-                <a:alpha val="8000"/>
+            <a:outerShdw sx="100000" sy="100000" kx="0" ky="0" algn="bl" rotWithShape="0" blurRad="152400" dist="25400" dir="8100000">
+              <a:srgbClr val="000000">
+                <a:alpha val="35000"/>
               </a:srgbClr>
             </a:outerShdw>
           </a:effectLst>
@@ -11156,7 +11156,7 @@
             <a:r>
               <a:rPr lang="en-US" sz="2200" b="1" dirty="0">
                 <a:solidFill>
-                  <a:srgbClr val="0D9488"/>
+                  <a:srgbClr val="2DD4BF"/>
                 </a:solidFill>
                 <a:latin typeface="Calibri" pitchFamily="34" charset="0"/>
                 <a:ea typeface="Calibri" pitchFamily="34" charset="-122"/>
@@ -11195,7 +11195,7 @@
             <a:r>
               <a:rPr lang="en-US" sz="1400" dirty="0">
                 <a:solidFill>
-                  <a:srgbClr val="475569"/>
+                  <a:srgbClr val="CBD5E1"/>
                 </a:solidFill>
                 <a:latin typeface="Calibri" pitchFamily="34" charset="0"/>
                 <a:ea typeface="Calibri" pitchFamily="34" charset="-122"/>
@@ -11222,18 +11222,18 @@
             <a:avLst/>
           </a:prstGeom>
           <a:solidFill>
-            <a:srgbClr val="FFFFFF"/>
+            <a:srgbClr val="152033"/>
           </a:solidFill>
           <a:ln w="12700">
             <a:solidFill>
-              <a:srgbClr val="E2E8F0"/>
+              <a:srgbClr val="2A4060"/>
             </a:solidFill>
             <a:prstDash val="solid"/>
           </a:ln>
           <a:effectLst>
-            <a:outerShdw sx="100000" sy="100000" kx="0" ky="0" algn="bl" rotWithShape="0" blurRad="127000" dist="38100" dir="8100000">
-              <a:srgbClr val="0A1628">
-                <a:alpha val="8000"/>
+            <a:outerShdw sx="100000" sy="100000" kx="0" ky="0" algn="bl" rotWithShape="0" blurRad="152400" dist="25400" dir="8100000">
+              <a:srgbClr val="000000">
+                <a:alpha val="35000"/>
               </a:srgbClr>
             </a:outerShdw>
           </a:effectLst>
@@ -11266,7 +11266,7 @@
             <a:r>
               <a:rPr lang="en-US" sz="2200" b="1" dirty="0">
                 <a:solidFill>
-                  <a:srgbClr val="0D9488"/>
+                  <a:srgbClr val="2DD4BF"/>
                 </a:solidFill>
                 <a:latin typeface="Calibri" pitchFamily="34" charset="0"/>
                 <a:ea typeface="Calibri" pitchFamily="34" charset="-122"/>
@@ -11305,7 +11305,7 @@
             <a:r>
               <a:rPr lang="en-US" sz="1400" dirty="0">
                 <a:solidFill>
-                  <a:srgbClr val="475569"/>
+                  <a:srgbClr val="CBD5E1"/>
                 </a:solidFill>
                 <a:latin typeface="Calibri" pitchFamily="34" charset="0"/>
                 <a:ea typeface="Calibri" pitchFamily="34" charset="-122"/>
@@ -11332,18 +11332,18 @@
             <a:avLst/>
           </a:prstGeom>
           <a:solidFill>
-            <a:srgbClr val="FFFFFF"/>
+            <a:srgbClr val="152033"/>
           </a:solidFill>
           <a:ln w="12700">
             <a:solidFill>
-              <a:srgbClr val="E2E8F0"/>
+              <a:srgbClr val="2A4060"/>
             </a:solidFill>
             <a:prstDash val="solid"/>
           </a:ln>
           <a:effectLst>
-            <a:outerShdw sx="100000" sy="100000" kx="0" ky="0" algn="bl" rotWithShape="0" blurRad="127000" dist="38100" dir="8100000">
-              <a:srgbClr val="0A1628">
-                <a:alpha val="8000"/>
+            <a:outerShdw sx="100000" sy="100000" kx="0" ky="0" algn="bl" rotWithShape="0" blurRad="152400" dist="25400" dir="8100000">
+              <a:srgbClr val="000000">
+                <a:alpha val="35000"/>
               </a:srgbClr>
             </a:outerShdw>
           </a:effectLst>
@@ -11376,7 +11376,7 @@
             <a:r>
               <a:rPr lang="en-US" sz="2200" b="1" dirty="0">
                 <a:solidFill>
-                  <a:srgbClr val="0D9488"/>
+                  <a:srgbClr val="2DD4BF"/>
                 </a:solidFill>
                 <a:latin typeface="Calibri" pitchFamily="34" charset="0"/>
                 <a:ea typeface="Calibri" pitchFamily="34" charset="-122"/>
@@ -11415,7 +11415,7 @@
             <a:r>
               <a:rPr lang="en-US" sz="1400" dirty="0">
                 <a:solidFill>
-                  <a:srgbClr val="475569"/>
+                  <a:srgbClr val="CBD5E1"/>
                 </a:solidFill>
                 <a:latin typeface="Calibri" pitchFamily="34" charset="0"/>
                 <a:ea typeface="Calibri" pitchFamily="34" charset="-122"/>
@@ -11454,7 +11454,7 @@
             <a:r>
               <a:rPr lang="en-US" sz="1000" i="1" dirty="0">
                 <a:solidFill>
-                  <a:srgbClr val="64748B"/>
+                  <a:srgbClr val="94A3B8"/>
                 </a:solidFill>
                 <a:latin typeface="Calibri" pitchFamily="34" charset="0"/>
                 <a:ea typeface="Calibri" pitchFamily="34" charset="-122"/>
@@ -11493,7 +11493,7 @@
             <a:r>
               <a:rPr lang="en-US" sz="1100" b="1" dirty="0">
                 <a:solidFill>
-                  <a:srgbClr val="0D9488"/>
+                  <a:srgbClr val="2DD4BF"/>
                 </a:solidFill>
                 <a:latin typeface="Calibri" pitchFamily="34" charset="0"/>
                 <a:ea typeface="Calibri" pitchFamily="34" charset="-122"/>
@@ -11519,7 +11519,7 @@
     <p:bg>
       <p:bgPr>
         <a:solidFill>
-          <a:srgbClr val="F4F7FB"/>
+          <a:srgbClr val="070B14"/>
         </a:solidFill>
       </p:bgPr>
     </p:bg>
@@ -11552,7 +11552,7 @@
             <a:avLst/>
           </a:prstGeom>
           <a:solidFill>
-            <a:srgbClr val="0D9488"/>
+            <a:srgbClr val="2DD4BF"/>
           </a:solidFill>
           <a:ln/>
         </p:spPr>
@@ -11584,7 +11584,7 @@
             <a:r>
               <a:rPr lang="en-US" sz="1100" b="1" spc="220" kern="0" dirty="0">
                 <a:solidFill>
-                  <a:srgbClr val="0D9488"/>
+                  <a:srgbClr val="2DD4BF"/>
                 </a:solidFill>
                 <a:latin typeface="Calibri" pitchFamily="34" charset="0"/>
                 <a:ea typeface="Calibri" pitchFamily="34" charset="-122"/>
@@ -11623,7 +11623,7 @@
             <a:r>
               <a:rPr lang="en-US" sz="2600" b="1" dirty="0">
                 <a:solidFill>
-                  <a:srgbClr val="0A1628"/>
+                  <a:srgbClr val="F8FAFC"/>
                 </a:solidFill>
                 <a:latin typeface="Calibri" pitchFamily="34" charset="0"/>
                 <a:ea typeface="Calibri" pitchFamily="34" charset="-122"/>
@@ -11666,7 +11666,7 @@
             <a:avLst/>
           </a:prstGeom>
           <a:solidFill>
-            <a:srgbClr val="0A1628"/>
+            <a:srgbClr val="101827"/>
           </a:solidFill>
           <a:ln/>
         </p:spPr>
@@ -11737,7 +11737,7 @@
             <a:r>
               <a:rPr lang="en-US" sz="1400" dirty="0">
                 <a:solidFill>
-                  <a:srgbClr val="FFFFFF"/>
+                  <a:srgbClr val="F8FAFC"/>
                 </a:solidFill>
                 <a:latin typeface="Calibri" pitchFamily="34" charset="0"/>
                 <a:ea typeface="Calibri" pitchFamily="34" charset="-122"/>
@@ -11776,7 +11776,7 @@
             <a:r>
               <a:rPr lang="en-US" sz="1400" dirty="0">
                 <a:solidFill>
-                  <a:srgbClr val="FFFFFF"/>
+                  <a:srgbClr val="F8FAFC"/>
                 </a:solidFill>
                 <a:latin typeface="Calibri" pitchFamily="34" charset="0"/>
                 <a:ea typeface="Calibri" pitchFamily="34" charset="-122"/>
@@ -11815,7 +11815,7 @@
             <a:r>
               <a:rPr lang="en-US" sz="1400" dirty="0">
                 <a:solidFill>
-                  <a:srgbClr val="FFFFFF"/>
+                  <a:srgbClr val="F8FAFC"/>
                 </a:solidFill>
                 <a:latin typeface="Calibri" pitchFamily="34" charset="0"/>
                 <a:ea typeface="Calibri" pitchFamily="34" charset="-122"/>
@@ -11854,7 +11854,7 @@
             <a:r>
               <a:rPr lang="en-US" sz="1400" dirty="0">
                 <a:solidFill>
-                  <a:srgbClr val="FFFFFF"/>
+                  <a:srgbClr val="F8FAFC"/>
                 </a:solidFill>
                 <a:latin typeface="Calibri" pitchFamily="34" charset="0"/>
                 <a:ea typeface="Calibri" pitchFamily="34" charset="-122"/>
@@ -11893,7 +11893,7 @@
             <a:r>
               <a:rPr lang="en-US" sz="1000" i="1" dirty="0">
                 <a:solidFill>
-                  <a:srgbClr val="64748B"/>
+                  <a:srgbClr val="94A3B8"/>
                 </a:solidFill>
                 <a:latin typeface="Calibri" pitchFamily="34" charset="0"/>
                 <a:ea typeface="Calibri" pitchFamily="34" charset="-122"/>
@@ -11932,7 +11932,7 @@
             <a:r>
               <a:rPr lang="en-US" sz="1100" b="1" dirty="0">
                 <a:solidFill>
-                  <a:srgbClr val="0D9488"/>
+                  <a:srgbClr val="2DD4BF"/>
                 </a:solidFill>
                 <a:latin typeface="Calibri" pitchFamily="34" charset="0"/>
                 <a:ea typeface="Calibri" pitchFamily="34" charset="-122"/>
@@ -11958,7 +11958,7 @@
     <p:bg>
       <p:bgPr>
         <a:solidFill>
-          <a:srgbClr val="F4F7FB"/>
+          <a:srgbClr val="070B14"/>
         </a:solidFill>
       </p:bgPr>
     </p:bg>
@@ -11991,7 +11991,7 @@
             <a:avLst/>
           </a:prstGeom>
           <a:solidFill>
-            <a:srgbClr val="0D9488"/>
+            <a:srgbClr val="2DD4BF"/>
           </a:solidFill>
           <a:ln/>
         </p:spPr>
@@ -12023,7 +12023,7 @@
             <a:r>
               <a:rPr lang="en-US" sz="1100" b="1" spc="220" kern="0" dirty="0">
                 <a:solidFill>
-                  <a:srgbClr val="0D9488"/>
+                  <a:srgbClr val="2DD4BF"/>
                 </a:solidFill>
                 <a:latin typeface="Calibri" pitchFamily="34" charset="0"/>
                 <a:ea typeface="Calibri" pitchFamily="34" charset="-122"/>
@@ -12062,7 +12062,7 @@
             <a:r>
               <a:rPr lang="en-US" sz="2600" b="1" dirty="0">
                 <a:solidFill>
-                  <a:srgbClr val="0A1628"/>
+                  <a:srgbClr val="F8FAFC"/>
                 </a:solidFill>
                 <a:latin typeface="Calibri" pitchFamily="34" charset="0"/>
                 <a:ea typeface="Calibri" pitchFamily="34" charset="-122"/>
@@ -12089,18 +12089,18 @@
             <a:avLst/>
           </a:prstGeom>
           <a:solidFill>
-            <a:srgbClr val="FFFFFF"/>
+            <a:srgbClr val="152033"/>
           </a:solidFill>
           <a:ln w="12700">
             <a:solidFill>
-              <a:srgbClr val="E2E8F0"/>
+              <a:srgbClr val="2A4060"/>
             </a:solidFill>
             <a:prstDash val="solid"/>
           </a:ln>
           <a:effectLst>
-            <a:outerShdw sx="100000" sy="100000" kx="0" ky="0" algn="bl" rotWithShape="0" blurRad="127000" dist="38100" dir="8100000">
-              <a:srgbClr val="0A1628">
-                <a:alpha val="8000"/>
+            <a:outerShdw sx="100000" sy="100000" kx="0" ky="0" algn="bl" rotWithShape="0" blurRad="152400" dist="25400" dir="8100000">
+              <a:srgbClr val="000000">
+                <a:alpha val="35000"/>
               </a:srgbClr>
             </a:outerShdw>
           </a:effectLst>
@@ -12121,7 +12121,7 @@
             <a:avLst/>
           </a:prstGeom>
           <a:solidFill>
-            <a:srgbClr val="ECFDF8"/>
+            <a:srgbClr val="101827"/>
           </a:solidFill>
           <a:ln/>
         </p:spPr>
@@ -12177,7 +12177,7 @@
             <a:r>
               <a:rPr lang="en-US" sz="1600" b="1" dirty="0">
                 <a:solidFill>
-                  <a:srgbClr val="0A1628"/>
+                  <a:srgbClr val="F8FAFC"/>
                 </a:solidFill>
                 <a:latin typeface="Calibri" pitchFamily="34" charset="0"/>
                 <a:ea typeface="Calibri" pitchFamily="34" charset="-122"/>
@@ -12216,7 +12216,7 @@
             <a:r>
               <a:rPr lang="en-US" sz="1400" dirty="0">
                 <a:solidFill>
-                  <a:srgbClr val="475569"/>
+                  <a:srgbClr val="CBD5E1"/>
                 </a:solidFill>
                 <a:latin typeface="Calibri" pitchFamily="34" charset="0"/>
                 <a:ea typeface="Calibri" pitchFamily="34" charset="-122"/>
@@ -12243,18 +12243,18 @@
             <a:avLst/>
           </a:prstGeom>
           <a:solidFill>
-            <a:srgbClr val="FFFFFF"/>
+            <a:srgbClr val="152033"/>
           </a:solidFill>
           <a:ln w="12700">
             <a:solidFill>
-              <a:srgbClr val="E2E8F0"/>
+              <a:srgbClr val="2A4060"/>
             </a:solidFill>
             <a:prstDash val="solid"/>
           </a:ln>
           <a:effectLst>
-            <a:outerShdw sx="100000" sy="100000" kx="0" ky="0" algn="bl" rotWithShape="0" blurRad="127000" dist="38100" dir="8100000">
-              <a:srgbClr val="0A1628">
-                <a:alpha val="8000"/>
+            <a:outerShdw sx="100000" sy="100000" kx="0" ky="0" algn="bl" rotWithShape="0" blurRad="152400" dist="25400" dir="8100000">
+              <a:srgbClr val="000000">
+                <a:alpha val="35000"/>
               </a:srgbClr>
             </a:outerShdw>
           </a:effectLst>
@@ -12275,7 +12275,7 @@
             <a:avLst/>
           </a:prstGeom>
           <a:solidFill>
-            <a:srgbClr val="ECFDF8"/>
+            <a:srgbClr val="101827"/>
           </a:solidFill>
           <a:ln/>
         </p:spPr>
@@ -12331,7 +12331,7 @@
             <a:r>
               <a:rPr lang="en-US" sz="1600" b="1" dirty="0">
                 <a:solidFill>
-                  <a:srgbClr val="0A1628"/>
+                  <a:srgbClr val="F8FAFC"/>
                 </a:solidFill>
                 <a:latin typeface="Calibri" pitchFamily="34" charset="0"/>
                 <a:ea typeface="Calibri" pitchFamily="34" charset="-122"/>
@@ -12370,7 +12370,7 @@
             <a:r>
               <a:rPr lang="en-US" sz="1400" dirty="0">
                 <a:solidFill>
-                  <a:srgbClr val="475569"/>
+                  <a:srgbClr val="CBD5E1"/>
                 </a:solidFill>
                 <a:latin typeface="Calibri" pitchFamily="34" charset="0"/>
                 <a:ea typeface="Calibri" pitchFamily="34" charset="-122"/>
@@ -12397,18 +12397,18 @@
             <a:avLst/>
           </a:prstGeom>
           <a:solidFill>
-            <a:srgbClr val="FFFFFF"/>
+            <a:srgbClr val="152033"/>
           </a:solidFill>
           <a:ln w="12700">
             <a:solidFill>
-              <a:srgbClr val="E2E8F0"/>
+              <a:srgbClr val="2A4060"/>
             </a:solidFill>
             <a:prstDash val="solid"/>
           </a:ln>
           <a:effectLst>
-            <a:outerShdw sx="100000" sy="100000" kx="0" ky="0" algn="bl" rotWithShape="0" blurRad="127000" dist="38100" dir="8100000">
-              <a:srgbClr val="0A1628">
-                <a:alpha val="8000"/>
+            <a:outerShdw sx="100000" sy="100000" kx="0" ky="0" algn="bl" rotWithShape="0" blurRad="152400" dist="25400" dir="8100000">
+              <a:srgbClr val="000000">
+                <a:alpha val="35000"/>
               </a:srgbClr>
             </a:outerShdw>
           </a:effectLst>
@@ -12429,7 +12429,7 @@
             <a:avLst/>
           </a:prstGeom>
           <a:solidFill>
-            <a:srgbClr val="ECFDF8"/>
+            <a:srgbClr val="101827"/>
           </a:solidFill>
           <a:ln/>
         </p:spPr>
@@ -12485,7 +12485,7 @@
             <a:r>
               <a:rPr lang="en-US" sz="1600" b="1" dirty="0">
                 <a:solidFill>
-                  <a:srgbClr val="0A1628"/>
+                  <a:srgbClr val="F8FAFC"/>
                 </a:solidFill>
                 <a:latin typeface="Calibri" pitchFamily="34" charset="0"/>
                 <a:ea typeface="Calibri" pitchFamily="34" charset="-122"/>
@@ -12524,7 +12524,7 @@
             <a:r>
               <a:rPr lang="en-US" sz="1400" dirty="0">
                 <a:solidFill>
-                  <a:srgbClr val="475569"/>
+                  <a:srgbClr val="CBD5E1"/>
                 </a:solidFill>
                 <a:latin typeface="Calibri" pitchFamily="34" charset="0"/>
                 <a:ea typeface="Calibri" pitchFamily="34" charset="-122"/>
@@ -12551,18 +12551,18 @@
             <a:avLst/>
           </a:prstGeom>
           <a:solidFill>
-            <a:srgbClr val="FFFFFF"/>
+            <a:srgbClr val="152033"/>
           </a:solidFill>
           <a:ln w="12700">
             <a:solidFill>
-              <a:srgbClr val="E2E8F0"/>
+              <a:srgbClr val="2A4060"/>
             </a:solidFill>
             <a:prstDash val="solid"/>
           </a:ln>
           <a:effectLst>
-            <a:outerShdw sx="100000" sy="100000" kx="0" ky="0" algn="bl" rotWithShape="0" blurRad="127000" dist="38100" dir="8100000">
-              <a:srgbClr val="0A1628">
-                <a:alpha val="8000"/>
+            <a:outerShdw sx="100000" sy="100000" kx="0" ky="0" algn="bl" rotWithShape="0" blurRad="152400" dist="25400" dir="8100000">
+              <a:srgbClr val="000000">
+                <a:alpha val="35000"/>
               </a:srgbClr>
             </a:outerShdw>
           </a:effectLst>
@@ -12583,7 +12583,7 @@
             <a:avLst/>
           </a:prstGeom>
           <a:solidFill>
-            <a:srgbClr val="ECFDF8"/>
+            <a:srgbClr val="101827"/>
           </a:solidFill>
           <a:ln/>
         </p:spPr>
@@ -12639,7 +12639,7 @@
             <a:r>
               <a:rPr lang="en-US" sz="1600" b="1" dirty="0">
                 <a:solidFill>
-                  <a:srgbClr val="0A1628"/>
+                  <a:srgbClr val="F8FAFC"/>
                 </a:solidFill>
                 <a:latin typeface="Calibri" pitchFamily="34" charset="0"/>
                 <a:ea typeface="Calibri" pitchFamily="34" charset="-122"/>
@@ -12678,7 +12678,7 @@
             <a:r>
               <a:rPr lang="en-US" sz="1400" dirty="0">
                 <a:solidFill>
-                  <a:srgbClr val="475569"/>
+                  <a:srgbClr val="CBD5E1"/>
                 </a:solidFill>
                 <a:latin typeface="Calibri" pitchFamily="34" charset="0"/>
                 <a:ea typeface="Calibri" pitchFamily="34" charset="-122"/>
@@ -12705,18 +12705,18 @@
             <a:avLst/>
           </a:prstGeom>
           <a:solidFill>
-            <a:srgbClr val="FFFFFF"/>
+            <a:srgbClr val="152033"/>
           </a:solidFill>
           <a:ln w="12700">
             <a:solidFill>
-              <a:srgbClr val="E2E8F0"/>
+              <a:srgbClr val="2A4060"/>
             </a:solidFill>
             <a:prstDash val="solid"/>
           </a:ln>
           <a:effectLst>
-            <a:outerShdw sx="100000" sy="100000" kx="0" ky="0" algn="bl" rotWithShape="0" blurRad="127000" dist="38100" dir="8100000">
-              <a:srgbClr val="0A1628">
-                <a:alpha val="8000"/>
+            <a:outerShdw sx="100000" sy="100000" kx="0" ky="0" algn="bl" rotWithShape="0" blurRad="152400" dist="25400" dir="8100000">
+              <a:srgbClr val="000000">
+                <a:alpha val="35000"/>
               </a:srgbClr>
             </a:outerShdw>
           </a:effectLst>
@@ -12737,7 +12737,7 @@
             <a:avLst/>
           </a:prstGeom>
           <a:solidFill>
-            <a:srgbClr val="ECFDF8"/>
+            <a:srgbClr val="101827"/>
           </a:solidFill>
           <a:ln/>
         </p:spPr>
@@ -12793,7 +12793,7 @@
             <a:r>
               <a:rPr lang="en-US" sz="1600" b="1" dirty="0">
                 <a:solidFill>
-                  <a:srgbClr val="0A1628"/>
+                  <a:srgbClr val="F8FAFC"/>
                 </a:solidFill>
                 <a:latin typeface="Calibri" pitchFamily="34" charset="0"/>
                 <a:ea typeface="Calibri" pitchFamily="34" charset="-122"/>
@@ -12832,7 +12832,7 @@
             <a:r>
               <a:rPr lang="en-US" sz="1400" dirty="0">
                 <a:solidFill>
-                  <a:srgbClr val="475569"/>
+                  <a:srgbClr val="CBD5E1"/>
                 </a:solidFill>
                 <a:latin typeface="Calibri" pitchFamily="34" charset="0"/>
                 <a:ea typeface="Calibri" pitchFamily="34" charset="-122"/>
@@ -12859,18 +12859,18 @@
             <a:avLst/>
           </a:prstGeom>
           <a:solidFill>
-            <a:srgbClr val="FFFFFF"/>
+            <a:srgbClr val="152033"/>
           </a:solidFill>
           <a:ln w="12700">
             <a:solidFill>
-              <a:srgbClr val="E2E8F0"/>
+              <a:srgbClr val="2A4060"/>
             </a:solidFill>
             <a:prstDash val="solid"/>
           </a:ln>
           <a:effectLst>
-            <a:outerShdw sx="100000" sy="100000" kx="0" ky="0" algn="bl" rotWithShape="0" blurRad="127000" dist="38100" dir="8100000">
-              <a:srgbClr val="0A1628">
-                <a:alpha val="8000"/>
+            <a:outerShdw sx="100000" sy="100000" kx="0" ky="0" algn="bl" rotWithShape="0" blurRad="152400" dist="25400" dir="8100000">
+              <a:srgbClr val="000000">
+                <a:alpha val="35000"/>
               </a:srgbClr>
             </a:outerShdw>
           </a:effectLst>
@@ -12891,7 +12891,7 @@
             <a:avLst/>
           </a:prstGeom>
           <a:solidFill>
-            <a:srgbClr val="ECFDF8"/>
+            <a:srgbClr val="101827"/>
           </a:solidFill>
           <a:ln/>
         </p:spPr>
@@ -12947,7 +12947,7 @@
             <a:r>
               <a:rPr lang="en-US" sz="1600" b="1" dirty="0">
                 <a:solidFill>
-                  <a:srgbClr val="0A1628"/>
+                  <a:srgbClr val="F8FAFC"/>
                 </a:solidFill>
                 <a:latin typeface="Calibri" pitchFamily="34" charset="0"/>
                 <a:ea typeface="Calibri" pitchFamily="34" charset="-122"/>
@@ -12986,7 +12986,7 @@
             <a:r>
               <a:rPr lang="en-US" sz="1400" dirty="0">
                 <a:solidFill>
-                  <a:srgbClr val="475569"/>
+                  <a:srgbClr val="CBD5E1"/>
                 </a:solidFill>
                 <a:latin typeface="Calibri" pitchFamily="34" charset="0"/>
                 <a:ea typeface="Calibri" pitchFamily="34" charset="-122"/>
@@ -13025,7 +13025,7 @@
             <a:r>
               <a:rPr lang="en-US" sz="1000" i="1" dirty="0">
                 <a:solidFill>
-                  <a:srgbClr val="64748B"/>
+                  <a:srgbClr val="94A3B8"/>
                 </a:solidFill>
                 <a:latin typeface="Calibri" pitchFamily="34" charset="0"/>
                 <a:ea typeface="Calibri" pitchFamily="34" charset="-122"/>
@@ -13064,7 +13064,7 @@
             <a:r>
               <a:rPr lang="en-US" sz="1100" b="1" dirty="0">
                 <a:solidFill>
-                  <a:srgbClr val="0D9488"/>
+                  <a:srgbClr val="2DD4BF"/>
                 </a:solidFill>
                 <a:latin typeface="Calibri" pitchFamily="34" charset="0"/>
                 <a:ea typeface="Calibri" pitchFamily="34" charset="-122"/>

</xml_diff>

<commit_message>
docs: glass dark proposal in HTML with slide controls
Add a self-contained HTML deck (blur cards, SVG mix charts, CSS bars,
keyboard/touch/overview HUD) and make the PPTX cards translucent so
both versions share a dark glass look.
</commit_message>
<xml_diff>
--- a/docs/Propuesta_Callcenter_Bancario.pptx
+++ b/docs/Propuesta_Callcenter_Bancario.pptx
@@ -365,7 +365,7 @@
       </c:doughnutChart>
       <c:spPr>
         <a:solidFill>
-          <a:srgbClr val="070B14"/>
+          <a:srgbClr val="101827"/>
         </a:solidFill>
         <a:ln>
           <a:noFill/>
@@ -398,7 +398,7 @@
   </c:chart>
   <c:spPr>
     <a:solidFill>
-      <a:srgbClr val="070B14"/>
+      <a:srgbClr val="101827"/>
     </a:solidFill>
     <a:ln>
       <a:noFill/>
@@ -635,7 +635,7 @@
       </c:valAx>
       <c:spPr>
         <a:solidFill>
-          <a:srgbClr val="070B14"/>
+          <a:srgbClr val="101827"/>
         </a:solidFill>
         <a:ln>
           <a:noFill/>
@@ -648,7 +648,7 @@
   </c:chart>
   <c:spPr>
     <a:solidFill>
-      <a:srgbClr val="070B14"/>
+      <a:srgbClr val="101827"/>
     </a:solidFill>
     <a:ln>
       <a:noFill/>
@@ -908,7 +908,7 @@
       </c:doughnutChart>
       <c:spPr>
         <a:solidFill>
-          <a:srgbClr val="070B14"/>
+          <a:srgbClr val="101827"/>
         </a:solidFill>
         <a:ln>
           <a:noFill/>
@@ -941,7 +941,7 @@
   </c:chart>
   <c:spPr>
     <a:solidFill>
-      <a:srgbClr val="070B14"/>
+      <a:srgbClr val="101827"/>
     </a:solidFill>
     <a:ln>
       <a:noFill/>
@@ -1267,7 +1267,7 @@
       </c:valAx>
       <c:spPr>
         <a:solidFill>
-          <a:srgbClr val="070B14"/>
+          <a:srgbClr val="101827"/>
         </a:solidFill>
         <a:ln>
           <a:noFill/>
@@ -1300,7 +1300,7 @@
   </c:chart>
   <c:spPr>
     <a:solidFill>
-      <a:srgbClr val="070B14"/>
+      <a:srgbClr val="101827"/>
     </a:solidFill>
     <a:ln>
       <a:noFill/>
@@ -3282,9 +3282,18 @@
             <a:avLst/>
           </a:prstGeom>
           <a:solidFill>
-            <a:srgbClr val="101827"/>
+            <a:srgbClr val="FFFFFF">
+              <a:alpha val="12000"/>
+            </a:srgbClr>
           </a:solidFill>
-          <a:ln/>
+          <a:ln w="9525">
+            <a:solidFill>
+              <a:srgbClr val="5EEAD4">
+                <a:alpha val="30000"/>
+              </a:srgbClr>
+            </a:solidFill>
+            <a:prstDash val="solid"/>
+          </a:ln>
         </p:spPr>
       </p:sp>
       <p:sp>
@@ -3417,9 +3426,18 @@
             <a:avLst/>
           </a:prstGeom>
           <a:solidFill>
-            <a:srgbClr val="101827"/>
+            <a:srgbClr val="FFFFFF">
+              <a:alpha val="12000"/>
+            </a:srgbClr>
           </a:solidFill>
-          <a:ln/>
+          <a:ln w="9525">
+            <a:solidFill>
+              <a:srgbClr val="5EEAD4">
+                <a:alpha val="30000"/>
+              </a:srgbClr>
+            </a:solidFill>
+            <a:prstDash val="solid"/>
+          </a:ln>
         </p:spPr>
       </p:sp>
       <p:sp>
@@ -3552,9 +3570,18 @@
             <a:avLst/>
           </a:prstGeom>
           <a:solidFill>
-            <a:srgbClr val="101827"/>
+            <a:srgbClr val="FFFFFF">
+              <a:alpha val="12000"/>
+            </a:srgbClr>
           </a:solidFill>
-          <a:ln/>
+          <a:ln w="9525">
+            <a:solidFill>
+              <a:srgbClr val="5EEAD4">
+                <a:alpha val="30000"/>
+              </a:srgbClr>
+            </a:solidFill>
+            <a:prstDash val="solid"/>
+          </a:ln>
         </p:spPr>
       </p:sp>
       <p:sp>
@@ -3751,6 +3778,50 @@
         </p:nvSpPr>
         <p:spPr>
           <a:xfrm>
+            <a:off x="-1645920" y="-2011680"/>
+            <a:ext cx="4754880" cy="4754880"/>
+          </a:xfrm>
+          <a:prstGeom prst="ellipse">
+            <a:avLst/>
+          </a:prstGeom>
+          <a:solidFill>
+            <a:srgbClr val="0D9488">
+              <a:alpha val="12000"/>
+            </a:srgbClr>
+          </a:solidFill>
+          <a:ln/>
+        </p:spPr>
+      </p:sp>
+      <p:sp>
+        <p:nvSpPr>
+          <p:cNvPr id="3" name="Shape 1"/>
+          <p:cNvSpPr/>
+          <p:nvPr/>
+        </p:nvSpPr>
+        <p:spPr>
+          <a:xfrm>
+            <a:off x="9509760" y="3840480"/>
+            <a:ext cx="4206240" cy="4206240"/>
+          </a:xfrm>
+          <a:prstGeom prst="ellipse">
+            <a:avLst/>
+          </a:prstGeom>
+          <a:solidFill>
+            <a:srgbClr val="38BDF8">
+              <a:alpha val="10000"/>
+            </a:srgbClr>
+          </a:solidFill>
+          <a:ln/>
+        </p:spPr>
+      </p:sp>
+      <p:sp>
+        <p:nvSpPr>
+          <p:cNvPr id="4" name="Shape 2"/>
+          <p:cNvSpPr/>
+          <p:nvPr/>
+        </p:nvSpPr>
+        <p:spPr>
+          <a:xfrm>
             <a:off x="0" y="0"/>
             <a:ext cx="12191695" cy="73152"/>
           </a:xfrm>
@@ -3765,7 +3836,7 @@
       </p:sp>
       <p:sp>
         <p:nvSpPr>
-          <p:cNvPr id="3" name="Text 1"/>
+          <p:cNvPr id="5" name="Text 3"/>
           <p:cNvSpPr/>
           <p:nvPr/>
         </p:nvSpPr>
@@ -3804,7 +3875,7 @@
       </p:sp>
       <p:sp>
         <p:nvSpPr>
-          <p:cNvPr id="4" name="Text 2"/>
+          <p:cNvPr id="6" name="Text 4"/>
           <p:cNvSpPr/>
           <p:nvPr/>
         </p:nvSpPr>
@@ -3843,7 +3914,7 @@
       </p:sp>
       <p:sp>
         <p:nvSpPr>
-          <p:cNvPr id="5" name="Shape 3"/>
+          <p:cNvPr id="7" name="Shape 5"/>
           <p:cNvSpPr/>
           <p:nvPr/>
         </p:nvSpPr>
@@ -3856,11 +3927,15 @@
             <a:avLst/>
           </a:prstGeom>
           <a:solidFill>
-            <a:srgbClr val="152033"/>
+            <a:srgbClr val="FFFFFF">
+              <a:alpha val="12000"/>
+            </a:srgbClr>
           </a:solidFill>
-          <a:ln w="12700">
+          <a:ln w="9525">
             <a:solidFill>
-              <a:srgbClr val="2A4060"/>
+              <a:srgbClr val="5EEAD4">
+                <a:alpha val="30000"/>
+              </a:srgbClr>
             </a:solidFill>
             <a:prstDash val="solid"/>
           </a:ln>
@@ -3875,7 +3950,7 @@
       </p:sp>
       <p:sp>
         <p:nvSpPr>
-          <p:cNvPr id="6" name="Shape 4"/>
+          <p:cNvPr id="8" name="Shape 6"/>
           <p:cNvSpPr/>
           <p:nvPr/>
         </p:nvSpPr>
@@ -3895,7 +3970,7 @@
       </p:sp>
       <p:pic>
         <p:nvPicPr>
-          <p:cNvPr id="7" name="Image 0" descr="preencoded.png">    </p:cNvPr>
+          <p:cNvPr id="9" name="Image 0" descr="preencoded.png">    </p:cNvPr>
           <p:cNvPicPr>
             <a:picLocks noChangeAspect="1"/>
           </p:cNvPicPr>
@@ -3919,7 +3994,7 @@
       </p:pic>
       <p:sp>
         <p:nvSpPr>
-          <p:cNvPr id="8" name="Text 5"/>
+          <p:cNvPr id="10" name="Text 7"/>
           <p:cNvSpPr/>
           <p:nvPr/>
         </p:nvSpPr>
@@ -3958,7 +4033,7 @@
       </p:sp>
       <p:sp>
         <p:nvSpPr>
-          <p:cNvPr id="9" name="Text 6"/>
+          <p:cNvPr id="11" name="Text 8"/>
           <p:cNvSpPr/>
           <p:nvPr/>
         </p:nvSpPr>
@@ -3997,7 +4072,7 @@
       </p:sp>
       <p:sp>
         <p:nvSpPr>
-          <p:cNvPr id="10" name="Shape 7"/>
+          <p:cNvPr id="12" name="Shape 9"/>
           <p:cNvSpPr/>
           <p:nvPr/>
         </p:nvSpPr>
@@ -4010,11 +4085,15 @@
             <a:avLst/>
           </a:prstGeom>
           <a:solidFill>
-            <a:srgbClr val="152033"/>
+            <a:srgbClr val="FFFFFF">
+              <a:alpha val="12000"/>
+            </a:srgbClr>
           </a:solidFill>
-          <a:ln w="12700">
+          <a:ln w="9525">
             <a:solidFill>
-              <a:srgbClr val="2A4060"/>
+              <a:srgbClr val="5EEAD4">
+                <a:alpha val="30000"/>
+              </a:srgbClr>
             </a:solidFill>
             <a:prstDash val="solid"/>
           </a:ln>
@@ -4029,7 +4108,7 @@
       </p:sp>
       <p:sp>
         <p:nvSpPr>
-          <p:cNvPr id="11" name="Shape 8"/>
+          <p:cNvPr id="13" name="Shape 10"/>
           <p:cNvSpPr/>
           <p:nvPr/>
         </p:nvSpPr>
@@ -4049,7 +4128,7 @@
       </p:sp>
       <p:pic>
         <p:nvPicPr>
-          <p:cNvPr id="12" name="Image 1" descr="preencoded.png">    </p:cNvPr>
+          <p:cNvPr id="14" name="Image 1" descr="preencoded.png">    </p:cNvPr>
           <p:cNvPicPr>
             <a:picLocks noChangeAspect="1"/>
           </p:cNvPicPr>
@@ -4073,7 +4152,7 @@
       </p:pic>
       <p:sp>
         <p:nvSpPr>
-          <p:cNvPr id="13" name="Text 9"/>
+          <p:cNvPr id="15" name="Text 11"/>
           <p:cNvSpPr/>
           <p:nvPr/>
         </p:nvSpPr>
@@ -4112,7 +4191,7 @@
       </p:sp>
       <p:sp>
         <p:nvSpPr>
-          <p:cNvPr id="14" name="Text 10"/>
+          <p:cNvPr id="16" name="Text 12"/>
           <p:cNvSpPr/>
           <p:nvPr/>
         </p:nvSpPr>
@@ -4151,7 +4230,7 @@
       </p:sp>
       <p:sp>
         <p:nvSpPr>
-          <p:cNvPr id="15" name="Shape 11"/>
+          <p:cNvPr id="17" name="Shape 13"/>
           <p:cNvSpPr/>
           <p:nvPr/>
         </p:nvSpPr>
@@ -4164,11 +4243,15 @@
             <a:avLst/>
           </a:prstGeom>
           <a:solidFill>
-            <a:srgbClr val="152033"/>
+            <a:srgbClr val="FFFFFF">
+              <a:alpha val="12000"/>
+            </a:srgbClr>
           </a:solidFill>
-          <a:ln w="12700">
+          <a:ln w="9525">
             <a:solidFill>
-              <a:srgbClr val="2A4060"/>
+              <a:srgbClr val="5EEAD4">
+                <a:alpha val="30000"/>
+              </a:srgbClr>
             </a:solidFill>
             <a:prstDash val="solid"/>
           </a:ln>
@@ -4183,7 +4266,7 @@
       </p:sp>
       <p:sp>
         <p:nvSpPr>
-          <p:cNvPr id="16" name="Shape 12"/>
+          <p:cNvPr id="18" name="Shape 14"/>
           <p:cNvSpPr/>
           <p:nvPr/>
         </p:nvSpPr>
@@ -4203,7 +4286,7 @@
       </p:sp>
       <p:pic>
         <p:nvPicPr>
-          <p:cNvPr id="17" name="Image 2" descr="preencoded.png">    </p:cNvPr>
+          <p:cNvPr id="19" name="Image 2" descr="preencoded.png">    </p:cNvPr>
           <p:cNvPicPr>
             <a:picLocks noChangeAspect="1"/>
           </p:cNvPicPr>
@@ -4227,7 +4310,7 @@
       </p:pic>
       <p:sp>
         <p:nvSpPr>
-          <p:cNvPr id="18" name="Text 13"/>
+          <p:cNvPr id="20" name="Text 15"/>
           <p:cNvSpPr/>
           <p:nvPr/>
         </p:nvSpPr>
@@ -4266,7 +4349,7 @@
       </p:sp>
       <p:sp>
         <p:nvSpPr>
-          <p:cNvPr id="19" name="Text 14"/>
+          <p:cNvPr id="21" name="Text 16"/>
           <p:cNvSpPr/>
           <p:nvPr/>
         </p:nvSpPr>
@@ -4305,7 +4388,7 @@
       </p:sp>
       <p:sp>
         <p:nvSpPr>
-          <p:cNvPr id="20" name="Shape 15"/>
+          <p:cNvPr id="22" name="Shape 17"/>
           <p:cNvSpPr/>
           <p:nvPr/>
         </p:nvSpPr>
@@ -4318,11 +4401,15 @@
             <a:avLst/>
           </a:prstGeom>
           <a:solidFill>
-            <a:srgbClr val="152033"/>
+            <a:srgbClr val="FFFFFF">
+              <a:alpha val="12000"/>
+            </a:srgbClr>
           </a:solidFill>
-          <a:ln w="12700">
+          <a:ln w="9525">
             <a:solidFill>
-              <a:srgbClr val="2A4060"/>
+              <a:srgbClr val="5EEAD4">
+                <a:alpha val="30000"/>
+              </a:srgbClr>
             </a:solidFill>
             <a:prstDash val="solid"/>
           </a:ln>
@@ -4337,7 +4424,7 @@
       </p:sp>
       <p:sp>
         <p:nvSpPr>
-          <p:cNvPr id="21" name="Shape 16"/>
+          <p:cNvPr id="23" name="Shape 18"/>
           <p:cNvSpPr/>
           <p:nvPr/>
         </p:nvSpPr>
@@ -4357,7 +4444,7 @@
       </p:sp>
       <p:pic>
         <p:nvPicPr>
-          <p:cNvPr id="22" name="Image 3" descr="preencoded.png">    </p:cNvPr>
+          <p:cNvPr id="24" name="Image 3" descr="preencoded.png">    </p:cNvPr>
           <p:cNvPicPr>
             <a:picLocks noChangeAspect="1"/>
           </p:cNvPicPr>
@@ -4381,7 +4468,7 @@
       </p:pic>
       <p:sp>
         <p:nvSpPr>
-          <p:cNvPr id="23" name="Text 17"/>
+          <p:cNvPr id="25" name="Text 19"/>
           <p:cNvSpPr/>
           <p:nvPr/>
         </p:nvSpPr>
@@ -4420,7 +4507,7 @@
       </p:sp>
       <p:sp>
         <p:nvSpPr>
-          <p:cNvPr id="24" name="Text 18"/>
+          <p:cNvPr id="26" name="Text 20"/>
           <p:cNvSpPr/>
           <p:nvPr/>
         </p:nvSpPr>
@@ -4459,7 +4546,7 @@
       </p:sp>
       <p:sp>
         <p:nvSpPr>
-          <p:cNvPr id="25" name="Text 19"/>
+          <p:cNvPr id="27" name="Text 21"/>
           <p:cNvSpPr/>
           <p:nvPr/>
         </p:nvSpPr>
@@ -4498,7 +4585,7 @@
       </p:sp>
       <p:sp>
         <p:nvSpPr>
-          <p:cNvPr id="26" name="Text 20"/>
+          <p:cNvPr id="28" name="Text 22"/>
           <p:cNvSpPr/>
           <p:nvPr/>
         </p:nvSpPr>
@@ -4575,6 +4662,50 @@
         </p:nvSpPr>
         <p:spPr>
           <a:xfrm>
+            <a:off x="-1645920" y="-2011680"/>
+            <a:ext cx="4754880" cy="4754880"/>
+          </a:xfrm>
+          <a:prstGeom prst="ellipse">
+            <a:avLst/>
+          </a:prstGeom>
+          <a:solidFill>
+            <a:srgbClr val="0D9488">
+              <a:alpha val="12000"/>
+            </a:srgbClr>
+          </a:solidFill>
+          <a:ln/>
+        </p:spPr>
+      </p:sp>
+      <p:sp>
+        <p:nvSpPr>
+          <p:cNvPr id="3" name="Shape 1"/>
+          <p:cNvSpPr/>
+          <p:nvPr/>
+        </p:nvSpPr>
+        <p:spPr>
+          <a:xfrm>
+            <a:off x="9509760" y="3840480"/>
+            <a:ext cx="4206240" cy="4206240"/>
+          </a:xfrm>
+          <a:prstGeom prst="ellipse">
+            <a:avLst/>
+          </a:prstGeom>
+          <a:solidFill>
+            <a:srgbClr val="38BDF8">
+              <a:alpha val="10000"/>
+            </a:srgbClr>
+          </a:solidFill>
+          <a:ln/>
+        </p:spPr>
+      </p:sp>
+      <p:sp>
+        <p:nvSpPr>
+          <p:cNvPr id="4" name="Shape 2"/>
+          <p:cNvSpPr/>
+          <p:nvPr/>
+        </p:nvSpPr>
+        <p:spPr>
+          <a:xfrm>
             <a:off x="0" y="0"/>
             <a:ext cx="12191695" cy="73152"/>
           </a:xfrm>
@@ -4589,7 +4720,7 @@
       </p:sp>
       <p:sp>
         <p:nvSpPr>
-          <p:cNvPr id="3" name="Text 1"/>
+          <p:cNvPr id="5" name="Text 3"/>
           <p:cNvSpPr/>
           <p:nvPr/>
         </p:nvSpPr>
@@ -4628,7 +4759,7 @@
       </p:sp>
       <p:sp>
         <p:nvSpPr>
-          <p:cNvPr id="4" name="Text 2"/>
+          <p:cNvPr id="6" name="Text 4"/>
           <p:cNvSpPr/>
           <p:nvPr/>
         </p:nvSpPr>
@@ -4667,7 +4798,7 @@
       </p:sp>
       <p:sp>
         <p:nvSpPr>
-          <p:cNvPr id="5" name="Shape 3"/>
+          <p:cNvPr id="7" name="Shape 5"/>
           <p:cNvSpPr/>
           <p:nvPr/>
         </p:nvSpPr>
@@ -4687,7 +4818,7 @@
       </p:sp>
       <p:sp>
         <p:nvSpPr>
-          <p:cNvPr id="6" name="Text 4"/>
+          <p:cNvPr id="8" name="Text 6"/>
           <p:cNvSpPr/>
           <p:nvPr/>
         </p:nvSpPr>
@@ -4726,7 +4857,7 @@
       </p:sp>
       <p:sp>
         <p:nvSpPr>
-          <p:cNvPr id="7" name="Shape 5"/>
+          <p:cNvPr id="9" name="Shape 7"/>
           <p:cNvSpPr/>
           <p:nvPr/>
         </p:nvSpPr>
@@ -4739,11 +4870,15 @@
             <a:avLst/>
           </a:prstGeom>
           <a:solidFill>
-            <a:srgbClr val="152033"/>
+            <a:srgbClr val="FFFFFF">
+              <a:alpha val="12000"/>
+            </a:srgbClr>
           </a:solidFill>
-          <a:ln w="12700">
+          <a:ln w="9525">
             <a:solidFill>
-              <a:srgbClr val="2A4060"/>
+              <a:srgbClr val="5EEAD4">
+                <a:alpha val="30000"/>
+              </a:srgbClr>
             </a:solidFill>
             <a:prstDash val="solid"/>
           </a:ln>
@@ -4751,7 +4886,7 @@
       </p:sp>
       <p:sp>
         <p:nvSpPr>
-          <p:cNvPr id="8" name="Text 6"/>
+          <p:cNvPr id="10" name="Text 8"/>
           <p:cNvSpPr/>
           <p:nvPr/>
         </p:nvSpPr>
@@ -4790,7 +4925,7 @@
       </p:sp>
       <p:sp>
         <p:nvSpPr>
-          <p:cNvPr id="9" name="Text 7"/>
+          <p:cNvPr id="11" name="Text 9"/>
           <p:cNvSpPr/>
           <p:nvPr/>
         </p:nvSpPr>
@@ -4829,7 +4964,7 @@
       </p:sp>
       <p:sp>
         <p:nvSpPr>
-          <p:cNvPr id="10" name="Shape 8"/>
+          <p:cNvPr id="12" name="Shape 10"/>
           <p:cNvSpPr/>
           <p:nvPr/>
         </p:nvSpPr>
@@ -4849,7 +4984,7 @@
       </p:sp>
       <p:sp>
         <p:nvSpPr>
-          <p:cNvPr id="11" name="Text 9"/>
+          <p:cNvPr id="13" name="Text 11"/>
           <p:cNvSpPr/>
           <p:nvPr/>
         </p:nvSpPr>
@@ -4888,7 +5023,7 @@
       </p:sp>
       <p:sp>
         <p:nvSpPr>
-          <p:cNvPr id="12" name="Shape 10"/>
+          <p:cNvPr id="14" name="Shape 12"/>
           <p:cNvSpPr/>
           <p:nvPr/>
         </p:nvSpPr>
@@ -4901,11 +5036,15 @@
             <a:avLst/>
           </a:prstGeom>
           <a:solidFill>
-            <a:srgbClr val="152033"/>
+            <a:srgbClr val="FFFFFF">
+              <a:alpha val="12000"/>
+            </a:srgbClr>
           </a:solidFill>
-          <a:ln w="12700">
+          <a:ln w="9525">
             <a:solidFill>
-              <a:srgbClr val="2A4060"/>
+              <a:srgbClr val="5EEAD4">
+                <a:alpha val="30000"/>
+              </a:srgbClr>
             </a:solidFill>
             <a:prstDash val="solid"/>
           </a:ln>
@@ -4913,7 +5052,7 @@
       </p:sp>
       <p:sp>
         <p:nvSpPr>
-          <p:cNvPr id="13" name="Text 11"/>
+          <p:cNvPr id="15" name="Text 13"/>
           <p:cNvSpPr/>
           <p:nvPr/>
         </p:nvSpPr>
@@ -4952,7 +5091,7 @@
       </p:sp>
       <p:sp>
         <p:nvSpPr>
-          <p:cNvPr id="14" name="Text 12"/>
+          <p:cNvPr id="16" name="Text 14"/>
           <p:cNvSpPr/>
           <p:nvPr/>
         </p:nvSpPr>
@@ -4991,7 +5130,7 @@
       </p:sp>
       <p:sp>
         <p:nvSpPr>
-          <p:cNvPr id="15" name="Shape 13"/>
+          <p:cNvPr id="17" name="Shape 15"/>
           <p:cNvSpPr/>
           <p:nvPr/>
         </p:nvSpPr>
@@ -5011,7 +5150,7 @@
       </p:sp>
       <p:sp>
         <p:nvSpPr>
-          <p:cNvPr id="16" name="Text 14"/>
+          <p:cNvPr id="18" name="Text 16"/>
           <p:cNvSpPr/>
           <p:nvPr/>
         </p:nvSpPr>
@@ -5050,7 +5189,7 @@
       </p:sp>
       <p:sp>
         <p:nvSpPr>
-          <p:cNvPr id="17" name="Shape 15"/>
+          <p:cNvPr id="19" name="Shape 17"/>
           <p:cNvSpPr/>
           <p:nvPr/>
         </p:nvSpPr>
@@ -5063,11 +5202,15 @@
             <a:avLst/>
           </a:prstGeom>
           <a:solidFill>
-            <a:srgbClr val="152033"/>
+            <a:srgbClr val="FFFFFF">
+              <a:alpha val="12000"/>
+            </a:srgbClr>
           </a:solidFill>
-          <a:ln w="12700">
+          <a:ln w="9525">
             <a:solidFill>
-              <a:srgbClr val="2A4060"/>
+              <a:srgbClr val="5EEAD4">
+                <a:alpha val="30000"/>
+              </a:srgbClr>
             </a:solidFill>
             <a:prstDash val="solid"/>
           </a:ln>
@@ -5075,7 +5218,7 @@
       </p:sp>
       <p:sp>
         <p:nvSpPr>
-          <p:cNvPr id="18" name="Text 16"/>
+          <p:cNvPr id="20" name="Text 18"/>
           <p:cNvSpPr/>
           <p:nvPr/>
         </p:nvSpPr>
@@ -5114,7 +5257,7 @@
       </p:sp>
       <p:sp>
         <p:nvSpPr>
-          <p:cNvPr id="19" name="Text 17"/>
+          <p:cNvPr id="21" name="Text 19"/>
           <p:cNvSpPr/>
           <p:nvPr/>
         </p:nvSpPr>
@@ -5153,7 +5296,7 @@
       </p:sp>
       <p:sp>
         <p:nvSpPr>
-          <p:cNvPr id="20" name="Shape 18"/>
+          <p:cNvPr id="22" name="Shape 20"/>
           <p:cNvSpPr/>
           <p:nvPr/>
         </p:nvSpPr>
@@ -5173,7 +5316,7 @@
       </p:sp>
       <p:sp>
         <p:nvSpPr>
-          <p:cNvPr id="21" name="Text 19"/>
+          <p:cNvPr id="23" name="Text 21"/>
           <p:cNvSpPr/>
           <p:nvPr/>
         </p:nvSpPr>
@@ -5212,7 +5355,7 @@
       </p:sp>
       <p:sp>
         <p:nvSpPr>
-          <p:cNvPr id="22" name="Shape 20"/>
+          <p:cNvPr id="24" name="Shape 22"/>
           <p:cNvSpPr/>
           <p:nvPr/>
         </p:nvSpPr>
@@ -5225,11 +5368,15 @@
             <a:avLst/>
           </a:prstGeom>
           <a:solidFill>
-            <a:srgbClr val="152033"/>
+            <a:srgbClr val="FFFFFF">
+              <a:alpha val="12000"/>
+            </a:srgbClr>
           </a:solidFill>
-          <a:ln w="12700">
+          <a:ln w="9525">
             <a:solidFill>
-              <a:srgbClr val="2A4060"/>
+              <a:srgbClr val="5EEAD4">
+                <a:alpha val="30000"/>
+              </a:srgbClr>
             </a:solidFill>
             <a:prstDash val="solid"/>
           </a:ln>
@@ -5237,7 +5384,7 @@
       </p:sp>
       <p:sp>
         <p:nvSpPr>
-          <p:cNvPr id="23" name="Text 21"/>
+          <p:cNvPr id="25" name="Text 23"/>
           <p:cNvSpPr/>
           <p:nvPr/>
         </p:nvSpPr>
@@ -5276,7 +5423,7 @@
       </p:sp>
       <p:sp>
         <p:nvSpPr>
-          <p:cNvPr id="24" name="Text 22"/>
+          <p:cNvPr id="26" name="Text 24"/>
           <p:cNvSpPr/>
           <p:nvPr/>
         </p:nvSpPr>
@@ -5315,7 +5462,7 @@
       </p:sp>
       <p:sp>
         <p:nvSpPr>
-          <p:cNvPr id="25" name="Text 23"/>
+          <p:cNvPr id="27" name="Text 25"/>
           <p:cNvSpPr/>
           <p:nvPr/>
         </p:nvSpPr>
@@ -5354,7 +5501,7 @@
       </p:sp>
       <p:sp>
         <p:nvSpPr>
-          <p:cNvPr id="26" name="Text 24"/>
+          <p:cNvPr id="28" name="Text 26"/>
           <p:cNvSpPr/>
           <p:nvPr/>
         </p:nvSpPr>
@@ -5945,9 +6092,18 @@
             <a:avLst/>
           </a:prstGeom>
           <a:solidFill>
-            <a:srgbClr val="101827"/>
+            <a:srgbClr val="FFFFFF">
+              <a:alpha val="12000"/>
+            </a:srgbClr>
           </a:solidFill>
-          <a:ln/>
+          <a:ln w="9525">
+            <a:solidFill>
+              <a:srgbClr val="5EEAD4">
+                <a:alpha val="30000"/>
+              </a:srgbClr>
+            </a:solidFill>
+            <a:prstDash val="solid"/>
+          </a:ln>
         </p:spPr>
       </p:sp>
       <p:sp>
@@ -6080,9 +6236,18 @@
             <a:avLst/>
           </a:prstGeom>
           <a:solidFill>
-            <a:srgbClr val="101827"/>
+            <a:srgbClr val="FFFFFF">
+              <a:alpha val="12000"/>
+            </a:srgbClr>
           </a:solidFill>
-          <a:ln/>
+          <a:ln w="9525">
+            <a:solidFill>
+              <a:srgbClr val="5EEAD4">
+                <a:alpha val="30000"/>
+              </a:srgbClr>
+            </a:solidFill>
+            <a:prstDash val="solid"/>
+          </a:ln>
         </p:spPr>
       </p:sp>
       <p:sp>
@@ -6215,9 +6380,18 @@
             <a:avLst/>
           </a:prstGeom>
           <a:solidFill>
-            <a:srgbClr val="101827"/>
+            <a:srgbClr val="FFFFFF">
+              <a:alpha val="12000"/>
+            </a:srgbClr>
           </a:solidFill>
-          <a:ln/>
+          <a:ln w="9525">
+            <a:solidFill>
+              <a:srgbClr val="5EEAD4">
+                <a:alpha val="30000"/>
+              </a:srgbClr>
+            </a:solidFill>
+            <a:prstDash val="solid"/>
+          </a:ln>
         </p:spPr>
       </p:sp>
       <p:sp>
@@ -6453,6 +6627,50 @@
         </p:nvSpPr>
         <p:spPr>
           <a:xfrm>
+            <a:off x="-1645920" y="-2011680"/>
+            <a:ext cx="4754880" cy="4754880"/>
+          </a:xfrm>
+          <a:prstGeom prst="ellipse">
+            <a:avLst/>
+          </a:prstGeom>
+          <a:solidFill>
+            <a:srgbClr val="0D9488">
+              <a:alpha val="12000"/>
+            </a:srgbClr>
+          </a:solidFill>
+          <a:ln/>
+        </p:spPr>
+      </p:sp>
+      <p:sp>
+        <p:nvSpPr>
+          <p:cNvPr id="3" name="Shape 1"/>
+          <p:cNvSpPr/>
+          <p:nvPr/>
+        </p:nvSpPr>
+        <p:spPr>
+          <a:xfrm>
+            <a:off x="9509760" y="3840480"/>
+            <a:ext cx="4206240" cy="4206240"/>
+          </a:xfrm>
+          <a:prstGeom prst="ellipse">
+            <a:avLst/>
+          </a:prstGeom>
+          <a:solidFill>
+            <a:srgbClr val="38BDF8">
+              <a:alpha val="10000"/>
+            </a:srgbClr>
+          </a:solidFill>
+          <a:ln/>
+        </p:spPr>
+      </p:sp>
+      <p:sp>
+        <p:nvSpPr>
+          <p:cNvPr id="4" name="Shape 2"/>
+          <p:cNvSpPr/>
+          <p:nvPr/>
+        </p:nvSpPr>
+        <p:spPr>
+          <a:xfrm>
             <a:off x="0" y="0"/>
             <a:ext cx="12191695" cy="73152"/>
           </a:xfrm>
@@ -6467,7 +6685,7 @@
       </p:sp>
       <p:sp>
         <p:nvSpPr>
-          <p:cNvPr id="3" name="Text 1"/>
+          <p:cNvPr id="5" name="Text 3"/>
           <p:cNvSpPr/>
           <p:nvPr/>
         </p:nvSpPr>
@@ -6506,7 +6724,7 @@
       </p:sp>
       <p:sp>
         <p:nvSpPr>
-          <p:cNvPr id="4" name="Text 2"/>
+          <p:cNvPr id="6" name="Text 4"/>
           <p:cNvSpPr/>
           <p:nvPr/>
         </p:nvSpPr>
@@ -6545,7 +6763,7 @@
       </p:sp>
       <p:sp>
         <p:nvSpPr>
-          <p:cNvPr id="5" name="Text 3"/>
+          <p:cNvPr id="7" name="Text 5"/>
           <p:cNvSpPr/>
           <p:nvPr/>
         </p:nvSpPr>
@@ -6584,7 +6802,7 @@
       </p:sp>
       <p:sp>
         <p:nvSpPr>
-          <p:cNvPr id="6" name="Shape 4"/>
+          <p:cNvPr id="8" name="Shape 6"/>
           <p:cNvSpPr/>
           <p:nvPr/>
         </p:nvSpPr>
@@ -6597,11 +6815,15 @@
             <a:avLst/>
           </a:prstGeom>
           <a:solidFill>
-            <a:srgbClr val="152033"/>
+            <a:srgbClr val="FFFFFF">
+              <a:alpha val="12000"/>
+            </a:srgbClr>
           </a:solidFill>
-          <a:ln w="12700">
+          <a:ln w="9525">
             <a:solidFill>
-              <a:srgbClr val="2A4060"/>
+              <a:srgbClr val="5EEAD4">
+                <a:alpha val="30000"/>
+              </a:srgbClr>
             </a:solidFill>
             <a:prstDash val="solid"/>
           </a:ln>
@@ -6616,7 +6838,7 @@
       </p:sp>
       <p:pic>
         <p:nvPicPr>
-          <p:cNvPr id="7" name="Image 0" descr="preencoded.png">    </p:cNvPr>
+          <p:cNvPr id="9" name="Image 0" descr="preencoded.png">    </p:cNvPr>
           <p:cNvPicPr>
             <a:picLocks noChangeAspect="1"/>
           </p:cNvPicPr>
@@ -6640,7 +6862,7 @@
       </p:pic>
       <p:sp>
         <p:nvSpPr>
-          <p:cNvPr id="8" name="Text 5"/>
+          <p:cNvPr id="10" name="Text 7"/>
           <p:cNvSpPr/>
           <p:nvPr/>
         </p:nvSpPr>
@@ -6679,7 +6901,7 @@
       </p:sp>
       <p:sp>
         <p:nvSpPr>
-          <p:cNvPr id="9" name="Text 6"/>
+          <p:cNvPr id="11" name="Text 8"/>
           <p:cNvSpPr/>
           <p:nvPr/>
         </p:nvSpPr>
@@ -6718,7 +6940,7 @@
       </p:sp>
       <p:sp>
         <p:nvSpPr>
-          <p:cNvPr id="10" name="Shape 7"/>
+          <p:cNvPr id="12" name="Shape 9"/>
           <p:cNvSpPr/>
           <p:nvPr/>
         </p:nvSpPr>
@@ -6731,11 +6953,15 @@
             <a:avLst/>
           </a:prstGeom>
           <a:solidFill>
-            <a:srgbClr val="152033"/>
+            <a:srgbClr val="FFFFFF">
+              <a:alpha val="12000"/>
+            </a:srgbClr>
           </a:solidFill>
-          <a:ln w="12700">
+          <a:ln w="9525">
             <a:solidFill>
-              <a:srgbClr val="2A4060"/>
+              <a:srgbClr val="5EEAD4">
+                <a:alpha val="30000"/>
+              </a:srgbClr>
             </a:solidFill>
             <a:prstDash val="solid"/>
           </a:ln>
@@ -6750,7 +6976,7 @@
       </p:sp>
       <p:pic>
         <p:nvPicPr>
-          <p:cNvPr id="11" name="Image 1" descr="preencoded.png">    </p:cNvPr>
+          <p:cNvPr id="13" name="Image 1" descr="preencoded.png">    </p:cNvPr>
           <p:cNvPicPr>
             <a:picLocks noChangeAspect="1"/>
           </p:cNvPicPr>
@@ -6774,7 +7000,7 @@
       </p:pic>
       <p:sp>
         <p:nvSpPr>
-          <p:cNvPr id="12" name="Text 8"/>
+          <p:cNvPr id="14" name="Text 10"/>
           <p:cNvSpPr/>
           <p:nvPr/>
         </p:nvSpPr>
@@ -6813,7 +7039,7 @@
       </p:sp>
       <p:sp>
         <p:nvSpPr>
-          <p:cNvPr id="13" name="Text 9"/>
+          <p:cNvPr id="15" name="Text 11"/>
           <p:cNvSpPr/>
           <p:nvPr/>
         </p:nvSpPr>
@@ -6852,7 +7078,7 @@
       </p:sp>
       <p:sp>
         <p:nvSpPr>
-          <p:cNvPr id="14" name="Shape 10"/>
+          <p:cNvPr id="16" name="Shape 12"/>
           <p:cNvSpPr/>
           <p:nvPr/>
         </p:nvSpPr>
@@ -6865,11 +7091,15 @@
             <a:avLst/>
           </a:prstGeom>
           <a:solidFill>
-            <a:srgbClr val="152033"/>
+            <a:srgbClr val="FFFFFF">
+              <a:alpha val="12000"/>
+            </a:srgbClr>
           </a:solidFill>
-          <a:ln w="12700">
+          <a:ln w="9525">
             <a:solidFill>
-              <a:srgbClr val="2A4060"/>
+              <a:srgbClr val="5EEAD4">
+                <a:alpha val="30000"/>
+              </a:srgbClr>
             </a:solidFill>
             <a:prstDash val="solid"/>
           </a:ln>
@@ -6884,7 +7114,7 @@
       </p:sp>
       <p:pic>
         <p:nvPicPr>
-          <p:cNvPr id="15" name="Image 2" descr="preencoded.png">    </p:cNvPr>
+          <p:cNvPr id="17" name="Image 2" descr="preencoded.png">    </p:cNvPr>
           <p:cNvPicPr>
             <a:picLocks noChangeAspect="1"/>
           </p:cNvPicPr>
@@ -6908,7 +7138,7 @@
       </p:pic>
       <p:sp>
         <p:nvSpPr>
-          <p:cNvPr id="16" name="Text 11"/>
+          <p:cNvPr id="18" name="Text 13"/>
           <p:cNvSpPr/>
           <p:nvPr/>
         </p:nvSpPr>
@@ -6947,7 +7177,7 @@
       </p:sp>
       <p:sp>
         <p:nvSpPr>
-          <p:cNvPr id="17" name="Text 12"/>
+          <p:cNvPr id="19" name="Text 14"/>
           <p:cNvSpPr/>
           <p:nvPr/>
         </p:nvSpPr>
@@ -6986,7 +7216,7 @@
       </p:sp>
       <p:sp>
         <p:nvSpPr>
-          <p:cNvPr id="18" name="Shape 13"/>
+          <p:cNvPr id="20" name="Shape 15"/>
           <p:cNvSpPr/>
           <p:nvPr/>
         </p:nvSpPr>
@@ -6999,11 +7229,15 @@
             <a:avLst/>
           </a:prstGeom>
           <a:solidFill>
-            <a:srgbClr val="152033"/>
+            <a:srgbClr val="FFFFFF">
+              <a:alpha val="12000"/>
+            </a:srgbClr>
           </a:solidFill>
-          <a:ln w="12700">
+          <a:ln w="9525">
             <a:solidFill>
-              <a:srgbClr val="2A4060"/>
+              <a:srgbClr val="5EEAD4">
+                <a:alpha val="30000"/>
+              </a:srgbClr>
             </a:solidFill>
             <a:prstDash val="solid"/>
           </a:ln>
@@ -7018,7 +7252,7 @@
       </p:sp>
       <p:pic>
         <p:nvPicPr>
-          <p:cNvPr id="19" name="Image 3" descr="preencoded.png">    </p:cNvPr>
+          <p:cNvPr id="21" name="Image 3" descr="preencoded.png">    </p:cNvPr>
           <p:cNvPicPr>
             <a:picLocks noChangeAspect="1"/>
           </p:cNvPicPr>
@@ -7042,7 +7276,7 @@
       </p:pic>
       <p:sp>
         <p:nvSpPr>
-          <p:cNvPr id="20" name="Text 14"/>
+          <p:cNvPr id="22" name="Text 16"/>
           <p:cNvSpPr/>
           <p:nvPr/>
         </p:nvSpPr>
@@ -7081,7 +7315,7 @@
       </p:sp>
       <p:sp>
         <p:nvSpPr>
-          <p:cNvPr id="21" name="Text 15"/>
+          <p:cNvPr id="23" name="Text 17"/>
           <p:cNvSpPr/>
           <p:nvPr/>
         </p:nvSpPr>
@@ -7120,7 +7354,7 @@
       </p:sp>
       <p:sp>
         <p:nvSpPr>
-          <p:cNvPr id="22" name="Text 16"/>
+          <p:cNvPr id="24" name="Text 18"/>
           <p:cNvSpPr/>
           <p:nvPr/>
         </p:nvSpPr>
@@ -7159,7 +7393,7 @@
       </p:sp>
       <p:graphicFrame>
         <p:nvGraphicFramePr>
-          <p:cNvPr id="23" name="Chart 0" descr=""/>
+          <p:cNvPr id="25" name="Chart 0" descr=""/>
           <p:cNvGraphicFramePr/>
           <p:nvPr/>
         </p:nvGraphicFramePr>
@@ -7175,7 +7409,7 @@
       </p:graphicFrame>
       <p:sp>
         <p:nvSpPr>
-          <p:cNvPr id="24" name="Text 17"/>
+          <p:cNvPr id="26" name="Text 19"/>
           <p:cNvSpPr/>
           <p:nvPr/>
         </p:nvSpPr>
@@ -7214,7 +7448,7 @@
       </p:sp>
       <p:sp>
         <p:nvSpPr>
-          <p:cNvPr id="25" name="Text 18"/>
+          <p:cNvPr id="27" name="Text 20"/>
           <p:cNvSpPr/>
           <p:nvPr/>
         </p:nvSpPr>
@@ -7291,6 +7525,50 @@
         </p:nvSpPr>
         <p:spPr>
           <a:xfrm>
+            <a:off x="-1645920" y="-2011680"/>
+            <a:ext cx="4754880" cy="4754880"/>
+          </a:xfrm>
+          <a:prstGeom prst="ellipse">
+            <a:avLst/>
+          </a:prstGeom>
+          <a:solidFill>
+            <a:srgbClr val="0D9488">
+              <a:alpha val="12000"/>
+            </a:srgbClr>
+          </a:solidFill>
+          <a:ln/>
+        </p:spPr>
+      </p:sp>
+      <p:sp>
+        <p:nvSpPr>
+          <p:cNvPr id="3" name="Shape 1"/>
+          <p:cNvSpPr/>
+          <p:nvPr/>
+        </p:nvSpPr>
+        <p:spPr>
+          <a:xfrm>
+            <a:off x="9509760" y="3840480"/>
+            <a:ext cx="4206240" cy="4206240"/>
+          </a:xfrm>
+          <a:prstGeom prst="ellipse">
+            <a:avLst/>
+          </a:prstGeom>
+          <a:solidFill>
+            <a:srgbClr val="38BDF8">
+              <a:alpha val="10000"/>
+            </a:srgbClr>
+          </a:solidFill>
+          <a:ln/>
+        </p:spPr>
+      </p:sp>
+      <p:sp>
+        <p:nvSpPr>
+          <p:cNvPr id="4" name="Shape 2"/>
+          <p:cNvSpPr/>
+          <p:nvPr/>
+        </p:nvSpPr>
+        <p:spPr>
+          <a:xfrm>
             <a:off x="0" y="0"/>
             <a:ext cx="12191695" cy="73152"/>
           </a:xfrm>
@@ -7305,7 +7583,7 @@
       </p:sp>
       <p:sp>
         <p:nvSpPr>
-          <p:cNvPr id="3" name="Text 1"/>
+          <p:cNvPr id="5" name="Text 3"/>
           <p:cNvSpPr/>
           <p:nvPr/>
         </p:nvSpPr>
@@ -7344,7 +7622,7 @@
       </p:sp>
       <p:sp>
         <p:nvSpPr>
-          <p:cNvPr id="4" name="Text 2"/>
+          <p:cNvPr id="6" name="Text 4"/>
           <p:cNvSpPr/>
           <p:nvPr/>
         </p:nvSpPr>
@@ -7383,7 +7661,7 @@
       </p:sp>
       <p:sp>
         <p:nvSpPr>
-          <p:cNvPr id="5" name="Shape 3"/>
+          <p:cNvPr id="7" name="Shape 5"/>
           <p:cNvSpPr/>
           <p:nvPr/>
         </p:nvSpPr>
@@ -7396,11 +7674,15 @@
             <a:avLst/>
           </a:prstGeom>
           <a:solidFill>
-            <a:srgbClr val="152033"/>
+            <a:srgbClr val="FFFFFF">
+              <a:alpha val="12000"/>
+            </a:srgbClr>
           </a:solidFill>
-          <a:ln w="12700">
+          <a:ln w="9525">
             <a:solidFill>
-              <a:srgbClr val="2A4060"/>
+              <a:srgbClr val="5EEAD4">
+                <a:alpha val="30000"/>
+              </a:srgbClr>
             </a:solidFill>
             <a:prstDash val="solid"/>
           </a:ln>
@@ -7415,7 +7697,7 @@
       </p:sp>
       <p:sp>
         <p:nvSpPr>
-          <p:cNvPr id="6" name="Shape 4"/>
+          <p:cNvPr id="8" name="Shape 6"/>
           <p:cNvSpPr/>
           <p:nvPr/>
         </p:nvSpPr>
@@ -7435,7 +7717,7 @@
       </p:sp>
       <p:sp>
         <p:nvSpPr>
-          <p:cNvPr id="7" name="Text 5"/>
+          <p:cNvPr id="9" name="Text 7"/>
           <p:cNvSpPr/>
           <p:nvPr/>
         </p:nvSpPr>
@@ -7474,7 +7756,7 @@
       </p:sp>
       <p:sp>
         <p:nvSpPr>
-          <p:cNvPr id="8" name="Text 6"/>
+          <p:cNvPr id="10" name="Text 8"/>
           <p:cNvSpPr/>
           <p:nvPr/>
         </p:nvSpPr>
@@ -7513,7 +7795,7 @@
       </p:sp>
       <p:sp>
         <p:nvSpPr>
-          <p:cNvPr id="9" name="Text 7"/>
+          <p:cNvPr id="11" name="Text 9"/>
           <p:cNvSpPr/>
           <p:nvPr/>
         </p:nvSpPr>
@@ -7552,7 +7834,7 @@
       </p:sp>
       <p:sp>
         <p:nvSpPr>
-          <p:cNvPr id="10" name="Shape 8"/>
+          <p:cNvPr id="12" name="Shape 10"/>
           <p:cNvSpPr/>
           <p:nvPr/>
         </p:nvSpPr>
@@ -7565,11 +7847,15 @@
             <a:avLst/>
           </a:prstGeom>
           <a:solidFill>
-            <a:srgbClr val="152033"/>
+            <a:srgbClr val="FFFFFF">
+              <a:alpha val="12000"/>
+            </a:srgbClr>
           </a:solidFill>
-          <a:ln w="12700">
+          <a:ln w="9525">
             <a:solidFill>
-              <a:srgbClr val="2A4060"/>
+              <a:srgbClr val="5EEAD4">
+                <a:alpha val="30000"/>
+              </a:srgbClr>
             </a:solidFill>
             <a:prstDash val="solid"/>
           </a:ln>
@@ -7584,7 +7870,7 @@
       </p:sp>
       <p:sp>
         <p:nvSpPr>
-          <p:cNvPr id="11" name="Shape 9"/>
+          <p:cNvPr id="13" name="Shape 11"/>
           <p:cNvSpPr/>
           <p:nvPr/>
         </p:nvSpPr>
@@ -7604,7 +7890,7 @@
       </p:sp>
       <p:sp>
         <p:nvSpPr>
-          <p:cNvPr id="12" name="Text 10"/>
+          <p:cNvPr id="14" name="Text 12"/>
           <p:cNvSpPr/>
           <p:nvPr/>
         </p:nvSpPr>
@@ -7643,7 +7929,7 @@
       </p:sp>
       <p:sp>
         <p:nvSpPr>
-          <p:cNvPr id="13" name="Text 11"/>
+          <p:cNvPr id="15" name="Text 13"/>
           <p:cNvSpPr/>
           <p:nvPr/>
         </p:nvSpPr>
@@ -7682,7 +7968,7 @@
       </p:sp>
       <p:sp>
         <p:nvSpPr>
-          <p:cNvPr id="14" name="Text 12"/>
+          <p:cNvPr id="16" name="Text 14"/>
           <p:cNvSpPr/>
           <p:nvPr/>
         </p:nvSpPr>
@@ -7721,7 +8007,7 @@
       </p:sp>
       <p:sp>
         <p:nvSpPr>
-          <p:cNvPr id="15" name="Shape 13"/>
+          <p:cNvPr id="17" name="Shape 15"/>
           <p:cNvSpPr/>
           <p:nvPr/>
         </p:nvSpPr>
@@ -7734,11 +8020,15 @@
             <a:avLst/>
           </a:prstGeom>
           <a:solidFill>
-            <a:srgbClr val="152033"/>
+            <a:srgbClr val="FFFFFF">
+              <a:alpha val="12000"/>
+            </a:srgbClr>
           </a:solidFill>
-          <a:ln w="12700">
+          <a:ln w="9525">
             <a:solidFill>
-              <a:srgbClr val="2A4060"/>
+              <a:srgbClr val="5EEAD4">
+                <a:alpha val="30000"/>
+              </a:srgbClr>
             </a:solidFill>
             <a:prstDash val="solid"/>
           </a:ln>
@@ -7753,7 +8043,7 @@
       </p:sp>
       <p:sp>
         <p:nvSpPr>
-          <p:cNvPr id="16" name="Shape 14"/>
+          <p:cNvPr id="18" name="Shape 16"/>
           <p:cNvSpPr/>
           <p:nvPr/>
         </p:nvSpPr>
@@ -7773,7 +8063,7 @@
       </p:sp>
       <p:sp>
         <p:nvSpPr>
-          <p:cNvPr id="17" name="Text 15"/>
+          <p:cNvPr id="19" name="Text 17"/>
           <p:cNvSpPr/>
           <p:nvPr/>
         </p:nvSpPr>
@@ -7812,7 +8102,7 @@
       </p:sp>
       <p:sp>
         <p:nvSpPr>
-          <p:cNvPr id="18" name="Text 16"/>
+          <p:cNvPr id="20" name="Text 18"/>
           <p:cNvSpPr/>
           <p:nvPr/>
         </p:nvSpPr>
@@ -7851,7 +8141,7 @@
       </p:sp>
       <p:sp>
         <p:nvSpPr>
-          <p:cNvPr id="19" name="Text 17"/>
+          <p:cNvPr id="21" name="Text 19"/>
           <p:cNvSpPr/>
           <p:nvPr/>
         </p:nvSpPr>
@@ -7890,7 +8180,7 @@
       </p:sp>
       <p:sp>
         <p:nvSpPr>
-          <p:cNvPr id="20" name="Shape 18"/>
+          <p:cNvPr id="22" name="Shape 20"/>
           <p:cNvSpPr/>
           <p:nvPr/>
         </p:nvSpPr>
@@ -7903,11 +8193,15 @@
             <a:avLst/>
           </a:prstGeom>
           <a:solidFill>
-            <a:srgbClr val="152033"/>
+            <a:srgbClr val="FFFFFF">
+              <a:alpha val="12000"/>
+            </a:srgbClr>
           </a:solidFill>
-          <a:ln w="12700">
+          <a:ln w="9525">
             <a:solidFill>
-              <a:srgbClr val="2A4060"/>
+              <a:srgbClr val="5EEAD4">
+                <a:alpha val="30000"/>
+              </a:srgbClr>
             </a:solidFill>
             <a:prstDash val="solid"/>
           </a:ln>
@@ -7922,7 +8216,7 @@
       </p:sp>
       <p:sp>
         <p:nvSpPr>
-          <p:cNvPr id="21" name="Shape 19"/>
+          <p:cNvPr id="23" name="Shape 21"/>
           <p:cNvSpPr/>
           <p:nvPr/>
         </p:nvSpPr>
@@ -7942,7 +8236,7 @@
       </p:sp>
       <p:sp>
         <p:nvSpPr>
-          <p:cNvPr id="22" name="Text 20"/>
+          <p:cNvPr id="24" name="Text 22"/>
           <p:cNvSpPr/>
           <p:nvPr/>
         </p:nvSpPr>
@@ -7981,7 +8275,7 @@
       </p:sp>
       <p:sp>
         <p:nvSpPr>
-          <p:cNvPr id="23" name="Text 21"/>
+          <p:cNvPr id="25" name="Text 23"/>
           <p:cNvSpPr/>
           <p:nvPr/>
         </p:nvSpPr>
@@ -8020,7 +8314,7 @@
       </p:sp>
       <p:sp>
         <p:nvSpPr>
-          <p:cNvPr id="24" name="Text 22"/>
+          <p:cNvPr id="26" name="Text 24"/>
           <p:cNvSpPr/>
           <p:nvPr/>
         </p:nvSpPr>
@@ -8059,7 +8353,7 @@
       </p:sp>
       <p:sp>
         <p:nvSpPr>
-          <p:cNvPr id="25" name="Text 23"/>
+          <p:cNvPr id="27" name="Text 25"/>
           <p:cNvSpPr/>
           <p:nvPr/>
         </p:nvSpPr>
@@ -8098,7 +8392,7 @@
       </p:sp>
       <p:sp>
         <p:nvSpPr>
-          <p:cNvPr id="26" name="Text 24"/>
+          <p:cNvPr id="28" name="Text 26"/>
           <p:cNvSpPr/>
           <p:nvPr/>
         </p:nvSpPr>
@@ -8175,6 +8469,50 @@
         </p:nvSpPr>
         <p:spPr>
           <a:xfrm>
+            <a:off x="-1645920" y="-2011680"/>
+            <a:ext cx="4754880" cy="4754880"/>
+          </a:xfrm>
+          <a:prstGeom prst="ellipse">
+            <a:avLst/>
+          </a:prstGeom>
+          <a:solidFill>
+            <a:srgbClr val="0D9488">
+              <a:alpha val="12000"/>
+            </a:srgbClr>
+          </a:solidFill>
+          <a:ln/>
+        </p:spPr>
+      </p:sp>
+      <p:sp>
+        <p:nvSpPr>
+          <p:cNvPr id="3" name="Shape 1"/>
+          <p:cNvSpPr/>
+          <p:nvPr/>
+        </p:nvSpPr>
+        <p:spPr>
+          <a:xfrm>
+            <a:off x="9509760" y="3840480"/>
+            <a:ext cx="4206240" cy="4206240"/>
+          </a:xfrm>
+          <a:prstGeom prst="ellipse">
+            <a:avLst/>
+          </a:prstGeom>
+          <a:solidFill>
+            <a:srgbClr val="38BDF8">
+              <a:alpha val="10000"/>
+            </a:srgbClr>
+          </a:solidFill>
+          <a:ln/>
+        </p:spPr>
+      </p:sp>
+      <p:sp>
+        <p:nvSpPr>
+          <p:cNvPr id="4" name="Shape 2"/>
+          <p:cNvSpPr/>
+          <p:nvPr/>
+        </p:nvSpPr>
+        <p:spPr>
+          <a:xfrm>
             <a:off x="0" y="0"/>
             <a:ext cx="12191695" cy="73152"/>
           </a:xfrm>
@@ -8189,7 +8527,7 @@
       </p:sp>
       <p:sp>
         <p:nvSpPr>
-          <p:cNvPr id="3" name="Text 1"/>
+          <p:cNvPr id="5" name="Text 3"/>
           <p:cNvSpPr/>
           <p:nvPr/>
         </p:nvSpPr>
@@ -8228,7 +8566,7 @@
       </p:sp>
       <p:sp>
         <p:nvSpPr>
-          <p:cNvPr id="4" name="Text 2"/>
+          <p:cNvPr id="6" name="Text 4"/>
           <p:cNvSpPr/>
           <p:nvPr/>
         </p:nvSpPr>
@@ -8267,7 +8605,7 @@
       </p:sp>
       <p:sp>
         <p:nvSpPr>
-          <p:cNvPr id="5" name="Shape 3"/>
+          <p:cNvPr id="7" name="Shape 5"/>
           <p:cNvSpPr/>
           <p:nvPr/>
         </p:nvSpPr>
@@ -8287,7 +8625,7 @@
       </p:sp>
       <p:sp>
         <p:nvSpPr>
-          <p:cNvPr id="6" name="Text 4"/>
+          <p:cNvPr id="8" name="Text 6"/>
           <p:cNvSpPr/>
           <p:nvPr/>
         </p:nvSpPr>
@@ -8326,7 +8664,7 @@
       </p:sp>
       <p:sp>
         <p:nvSpPr>
-          <p:cNvPr id="7" name="Shape 5"/>
+          <p:cNvPr id="9" name="Shape 7"/>
           <p:cNvSpPr/>
           <p:nvPr/>
         </p:nvSpPr>
@@ -8346,7 +8684,7 @@
       </p:sp>
       <p:sp>
         <p:nvSpPr>
-          <p:cNvPr id="8" name="Shape 6"/>
+          <p:cNvPr id="10" name="Shape 8"/>
           <p:cNvSpPr/>
           <p:nvPr/>
         </p:nvSpPr>
@@ -8359,11 +8697,15 @@
             <a:avLst/>
           </a:prstGeom>
           <a:solidFill>
-            <a:srgbClr val="152033"/>
+            <a:srgbClr val="FFFFFF">
+              <a:alpha val="12000"/>
+            </a:srgbClr>
           </a:solidFill>
-          <a:ln w="12700">
+          <a:ln w="9525">
             <a:solidFill>
-              <a:srgbClr val="2A4060"/>
+              <a:srgbClr val="5EEAD4">
+                <a:alpha val="30000"/>
+              </a:srgbClr>
             </a:solidFill>
             <a:prstDash val="solid"/>
           </a:ln>
@@ -8378,7 +8720,7 @@
       </p:sp>
       <p:sp>
         <p:nvSpPr>
-          <p:cNvPr id="9" name="Text 7"/>
+          <p:cNvPr id="11" name="Text 9"/>
           <p:cNvSpPr/>
           <p:nvPr/>
         </p:nvSpPr>
@@ -8417,7 +8759,7 @@
       </p:sp>
       <p:sp>
         <p:nvSpPr>
-          <p:cNvPr id="10" name="Text 8"/>
+          <p:cNvPr id="12" name="Text 10"/>
           <p:cNvSpPr/>
           <p:nvPr/>
         </p:nvSpPr>
@@ -8456,7 +8798,7 @@
       </p:sp>
       <p:sp>
         <p:nvSpPr>
-          <p:cNvPr id="11" name="Shape 9"/>
+          <p:cNvPr id="13" name="Shape 11"/>
           <p:cNvSpPr/>
           <p:nvPr/>
         </p:nvSpPr>
@@ -8476,7 +8818,7 @@
       </p:sp>
       <p:sp>
         <p:nvSpPr>
-          <p:cNvPr id="12" name="Text 10"/>
+          <p:cNvPr id="14" name="Text 12"/>
           <p:cNvSpPr/>
           <p:nvPr/>
         </p:nvSpPr>
@@ -8515,7 +8857,7 @@
       </p:sp>
       <p:sp>
         <p:nvSpPr>
-          <p:cNvPr id="13" name="Shape 11"/>
+          <p:cNvPr id="15" name="Shape 13"/>
           <p:cNvSpPr/>
           <p:nvPr/>
         </p:nvSpPr>
@@ -8535,7 +8877,7 @@
       </p:sp>
       <p:sp>
         <p:nvSpPr>
-          <p:cNvPr id="14" name="Shape 12"/>
+          <p:cNvPr id="16" name="Shape 14"/>
           <p:cNvSpPr/>
           <p:nvPr/>
         </p:nvSpPr>
@@ -8548,11 +8890,15 @@
             <a:avLst/>
           </a:prstGeom>
           <a:solidFill>
-            <a:srgbClr val="152033"/>
+            <a:srgbClr val="FFFFFF">
+              <a:alpha val="12000"/>
+            </a:srgbClr>
           </a:solidFill>
-          <a:ln w="12700">
+          <a:ln w="9525">
             <a:solidFill>
-              <a:srgbClr val="2A4060"/>
+              <a:srgbClr val="5EEAD4">
+                <a:alpha val="30000"/>
+              </a:srgbClr>
             </a:solidFill>
             <a:prstDash val="solid"/>
           </a:ln>
@@ -8567,7 +8913,7 @@
       </p:sp>
       <p:sp>
         <p:nvSpPr>
-          <p:cNvPr id="15" name="Text 13"/>
+          <p:cNvPr id="17" name="Text 15"/>
           <p:cNvSpPr/>
           <p:nvPr/>
         </p:nvSpPr>
@@ -8606,7 +8952,7 @@
       </p:sp>
       <p:sp>
         <p:nvSpPr>
-          <p:cNvPr id="16" name="Text 14"/>
+          <p:cNvPr id="18" name="Text 16"/>
           <p:cNvSpPr/>
           <p:nvPr/>
         </p:nvSpPr>
@@ -8645,7 +8991,7 @@
       </p:sp>
       <p:sp>
         <p:nvSpPr>
-          <p:cNvPr id="17" name="Shape 15"/>
+          <p:cNvPr id="19" name="Shape 17"/>
           <p:cNvSpPr/>
           <p:nvPr/>
         </p:nvSpPr>
@@ -8665,7 +9011,7 @@
       </p:sp>
       <p:sp>
         <p:nvSpPr>
-          <p:cNvPr id="18" name="Text 16"/>
+          <p:cNvPr id="20" name="Text 18"/>
           <p:cNvSpPr/>
           <p:nvPr/>
         </p:nvSpPr>
@@ -8704,7 +9050,7 @@
       </p:sp>
       <p:sp>
         <p:nvSpPr>
-          <p:cNvPr id="19" name="Shape 17"/>
+          <p:cNvPr id="21" name="Shape 19"/>
           <p:cNvSpPr/>
           <p:nvPr/>
         </p:nvSpPr>
@@ -8724,7 +9070,7 @@
       </p:sp>
       <p:sp>
         <p:nvSpPr>
-          <p:cNvPr id="20" name="Shape 18"/>
+          <p:cNvPr id="22" name="Shape 20"/>
           <p:cNvSpPr/>
           <p:nvPr/>
         </p:nvSpPr>
@@ -8737,11 +9083,15 @@
             <a:avLst/>
           </a:prstGeom>
           <a:solidFill>
-            <a:srgbClr val="152033"/>
+            <a:srgbClr val="FFFFFF">
+              <a:alpha val="12000"/>
+            </a:srgbClr>
           </a:solidFill>
-          <a:ln w="12700">
+          <a:ln w="9525">
             <a:solidFill>
-              <a:srgbClr val="2A4060"/>
+              <a:srgbClr val="5EEAD4">
+                <a:alpha val="30000"/>
+              </a:srgbClr>
             </a:solidFill>
             <a:prstDash val="solid"/>
           </a:ln>
@@ -8756,7 +9106,7 @@
       </p:sp>
       <p:sp>
         <p:nvSpPr>
-          <p:cNvPr id="21" name="Text 19"/>
+          <p:cNvPr id="23" name="Text 21"/>
           <p:cNvSpPr/>
           <p:nvPr/>
         </p:nvSpPr>
@@ -8795,7 +9145,7 @@
       </p:sp>
       <p:sp>
         <p:nvSpPr>
-          <p:cNvPr id="22" name="Text 20"/>
+          <p:cNvPr id="24" name="Text 22"/>
           <p:cNvSpPr/>
           <p:nvPr/>
         </p:nvSpPr>
@@ -8834,7 +9184,7 @@
       </p:sp>
       <p:sp>
         <p:nvSpPr>
-          <p:cNvPr id="23" name="Shape 21"/>
+          <p:cNvPr id="25" name="Shape 23"/>
           <p:cNvSpPr/>
           <p:nvPr/>
         </p:nvSpPr>
@@ -8854,7 +9204,7 @@
       </p:sp>
       <p:sp>
         <p:nvSpPr>
-          <p:cNvPr id="24" name="Text 22"/>
+          <p:cNvPr id="26" name="Text 24"/>
           <p:cNvSpPr/>
           <p:nvPr/>
         </p:nvSpPr>
@@ -8893,7 +9243,7 @@
       </p:sp>
       <p:sp>
         <p:nvSpPr>
-          <p:cNvPr id="25" name="Shape 23"/>
+          <p:cNvPr id="27" name="Shape 25"/>
           <p:cNvSpPr/>
           <p:nvPr/>
         </p:nvSpPr>
@@ -8913,7 +9263,7 @@
       </p:sp>
       <p:sp>
         <p:nvSpPr>
-          <p:cNvPr id="26" name="Shape 24"/>
+          <p:cNvPr id="28" name="Shape 26"/>
           <p:cNvSpPr/>
           <p:nvPr/>
         </p:nvSpPr>
@@ -8926,11 +9276,15 @@
             <a:avLst/>
           </a:prstGeom>
           <a:solidFill>
-            <a:srgbClr val="152033"/>
+            <a:srgbClr val="FFFFFF">
+              <a:alpha val="12000"/>
+            </a:srgbClr>
           </a:solidFill>
-          <a:ln w="12700">
+          <a:ln w="9525">
             <a:solidFill>
-              <a:srgbClr val="2A4060"/>
+              <a:srgbClr val="5EEAD4">
+                <a:alpha val="30000"/>
+              </a:srgbClr>
             </a:solidFill>
             <a:prstDash val="solid"/>
           </a:ln>
@@ -8945,7 +9299,7 @@
       </p:sp>
       <p:sp>
         <p:nvSpPr>
-          <p:cNvPr id="27" name="Text 25"/>
+          <p:cNvPr id="29" name="Text 27"/>
           <p:cNvSpPr/>
           <p:nvPr/>
         </p:nvSpPr>
@@ -8984,7 +9338,7 @@
       </p:sp>
       <p:sp>
         <p:nvSpPr>
-          <p:cNvPr id="28" name="Text 26"/>
+          <p:cNvPr id="30" name="Text 28"/>
           <p:cNvSpPr/>
           <p:nvPr/>
         </p:nvSpPr>
@@ -9023,7 +9377,7 @@
       </p:sp>
       <p:sp>
         <p:nvSpPr>
-          <p:cNvPr id="29" name="Shape 27"/>
+          <p:cNvPr id="31" name="Shape 29"/>
           <p:cNvSpPr/>
           <p:nvPr/>
         </p:nvSpPr>
@@ -9043,7 +9397,7 @@
       </p:sp>
       <p:sp>
         <p:nvSpPr>
-          <p:cNvPr id="30" name="Text 28"/>
+          <p:cNvPr id="32" name="Text 30"/>
           <p:cNvSpPr/>
           <p:nvPr/>
         </p:nvSpPr>
@@ -9082,7 +9436,7 @@
       </p:sp>
       <p:sp>
         <p:nvSpPr>
-          <p:cNvPr id="31" name="Shape 29"/>
+          <p:cNvPr id="33" name="Shape 31"/>
           <p:cNvSpPr/>
           <p:nvPr/>
         </p:nvSpPr>
@@ -9095,11 +9449,15 @@
             <a:avLst/>
           </a:prstGeom>
           <a:solidFill>
-            <a:srgbClr val="152033"/>
+            <a:srgbClr val="FFFFFF">
+              <a:alpha val="12000"/>
+            </a:srgbClr>
           </a:solidFill>
-          <a:ln w="12700">
+          <a:ln w="9525">
             <a:solidFill>
-              <a:srgbClr val="2A4060"/>
+              <a:srgbClr val="5EEAD4">
+                <a:alpha val="30000"/>
+              </a:srgbClr>
             </a:solidFill>
             <a:prstDash val="solid"/>
           </a:ln>
@@ -9114,7 +9472,7 @@
       </p:sp>
       <p:sp>
         <p:nvSpPr>
-          <p:cNvPr id="32" name="Text 30"/>
+          <p:cNvPr id="34" name="Text 32"/>
           <p:cNvSpPr/>
           <p:nvPr/>
         </p:nvSpPr>
@@ -9153,7 +9511,7 @@
       </p:sp>
       <p:sp>
         <p:nvSpPr>
-          <p:cNvPr id="33" name="Text 31"/>
+          <p:cNvPr id="35" name="Text 33"/>
           <p:cNvSpPr/>
           <p:nvPr/>
         </p:nvSpPr>
@@ -9192,7 +9550,7 @@
       </p:sp>
       <p:sp>
         <p:nvSpPr>
-          <p:cNvPr id="34" name="Text 32"/>
+          <p:cNvPr id="36" name="Text 34"/>
           <p:cNvSpPr/>
           <p:nvPr/>
         </p:nvSpPr>
@@ -9231,7 +9589,7 @@
       </p:sp>
       <p:sp>
         <p:nvSpPr>
-          <p:cNvPr id="35" name="Text 33"/>
+          <p:cNvPr id="37" name="Text 35"/>
           <p:cNvSpPr/>
           <p:nvPr/>
         </p:nvSpPr>
@@ -9308,6 +9666,50 @@
         </p:nvSpPr>
         <p:spPr>
           <a:xfrm>
+            <a:off x="-1645920" y="-2011680"/>
+            <a:ext cx="4754880" cy="4754880"/>
+          </a:xfrm>
+          <a:prstGeom prst="ellipse">
+            <a:avLst/>
+          </a:prstGeom>
+          <a:solidFill>
+            <a:srgbClr val="0D9488">
+              <a:alpha val="12000"/>
+            </a:srgbClr>
+          </a:solidFill>
+          <a:ln/>
+        </p:spPr>
+      </p:sp>
+      <p:sp>
+        <p:nvSpPr>
+          <p:cNvPr id="3" name="Shape 1"/>
+          <p:cNvSpPr/>
+          <p:nvPr/>
+        </p:nvSpPr>
+        <p:spPr>
+          <a:xfrm>
+            <a:off x="9509760" y="3840480"/>
+            <a:ext cx="4206240" cy="4206240"/>
+          </a:xfrm>
+          <a:prstGeom prst="ellipse">
+            <a:avLst/>
+          </a:prstGeom>
+          <a:solidFill>
+            <a:srgbClr val="38BDF8">
+              <a:alpha val="10000"/>
+            </a:srgbClr>
+          </a:solidFill>
+          <a:ln/>
+        </p:spPr>
+      </p:sp>
+      <p:sp>
+        <p:nvSpPr>
+          <p:cNvPr id="4" name="Shape 2"/>
+          <p:cNvSpPr/>
+          <p:nvPr/>
+        </p:nvSpPr>
+        <p:spPr>
+          <a:xfrm>
             <a:off x="0" y="0"/>
             <a:ext cx="12191695" cy="73152"/>
           </a:xfrm>
@@ -9322,7 +9724,7 @@
       </p:sp>
       <p:sp>
         <p:nvSpPr>
-          <p:cNvPr id="3" name="Text 1"/>
+          <p:cNvPr id="5" name="Text 3"/>
           <p:cNvSpPr/>
           <p:nvPr/>
         </p:nvSpPr>
@@ -9361,7 +9763,7 @@
       </p:sp>
       <p:sp>
         <p:nvSpPr>
-          <p:cNvPr id="4" name="Text 2"/>
+          <p:cNvPr id="6" name="Text 4"/>
           <p:cNvSpPr/>
           <p:nvPr/>
         </p:nvSpPr>
@@ -9400,7 +9802,7 @@
       </p:sp>
       <p:sp>
         <p:nvSpPr>
-          <p:cNvPr id="5" name="Text 3"/>
+          <p:cNvPr id="7" name="Text 5"/>
           <p:cNvSpPr/>
           <p:nvPr/>
         </p:nvSpPr>
@@ -9439,7 +9841,7 @@
       </p:sp>
       <p:sp>
         <p:nvSpPr>
-          <p:cNvPr id="6" name="Shape 4"/>
+          <p:cNvPr id="8" name="Shape 6"/>
           <p:cNvSpPr/>
           <p:nvPr/>
         </p:nvSpPr>
@@ -9452,11 +9854,15 @@
             <a:avLst/>
           </a:prstGeom>
           <a:solidFill>
-            <a:srgbClr val="152033"/>
+            <a:srgbClr val="FFFFFF">
+              <a:alpha val="12000"/>
+            </a:srgbClr>
           </a:solidFill>
-          <a:ln w="12700">
+          <a:ln w="9525">
             <a:solidFill>
-              <a:srgbClr val="2A4060"/>
+              <a:srgbClr val="5EEAD4">
+                <a:alpha val="30000"/>
+              </a:srgbClr>
             </a:solidFill>
             <a:prstDash val="solid"/>
           </a:ln>
@@ -9471,7 +9877,7 @@
       </p:sp>
       <p:pic>
         <p:nvPicPr>
-          <p:cNvPr id="7" name="Image 0" descr="preencoded.png">    </p:cNvPr>
+          <p:cNvPr id="9" name="Image 0" descr="preencoded.png">    </p:cNvPr>
           <p:cNvPicPr>
             <a:picLocks noChangeAspect="1"/>
           </p:cNvPicPr>
@@ -9495,7 +9901,7 @@
       </p:pic>
       <p:sp>
         <p:nvSpPr>
-          <p:cNvPr id="8" name="Text 5"/>
+          <p:cNvPr id="10" name="Text 7"/>
           <p:cNvSpPr/>
           <p:nvPr/>
         </p:nvSpPr>
@@ -9534,7 +9940,7 @@
       </p:sp>
       <p:sp>
         <p:nvSpPr>
-          <p:cNvPr id="9" name="Text 6"/>
+          <p:cNvPr id="11" name="Text 8"/>
           <p:cNvSpPr/>
           <p:nvPr/>
         </p:nvSpPr>
@@ -9573,7 +9979,7 @@
       </p:sp>
       <p:sp>
         <p:nvSpPr>
-          <p:cNvPr id="10" name="Shape 7"/>
+          <p:cNvPr id="12" name="Shape 9"/>
           <p:cNvSpPr/>
           <p:nvPr/>
         </p:nvSpPr>
@@ -9586,11 +9992,15 @@
             <a:avLst/>
           </a:prstGeom>
           <a:solidFill>
-            <a:srgbClr val="152033"/>
+            <a:srgbClr val="FFFFFF">
+              <a:alpha val="12000"/>
+            </a:srgbClr>
           </a:solidFill>
-          <a:ln w="12700">
+          <a:ln w="9525">
             <a:solidFill>
-              <a:srgbClr val="2A4060"/>
+              <a:srgbClr val="5EEAD4">
+                <a:alpha val="30000"/>
+              </a:srgbClr>
             </a:solidFill>
             <a:prstDash val="solid"/>
           </a:ln>
@@ -9605,7 +10015,7 @@
       </p:sp>
       <p:pic>
         <p:nvPicPr>
-          <p:cNvPr id="11" name="Image 1" descr="preencoded.png">    </p:cNvPr>
+          <p:cNvPr id="13" name="Image 1" descr="preencoded.png">    </p:cNvPr>
           <p:cNvPicPr>
             <a:picLocks noChangeAspect="1"/>
           </p:cNvPicPr>
@@ -9629,7 +10039,7 @@
       </p:pic>
       <p:sp>
         <p:nvSpPr>
-          <p:cNvPr id="12" name="Text 8"/>
+          <p:cNvPr id="14" name="Text 10"/>
           <p:cNvSpPr/>
           <p:nvPr/>
         </p:nvSpPr>
@@ -9668,7 +10078,7 @@
       </p:sp>
       <p:sp>
         <p:nvSpPr>
-          <p:cNvPr id="13" name="Text 9"/>
+          <p:cNvPr id="15" name="Text 11"/>
           <p:cNvSpPr/>
           <p:nvPr/>
         </p:nvSpPr>
@@ -9707,7 +10117,7 @@
       </p:sp>
       <p:sp>
         <p:nvSpPr>
-          <p:cNvPr id="14" name="Shape 10"/>
+          <p:cNvPr id="16" name="Shape 12"/>
           <p:cNvSpPr/>
           <p:nvPr/>
         </p:nvSpPr>
@@ -9720,11 +10130,15 @@
             <a:avLst/>
           </a:prstGeom>
           <a:solidFill>
-            <a:srgbClr val="152033"/>
+            <a:srgbClr val="FFFFFF">
+              <a:alpha val="12000"/>
+            </a:srgbClr>
           </a:solidFill>
-          <a:ln w="12700">
+          <a:ln w="9525">
             <a:solidFill>
-              <a:srgbClr val="2A4060"/>
+              <a:srgbClr val="5EEAD4">
+                <a:alpha val="30000"/>
+              </a:srgbClr>
             </a:solidFill>
             <a:prstDash val="solid"/>
           </a:ln>
@@ -9739,7 +10153,7 @@
       </p:sp>
       <p:pic>
         <p:nvPicPr>
-          <p:cNvPr id="15" name="Image 2" descr="preencoded.png">    </p:cNvPr>
+          <p:cNvPr id="17" name="Image 2" descr="preencoded.png">    </p:cNvPr>
           <p:cNvPicPr>
             <a:picLocks noChangeAspect="1"/>
           </p:cNvPicPr>
@@ -9763,7 +10177,7 @@
       </p:pic>
       <p:sp>
         <p:nvSpPr>
-          <p:cNvPr id="16" name="Text 11"/>
+          <p:cNvPr id="18" name="Text 13"/>
           <p:cNvSpPr/>
           <p:nvPr/>
         </p:nvSpPr>
@@ -9802,7 +10216,7 @@
       </p:sp>
       <p:sp>
         <p:nvSpPr>
-          <p:cNvPr id="17" name="Text 12"/>
+          <p:cNvPr id="19" name="Text 14"/>
           <p:cNvSpPr/>
           <p:nvPr/>
         </p:nvSpPr>
@@ -9841,7 +10255,7 @@
       </p:sp>
       <p:sp>
         <p:nvSpPr>
-          <p:cNvPr id="18" name="Shape 13"/>
+          <p:cNvPr id="20" name="Shape 15"/>
           <p:cNvSpPr/>
           <p:nvPr/>
         </p:nvSpPr>
@@ -9854,11 +10268,15 @@
             <a:avLst/>
           </a:prstGeom>
           <a:solidFill>
-            <a:srgbClr val="152033"/>
+            <a:srgbClr val="FFFFFF">
+              <a:alpha val="12000"/>
+            </a:srgbClr>
           </a:solidFill>
-          <a:ln w="12700">
+          <a:ln w="9525">
             <a:solidFill>
-              <a:srgbClr val="2A4060"/>
+              <a:srgbClr val="5EEAD4">
+                <a:alpha val="30000"/>
+              </a:srgbClr>
             </a:solidFill>
             <a:prstDash val="solid"/>
           </a:ln>
@@ -9873,7 +10291,7 @@
       </p:sp>
       <p:pic>
         <p:nvPicPr>
-          <p:cNvPr id="19" name="Image 3" descr="preencoded.png">    </p:cNvPr>
+          <p:cNvPr id="21" name="Image 3" descr="preencoded.png">    </p:cNvPr>
           <p:cNvPicPr>
             <a:picLocks noChangeAspect="1"/>
           </p:cNvPicPr>
@@ -9897,7 +10315,7 @@
       </p:pic>
       <p:sp>
         <p:nvSpPr>
-          <p:cNvPr id="20" name="Text 14"/>
+          <p:cNvPr id="22" name="Text 16"/>
           <p:cNvSpPr/>
           <p:nvPr/>
         </p:nvSpPr>
@@ -9936,7 +10354,7 @@
       </p:sp>
       <p:sp>
         <p:nvSpPr>
-          <p:cNvPr id="21" name="Text 15"/>
+          <p:cNvPr id="23" name="Text 17"/>
           <p:cNvSpPr/>
           <p:nvPr/>
         </p:nvSpPr>
@@ -9975,7 +10393,7 @@
       </p:sp>
       <p:sp>
         <p:nvSpPr>
-          <p:cNvPr id="22" name="Shape 16"/>
+          <p:cNvPr id="24" name="Shape 18"/>
           <p:cNvSpPr/>
           <p:nvPr/>
         </p:nvSpPr>
@@ -9988,11 +10406,15 @@
             <a:avLst/>
           </a:prstGeom>
           <a:solidFill>
-            <a:srgbClr val="152033"/>
+            <a:srgbClr val="FFFFFF">
+              <a:alpha val="12000"/>
+            </a:srgbClr>
           </a:solidFill>
-          <a:ln w="12700">
+          <a:ln w="9525">
             <a:solidFill>
-              <a:srgbClr val="2A4060"/>
+              <a:srgbClr val="5EEAD4">
+                <a:alpha val="30000"/>
+              </a:srgbClr>
             </a:solidFill>
             <a:prstDash val="solid"/>
           </a:ln>
@@ -10007,7 +10429,7 @@
       </p:sp>
       <p:pic>
         <p:nvPicPr>
-          <p:cNvPr id="23" name="Image 4" descr="preencoded.png">    </p:cNvPr>
+          <p:cNvPr id="25" name="Image 4" descr="preencoded.png">    </p:cNvPr>
           <p:cNvPicPr>
             <a:picLocks noChangeAspect="1"/>
           </p:cNvPicPr>
@@ -10031,7 +10453,7 @@
       </p:pic>
       <p:sp>
         <p:nvSpPr>
-          <p:cNvPr id="24" name="Text 17"/>
+          <p:cNvPr id="26" name="Text 19"/>
           <p:cNvSpPr/>
           <p:nvPr/>
         </p:nvSpPr>
@@ -10070,7 +10492,7 @@
       </p:sp>
       <p:sp>
         <p:nvSpPr>
-          <p:cNvPr id="25" name="Text 18"/>
+          <p:cNvPr id="27" name="Text 20"/>
           <p:cNvSpPr/>
           <p:nvPr/>
         </p:nvSpPr>
@@ -10109,7 +10531,7 @@
       </p:sp>
       <p:sp>
         <p:nvSpPr>
-          <p:cNvPr id="26" name="Shape 19"/>
+          <p:cNvPr id="28" name="Shape 21"/>
           <p:cNvSpPr/>
           <p:nvPr/>
         </p:nvSpPr>
@@ -10122,11 +10544,15 @@
             <a:avLst/>
           </a:prstGeom>
           <a:solidFill>
-            <a:srgbClr val="152033"/>
+            <a:srgbClr val="FFFFFF">
+              <a:alpha val="12000"/>
+            </a:srgbClr>
           </a:solidFill>
-          <a:ln w="12700">
+          <a:ln w="9525">
             <a:solidFill>
-              <a:srgbClr val="2A4060"/>
+              <a:srgbClr val="5EEAD4">
+                <a:alpha val="30000"/>
+              </a:srgbClr>
             </a:solidFill>
             <a:prstDash val="solid"/>
           </a:ln>
@@ -10141,7 +10567,7 @@
       </p:sp>
       <p:pic>
         <p:nvPicPr>
-          <p:cNvPr id="27" name="Image 5" descr="preencoded.png">    </p:cNvPr>
+          <p:cNvPr id="29" name="Image 5" descr="preencoded.png">    </p:cNvPr>
           <p:cNvPicPr>
             <a:picLocks noChangeAspect="1"/>
           </p:cNvPicPr>
@@ -10165,7 +10591,7 @@
       </p:pic>
       <p:sp>
         <p:nvSpPr>
-          <p:cNvPr id="28" name="Text 20"/>
+          <p:cNvPr id="30" name="Text 22"/>
           <p:cNvSpPr/>
           <p:nvPr/>
         </p:nvSpPr>
@@ -10204,7 +10630,7 @@
       </p:sp>
       <p:sp>
         <p:nvSpPr>
-          <p:cNvPr id="29" name="Text 21"/>
+          <p:cNvPr id="31" name="Text 23"/>
           <p:cNvSpPr/>
           <p:nvPr/>
         </p:nvSpPr>
@@ -10243,7 +10669,7 @@
       </p:sp>
       <p:sp>
         <p:nvSpPr>
-          <p:cNvPr id="30" name="Text 22"/>
+          <p:cNvPr id="32" name="Text 24"/>
           <p:cNvSpPr/>
           <p:nvPr/>
         </p:nvSpPr>
@@ -10282,7 +10708,7 @@
       </p:sp>
       <p:sp>
         <p:nvSpPr>
-          <p:cNvPr id="31" name="Text 23"/>
+          <p:cNvPr id="33" name="Text 25"/>
           <p:cNvSpPr/>
           <p:nvPr/>
         </p:nvSpPr>
@@ -10359,6 +10785,50 @@
         </p:nvSpPr>
         <p:spPr>
           <a:xfrm>
+            <a:off x="-1645920" y="-2011680"/>
+            <a:ext cx="4754880" cy="4754880"/>
+          </a:xfrm>
+          <a:prstGeom prst="ellipse">
+            <a:avLst/>
+          </a:prstGeom>
+          <a:solidFill>
+            <a:srgbClr val="0D9488">
+              <a:alpha val="12000"/>
+            </a:srgbClr>
+          </a:solidFill>
+          <a:ln/>
+        </p:spPr>
+      </p:sp>
+      <p:sp>
+        <p:nvSpPr>
+          <p:cNvPr id="3" name="Shape 1"/>
+          <p:cNvSpPr/>
+          <p:nvPr/>
+        </p:nvSpPr>
+        <p:spPr>
+          <a:xfrm>
+            <a:off x="9509760" y="3840480"/>
+            <a:ext cx="4206240" cy="4206240"/>
+          </a:xfrm>
+          <a:prstGeom prst="ellipse">
+            <a:avLst/>
+          </a:prstGeom>
+          <a:solidFill>
+            <a:srgbClr val="38BDF8">
+              <a:alpha val="10000"/>
+            </a:srgbClr>
+          </a:solidFill>
+          <a:ln/>
+        </p:spPr>
+      </p:sp>
+      <p:sp>
+        <p:nvSpPr>
+          <p:cNvPr id="4" name="Shape 2"/>
+          <p:cNvSpPr/>
+          <p:nvPr/>
+        </p:nvSpPr>
+        <p:spPr>
+          <a:xfrm>
             <a:off x="0" y="0"/>
             <a:ext cx="12191695" cy="73152"/>
           </a:xfrm>
@@ -10373,7 +10843,7 @@
       </p:sp>
       <p:sp>
         <p:nvSpPr>
-          <p:cNvPr id="3" name="Text 1"/>
+          <p:cNvPr id="5" name="Text 3"/>
           <p:cNvSpPr/>
           <p:nvPr/>
         </p:nvSpPr>
@@ -10412,7 +10882,7 @@
       </p:sp>
       <p:sp>
         <p:nvSpPr>
-          <p:cNvPr id="4" name="Text 2"/>
+          <p:cNvPr id="6" name="Text 4"/>
           <p:cNvSpPr/>
           <p:nvPr/>
         </p:nvSpPr>
@@ -10451,7 +10921,7 @@
       </p:sp>
       <p:sp>
         <p:nvSpPr>
-          <p:cNvPr id="5" name="Text 3"/>
+          <p:cNvPr id="7" name="Text 5"/>
           <p:cNvSpPr/>
           <p:nvPr/>
         </p:nvSpPr>
@@ -10490,7 +10960,7 @@
       </p:sp>
       <p:graphicFrame>
         <p:nvGraphicFramePr>
-          <p:cNvPr id="6" name="Chart 0" descr=""/>
+          <p:cNvPr id="8" name="Chart 0" descr=""/>
           <p:cNvGraphicFramePr/>
           <p:nvPr/>
         </p:nvGraphicFramePr>
@@ -10506,7 +10976,7 @@
       </p:graphicFrame>
       <p:sp>
         <p:nvSpPr>
-          <p:cNvPr id="7" name="Shape 4"/>
+          <p:cNvPr id="9" name="Shape 6"/>
           <p:cNvSpPr/>
           <p:nvPr/>
         </p:nvSpPr>
@@ -10519,11 +10989,15 @@
             <a:avLst/>
           </a:prstGeom>
           <a:solidFill>
-            <a:srgbClr val="152033"/>
+            <a:srgbClr val="FFFFFF">
+              <a:alpha val="12000"/>
+            </a:srgbClr>
           </a:solidFill>
-          <a:ln w="12700">
+          <a:ln w="9525">
             <a:solidFill>
-              <a:srgbClr val="2A4060"/>
+              <a:srgbClr val="5EEAD4">
+                <a:alpha val="30000"/>
+              </a:srgbClr>
             </a:solidFill>
             <a:prstDash val="solid"/>
           </a:ln>
@@ -10538,7 +11012,7 @@
       </p:sp>
       <p:sp>
         <p:nvSpPr>
-          <p:cNvPr id="8" name="Text 5"/>
+          <p:cNvPr id="10" name="Text 7"/>
           <p:cNvSpPr/>
           <p:nvPr/>
         </p:nvSpPr>
@@ -10577,7 +11051,7 @@
       </p:sp>
       <p:sp>
         <p:nvSpPr>
-          <p:cNvPr id="9" name="Text 6"/>
+          <p:cNvPr id="11" name="Text 8"/>
           <p:cNvSpPr/>
           <p:nvPr/>
         </p:nvSpPr>
@@ -10616,7 +11090,7 @@
       </p:sp>
       <p:sp>
         <p:nvSpPr>
-          <p:cNvPr id="10" name="Shape 7"/>
+          <p:cNvPr id="12" name="Shape 9"/>
           <p:cNvSpPr/>
           <p:nvPr/>
         </p:nvSpPr>
@@ -10629,11 +11103,15 @@
             <a:avLst/>
           </a:prstGeom>
           <a:solidFill>
-            <a:srgbClr val="152033"/>
+            <a:srgbClr val="FFFFFF">
+              <a:alpha val="12000"/>
+            </a:srgbClr>
           </a:solidFill>
-          <a:ln w="12700">
+          <a:ln w="9525">
             <a:solidFill>
-              <a:srgbClr val="2A4060"/>
+              <a:srgbClr val="5EEAD4">
+                <a:alpha val="30000"/>
+              </a:srgbClr>
             </a:solidFill>
             <a:prstDash val="solid"/>
           </a:ln>
@@ -10648,7 +11126,7 @@
       </p:sp>
       <p:sp>
         <p:nvSpPr>
-          <p:cNvPr id="11" name="Text 8"/>
+          <p:cNvPr id="13" name="Text 10"/>
           <p:cNvSpPr/>
           <p:nvPr/>
         </p:nvSpPr>
@@ -10687,7 +11165,7 @@
       </p:sp>
       <p:sp>
         <p:nvSpPr>
-          <p:cNvPr id="12" name="Text 9"/>
+          <p:cNvPr id="14" name="Text 11"/>
           <p:cNvSpPr/>
           <p:nvPr/>
         </p:nvSpPr>
@@ -10726,7 +11204,7 @@
       </p:sp>
       <p:sp>
         <p:nvSpPr>
-          <p:cNvPr id="13" name="Shape 10"/>
+          <p:cNvPr id="15" name="Shape 12"/>
           <p:cNvSpPr/>
           <p:nvPr/>
         </p:nvSpPr>
@@ -10739,11 +11217,15 @@
             <a:avLst/>
           </a:prstGeom>
           <a:solidFill>
-            <a:srgbClr val="152033"/>
+            <a:srgbClr val="FFFFFF">
+              <a:alpha val="12000"/>
+            </a:srgbClr>
           </a:solidFill>
-          <a:ln w="12700">
+          <a:ln w="9525">
             <a:solidFill>
-              <a:srgbClr val="2A4060"/>
+              <a:srgbClr val="5EEAD4">
+                <a:alpha val="30000"/>
+              </a:srgbClr>
             </a:solidFill>
             <a:prstDash val="solid"/>
           </a:ln>
@@ -10758,7 +11240,7 @@
       </p:sp>
       <p:sp>
         <p:nvSpPr>
-          <p:cNvPr id="14" name="Text 11"/>
+          <p:cNvPr id="16" name="Text 13"/>
           <p:cNvSpPr/>
           <p:nvPr/>
         </p:nvSpPr>
@@ -10797,7 +11279,7 @@
       </p:sp>
       <p:sp>
         <p:nvSpPr>
-          <p:cNvPr id="15" name="Text 12"/>
+          <p:cNvPr id="17" name="Text 14"/>
           <p:cNvSpPr/>
           <p:nvPr/>
         </p:nvSpPr>
@@ -10836,7 +11318,7 @@
       </p:sp>
       <p:sp>
         <p:nvSpPr>
-          <p:cNvPr id="16" name="Text 13"/>
+          <p:cNvPr id="18" name="Text 15"/>
           <p:cNvSpPr/>
           <p:nvPr/>
         </p:nvSpPr>
@@ -10875,7 +11357,7 @@
       </p:sp>
       <p:sp>
         <p:nvSpPr>
-          <p:cNvPr id="17" name="Text 14"/>
+          <p:cNvPr id="19" name="Text 16"/>
           <p:cNvSpPr/>
           <p:nvPr/>
         </p:nvSpPr>
@@ -10952,6 +11434,50 @@
         </p:nvSpPr>
         <p:spPr>
           <a:xfrm>
+            <a:off x="-1645920" y="-2011680"/>
+            <a:ext cx="4754880" cy="4754880"/>
+          </a:xfrm>
+          <a:prstGeom prst="ellipse">
+            <a:avLst/>
+          </a:prstGeom>
+          <a:solidFill>
+            <a:srgbClr val="0D9488">
+              <a:alpha val="12000"/>
+            </a:srgbClr>
+          </a:solidFill>
+          <a:ln/>
+        </p:spPr>
+      </p:sp>
+      <p:sp>
+        <p:nvSpPr>
+          <p:cNvPr id="3" name="Shape 1"/>
+          <p:cNvSpPr/>
+          <p:nvPr/>
+        </p:nvSpPr>
+        <p:spPr>
+          <a:xfrm>
+            <a:off x="9509760" y="3840480"/>
+            <a:ext cx="4206240" cy="4206240"/>
+          </a:xfrm>
+          <a:prstGeom prst="ellipse">
+            <a:avLst/>
+          </a:prstGeom>
+          <a:solidFill>
+            <a:srgbClr val="38BDF8">
+              <a:alpha val="10000"/>
+            </a:srgbClr>
+          </a:solidFill>
+          <a:ln/>
+        </p:spPr>
+      </p:sp>
+      <p:sp>
+        <p:nvSpPr>
+          <p:cNvPr id="4" name="Shape 2"/>
+          <p:cNvSpPr/>
+          <p:nvPr/>
+        </p:nvSpPr>
+        <p:spPr>
+          <a:xfrm>
             <a:off x="0" y="0"/>
             <a:ext cx="12191695" cy="73152"/>
           </a:xfrm>
@@ -10966,7 +11492,7 @@
       </p:sp>
       <p:sp>
         <p:nvSpPr>
-          <p:cNvPr id="3" name="Text 1"/>
+          <p:cNvPr id="5" name="Text 3"/>
           <p:cNvSpPr/>
           <p:nvPr/>
         </p:nvSpPr>
@@ -11005,7 +11531,7 @@
       </p:sp>
       <p:sp>
         <p:nvSpPr>
-          <p:cNvPr id="4" name="Text 2"/>
+          <p:cNvPr id="6" name="Text 4"/>
           <p:cNvSpPr/>
           <p:nvPr/>
         </p:nvSpPr>
@@ -11044,7 +11570,7 @@
       </p:sp>
       <p:sp>
         <p:nvSpPr>
-          <p:cNvPr id="5" name="Text 3"/>
+          <p:cNvPr id="7" name="Text 5"/>
           <p:cNvSpPr/>
           <p:nvPr/>
         </p:nvSpPr>
@@ -11083,7 +11609,7 @@
       </p:sp>
       <p:graphicFrame>
         <p:nvGraphicFramePr>
-          <p:cNvPr id="6" name="Chart 0" descr=""/>
+          <p:cNvPr id="8" name="Chart 0" descr=""/>
           <p:cNvGraphicFramePr/>
           <p:nvPr/>
         </p:nvGraphicFramePr>
@@ -11099,7 +11625,7 @@
       </p:graphicFrame>
       <p:sp>
         <p:nvSpPr>
-          <p:cNvPr id="7" name="Shape 4"/>
+          <p:cNvPr id="9" name="Shape 6"/>
           <p:cNvSpPr/>
           <p:nvPr/>
         </p:nvSpPr>
@@ -11112,11 +11638,15 @@
             <a:avLst/>
           </a:prstGeom>
           <a:solidFill>
-            <a:srgbClr val="152033"/>
+            <a:srgbClr val="FFFFFF">
+              <a:alpha val="12000"/>
+            </a:srgbClr>
           </a:solidFill>
-          <a:ln w="12700">
+          <a:ln w="9525">
             <a:solidFill>
-              <a:srgbClr val="2A4060"/>
+              <a:srgbClr val="5EEAD4">
+                <a:alpha val="30000"/>
+              </a:srgbClr>
             </a:solidFill>
             <a:prstDash val="solid"/>
           </a:ln>
@@ -11131,7 +11661,7 @@
       </p:sp>
       <p:sp>
         <p:nvSpPr>
-          <p:cNvPr id="8" name="Text 5"/>
+          <p:cNvPr id="10" name="Text 7"/>
           <p:cNvSpPr/>
           <p:nvPr/>
         </p:nvSpPr>
@@ -11170,7 +11700,7 @@
       </p:sp>
       <p:sp>
         <p:nvSpPr>
-          <p:cNvPr id="9" name="Text 6"/>
+          <p:cNvPr id="11" name="Text 8"/>
           <p:cNvSpPr/>
           <p:nvPr/>
         </p:nvSpPr>
@@ -11209,7 +11739,7 @@
       </p:sp>
       <p:sp>
         <p:nvSpPr>
-          <p:cNvPr id="10" name="Shape 7"/>
+          <p:cNvPr id="12" name="Shape 9"/>
           <p:cNvSpPr/>
           <p:nvPr/>
         </p:nvSpPr>
@@ -11222,11 +11752,15 @@
             <a:avLst/>
           </a:prstGeom>
           <a:solidFill>
-            <a:srgbClr val="152033"/>
+            <a:srgbClr val="FFFFFF">
+              <a:alpha val="12000"/>
+            </a:srgbClr>
           </a:solidFill>
-          <a:ln w="12700">
+          <a:ln w="9525">
             <a:solidFill>
-              <a:srgbClr val="2A4060"/>
+              <a:srgbClr val="5EEAD4">
+                <a:alpha val="30000"/>
+              </a:srgbClr>
             </a:solidFill>
             <a:prstDash val="solid"/>
           </a:ln>
@@ -11241,7 +11775,7 @@
       </p:sp>
       <p:sp>
         <p:nvSpPr>
-          <p:cNvPr id="11" name="Text 8"/>
+          <p:cNvPr id="13" name="Text 10"/>
           <p:cNvSpPr/>
           <p:nvPr/>
         </p:nvSpPr>
@@ -11280,7 +11814,7 @@
       </p:sp>
       <p:sp>
         <p:nvSpPr>
-          <p:cNvPr id="12" name="Text 9"/>
+          <p:cNvPr id="14" name="Text 11"/>
           <p:cNvSpPr/>
           <p:nvPr/>
         </p:nvSpPr>
@@ -11319,7 +11853,7 @@
       </p:sp>
       <p:sp>
         <p:nvSpPr>
-          <p:cNvPr id="13" name="Shape 10"/>
+          <p:cNvPr id="15" name="Shape 12"/>
           <p:cNvSpPr/>
           <p:nvPr/>
         </p:nvSpPr>
@@ -11332,11 +11866,15 @@
             <a:avLst/>
           </a:prstGeom>
           <a:solidFill>
-            <a:srgbClr val="152033"/>
+            <a:srgbClr val="FFFFFF">
+              <a:alpha val="12000"/>
+            </a:srgbClr>
           </a:solidFill>
-          <a:ln w="12700">
+          <a:ln w="9525">
             <a:solidFill>
-              <a:srgbClr val="2A4060"/>
+              <a:srgbClr val="5EEAD4">
+                <a:alpha val="30000"/>
+              </a:srgbClr>
             </a:solidFill>
             <a:prstDash val="solid"/>
           </a:ln>
@@ -11351,7 +11889,7 @@
       </p:sp>
       <p:sp>
         <p:nvSpPr>
-          <p:cNvPr id="14" name="Text 11"/>
+          <p:cNvPr id="16" name="Text 13"/>
           <p:cNvSpPr/>
           <p:nvPr/>
         </p:nvSpPr>
@@ -11390,7 +11928,7 @@
       </p:sp>
       <p:sp>
         <p:nvSpPr>
-          <p:cNvPr id="15" name="Text 12"/>
+          <p:cNvPr id="17" name="Text 14"/>
           <p:cNvSpPr/>
           <p:nvPr/>
         </p:nvSpPr>
@@ -11429,7 +11967,7 @@
       </p:sp>
       <p:sp>
         <p:nvSpPr>
-          <p:cNvPr id="16" name="Text 13"/>
+          <p:cNvPr id="18" name="Text 15"/>
           <p:cNvSpPr/>
           <p:nvPr/>
         </p:nvSpPr>
@@ -11468,7 +12006,7 @@
       </p:sp>
       <p:sp>
         <p:nvSpPr>
-          <p:cNvPr id="17" name="Text 14"/>
+          <p:cNvPr id="19" name="Text 16"/>
           <p:cNvSpPr/>
           <p:nvPr/>
         </p:nvSpPr>
@@ -11545,6 +12083,50 @@
         </p:nvSpPr>
         <p:spPr>
           <a:xfrm>
+            <a:off x="-1645920" y="-2011680"/>
+            <a:ext cx="4754880" cy="4754880"/>
+          </a:xfrm>
+          <a:prstGeom prst="ellipse">
+            <a:avLst/>
+          </a:prstGeom>
+          <a:solidFill>
+            <a:srgbClr val="0D9488">
+              <a:alpha val="12000"/>
+            </a:srgbClr>
+          </a:solidFill>
+          <a:ln/>
+        </p:spPr>
+      </p:sp>
+      <p:sp>
+        <p:nvSpPr>
+          <p:cNvPr id="3" name="Shape 1"/>
+          <p:cNvSpPr/>
+          <p:nvPr/>
+        </p:nvSpPr>
+        <p:spPr>
+          <a:xfrm>
+            <a:off x="9509760" y="3840480"/>
+            <a:ext cx="4206240" cy="4206240"/>
+          </a:xfrm>
+          <a:prstGeom prst="ellipse">
+            <a:avLst/>
+          </a:prstGeom>
+          <a:solidFill>
+            <a:srgbClr val="38BDF8">
+              <a:alpha val="10000"/>
+            </a:srgbClr>
+          </a:solidFill>
+          <a:ln/>
+        </p:spPr>
+      </p:sp>
+      <p:sp>
+        <p:nvSpPr>
+          <p:cNvPr id="4" name="Shape 2"/>
+          <p:cNvSpPr/>
+          <p:nvPr/>
+        </p:nvSpPr>
+        <p:spPr>
+          <a:xfrm>
             <a:off x="0" y="0"/>
             <a:ext cx="12191695" cy="73152"/>
           </a:xfrm>
@@ -11559,7 +12141,7 @@
       </p:sp>
       <p:sp>
         <p:nvSpPr>
-          <p:cNvPr id="3" name="Text 1"/>
+          <p:cNvPr id="5" name="Text 3"/>
           <p:cNvSpPr/>
           <p:nvPr/>
         </p:nvSpPr>
@@ -11598,7 +12180,7 @@
       </p:sp>
       <p:sp>
         <p:nvSpPr>
-          <p:cNvPr id="4" name="Text 2"/>
+          <p:cNvPr id="6" name="Text 4"/>
           <p:cNvSpPr/>
           <p:nvPr/>
         </p:nvSpPr>
@@ -11637,7 +12219,7 @@
       </p:sp>
       <p:graphicFrame>
         <p:nvGraphicFramePr>
-          <p:cNvPr id="5" name="Chart 0" descr=""/>
+          <p:cNvPr id="7" name="Chart 0" descr=""/>
           <p:cNvGraphicFramePr/>
           <p:nvPr/>
         </p:nvGraphicFramePr>
@@ -11653,7 +12235,7 @@
       </p:graphicFrame>
       <p:sp>
         <p:nvSpPr>
-          <p:cNvPr id="6" name="Shape 3"/>
+          <p:cNvPr id="8" name="Shape 5"/>
           <p:cNvSpPr/>
           <p:nvPr/>
         </p:nvSpPr>
@@ -11666,14 +12248,23 @@
             <a:avLst/>
           </a:prstGeom>
           <a:solidFill>
-            <a:srgbClr val="101827"/>
+            <a:srgbClr val="FFFFFF">
+              <a:alpha val="12000"/>
+            </a:srgbClr>
           </a:solidFill>
-          <a:ln/>
-        </p:spPr>
-      </p:sp>
-      <p:sp>
-        <p:nvSpPr>
-          <p:cNvPr id="7" name="Text 4"/>
+          <a:ln w="9525">
+            <a:solidFill>
+              <a:srgbClr val="5EEAD4">
+                <a:alpha val="30000"/>
+              </a:srgbClr>
+            </a:solidFill>
+            <a:prstDash val="solid"/>
+          </a:ln>
+        </p:spPr>
+      </p:sp>
+      <p:sp>
+        <p:nvSpPr>
+          <p:cNvPr id="9" name="Text 6"/>
           <p:cNvSpPr/>
           <p:nvPr/>
         </p:nvSpPr>
@@ -11712,7 +12303,7 @@
       </p:sp>
       <p:sp>
         <p:nvSpPr>
-          <p:cNvPr id="8" name="Text 5"/>
+          <p:cNvPr id="10" name="Text 7"/>
           <p:cNvSpPr/>
           <p:nvPr/>
         </p:nvSpPr>
@@ -11751,7 +12342,7 @@
       </p:sp>
       <p:sp>
         <p:nvSpPr>
-          <p:cNvPr id="9" name="Text 6"/>
+          <p:cNvPr id="11" name="Text 8"/>
           <p:cNvSpPr/>
           <p:nvPr/>
         </p:nvSpPr>
@@ -11790,7 +12381,7 @@
       </p:sp>
       <p:sp>
         <p:nvSpPr>
-          <p:cNvPr id="10" name="Text 7"/>
+          <p:cNvPr id="12" name="Text 9"/>
           <p:cNvSpPr/>
           <p:nvPr/>
         </p:nvSpPr>
@@ -11829,7 +12420,7 @@
       </p:sp>
       <p:sp>
         <p:nvSpPr>
-          <p:cNvPr id="11" name="Text 8"/>
+          <p:cNvPr id="13" name="Text 10"/>
           <p:cNvSpPr/>
           <p:nvPr/>
         </p:nvSpPr>
@@ -11868,7 +12459,7 @@
       </p:sp>
       <p:sp>
         <p:nvSpPr>
-          <p:cNvPr id="12" name="Text 9"/>
+          <p:cNvPr id="14" name="Text 11"/>
           <p:cNvSpPr/>
           <p:nvPr/>
         </p:nvSpPr>
@@ -11907,7 +12498,7 @@
       </p:sp>
       <p:sp>
         <p:nvSpPr>
-          <p:cNvPr id="13" name="Text 10"/>
+          <p:cNvPr id="15" name="Text 12"/>
           <p:cNvSpPr/>
           <p:nvPr/>
         </p:nvSpPr>
@@ -11984,6 +12575,50 @@
         </p:nvSpPr>
         <p:spPr>
           <a:xfrm>
+            <a:off x="-1645920" y="-2011680"/>
+            <a:ext cx="4754880" cy="4754880"/>
+          </a:xfrm>
+          <a:prstGeom prst="ellipse">
+            <a:avLst/>
+          </a:prstGeom>
+          <a:solidFill>
+            <a:srgbClr val="0D9488">
+              <a:alpha val="12000"/>
+            </a:srgbClr>
+          </a:solidFill>
+          <a:ln/>
+        </p:spPr>
+      </p:sp>
+      <p:sp>
+        <p:nvSpPr>
+          <p:cNvPr id="3" name="Shape 1"/>
+          <p:cNvSpPr/>
+          <p:nvPr/>
+        </p:nvSpPr>
+        <p:spPr>
+          <a:xfrm>
+            <a:off x="9509760" y="3840480"/>
+            <a:ext cx="4206240" cy="4206240"/>
+          </a:xfrm>
+          <a:prstGeom prst="ellipse">
+            <a:avLst/>
+          </a:prstGeom>
+          <a:solidFill>
+            <a:srgbClr val="38BDF8">
+              <a:alpha val="10000"/>
+            </a:srgbClr>
+          </a:solidFill>
+          <a:ln/>
+        </p:spPr>
+      </p:sp>
+      <p:sp>
+        <p:nvSpPr>
+          <p:cNvPr id="4" name="Shape 2"/>
+          <p:cNvSpPr/>
+          <p:nvPr/>
+        </p:nvSpPr>
+        <p:spPr>
+          <a:xfrm>
             <a:off x="0" y="0"/>
             <a:ext cx="12191695" cy="73152"/>
           </a:xfrm>
@@ -11998,7 +12633,7 @@
       </p:sp>
       <p:sp>
         <p:nvSpPr>
-          <p:cNvPr id="3" name="Text 1"/>
+          <p:cNvPr id="5" name="Text 3"/>
           <p:cNvSpPr/>
           <p:nvPr/>
         </p:nvSpPr>
@@ -12037,7 +12672,7 @@
       </p:sp>
       <p:sp>
         <p:nvSpPr>
-          <p:cNvPr id="4" name="Text 2"/>
+          <p:cNvPr id="6" name="Text 4"/>
           <p:cNvSpPr/>
           <p:nvPr/>
         </p:nvSpPr>
@@ -12076,7 +12711,7 @@
       </p:sp>
       <p:sp>
         <p:nvSpPr>
-          <p:cNvPr id="5" name="Shape 3"/>
+          <p:cNvPr id="7" name="Shape 5"/>
           <p:cNvSpPr/>
           <p:nvPr/>
         </p:nvSpPr>
@@ -12089,11 +12724,15 @@
             <a:avLst/>
           </a:prstGeom>
           <a:solidFill>
-            <a:srgbClr val="152033"/>
+            <a:srgbClr val="FFFFFF">
+              <a:alpha val="12000"/>
+            </a:srgbClr>
           </a:solidFill>
-          <a:ln w="12700">
+          <a:ln w="9525">
             <a:solidFill>
-              <a:srgbClr val="2A4060"/>
+              <a:srgbClr val="5EEAD4">
+                <a:alpha val="30000"/>
+              </a:srgbClr>
             </a:solidFill>
             <a:prstDash val="solid"/>
           </a:ln>
@@ -12108,7 +12747,7 @@
       </p:sp>
       <p:sp>
         <p:nvSpPr>
-          <p:cNvPr id="6" name="Shape 4"/>
+          <p:cNvPr id="8" name="Shape 6"/>
           <p:cNvSpPr/>
           <p:nvPr/>
         </p:nvSpPr>
@@ -12128,7 +12767,7 @@
       </p:sp>
       <p:pic>
         <p:nvPicPr>
-          <p:cNvPr id="7" name="Image 0" descr="preencoded.png">    </p:cNvPr>
+          <p:cNvPr id="9" name="Image 0" descr="preencoded.png">    </p:cNvPr>
           <p:cNvPicPr>
             <a:picLocks noChangeAspect="1"/>
           </p:cNvPicPr>
@@ -12152,7 +12791,7 @@
       </p:pic>
       <p:sp>
         <p:nvSpPr>
-          <p:cNvPr id="8" name="Text 5"/>
+          <p:cNvPr id="10" name="Text 7"/>
           <p:cNvSpPr/>
           <p:nvPr/>
         </p:nvSpPr>
@@ -12191,7 +12830,7 @@
       </p:sp>
       <p:sp>
         <p:nvSpPr>
-          <p:cNvPr id="9" name="Text 6"/>
+          <p:cNvPr id="11" name="Text 8"/>
           <p:cNvSpPr/>
           <p:nvPr/>
         </p:nvSpPr>
@@ -12230,7 +12869,7 @@
       </p:sp>
       <p:sp>
         <p:nvSpPr>
-          <p:cNvPr id="10" name="Shape 7"/>
+          <p:cNvPr id="12" name="Shape 9"/>
           <p:cNvSpPr/>
           <p:nvPr/>
         </p:nvSpPr>
@@ -12243,11 +12882,15 @@
             <a:avLst/>
           </a:prstGeom>
           <a:solidFill>
-            <a:srgbClr val="152033"/>
+            <a:srgbClr val="FFFFFF">
+              <a:alpha val="12000"/>
+            </a:srgbClr>
           </a:solidFill>
-          <a:ln w="12700">
+          <a:ln w="9525">
             <a:solidFill>
-              <a:srgbClr val="2A4060"/>
+              <a:srgbClr val="5EEAD4">
+                <a:alpha val="30000"/>
+              </a:srgbClr>
             </a:solidFill>
             <a:prstDash val="solid"/>
           </a:ln>
@@ -12262,7 +12905,7 @@
       </p:sp>
       <p:sp>
         <p:nvSpPr>
-          <p:cNvPr id="11" name="Shape 8"/>
+          <p:cNvPr id="13" name="Shape 10"/>
           <p:cNvSpPr/>
           <p:nvPr/>
         </p:nvSpPr>
@@ -12282,7 +12925,7 @@
       </p:sp>
       <p:pic>
         <p:nvPicPr>
-          <p:cNvPr id="12" name="Image 1" descr="preencoded.png">    </p:cNvPr>
+          <p:cNvPr id="14" name="Image 1" descr="preencoded.png">    </p:cNvPr>
           <p:cNvPicPr>
             <a:picLocks noChangeAspect="1"/>
           </p:cNvPicPr>
@@ -12306,7 +12949,7 @@
       </p:pic>
       <p:sp>
         <p:nvSpPr>
-          <p:cNvPr id="13" name="Text 9"/>
+          <p:cNvPr id="15" name="Text 11"/>
           <p:cNvSpPr/>
           <p:nvPr/>
         </p:nvSpPr>
@@ -12345,7 +12988,7 @@
       </p:sp>
       <p:sp>
         <p:nvSpPr>
-          <p:cNvPr id="14" name="Text 10"/>
+          <p:cNvPr id="16" name="Text 12"/>
           <p:cNvSpPr/>
           <p:nvPr/>
         </p:nvSpPr>
@@ -12384,7 +13027,7 @@
       </p:sp>
       <p:sp>
         <p:nvSpPr>
-          <p:cNvPr id="15" name="Shape 11"/>
+          <p:cNvPr id="17" name="Shape 13"/>
           <p:cNvSpPr/>
           <p:nvPr/>
         </p:nvSpPr>
@@ -12397,11 +13040,15 @@
             <a:avLst/>
           </a:prstGeom>
           <a:solidFill>
-            <a:srgbClr val="152033"/>
+            <a:srgbClr val="FFFFFF">
+              <a:alpha val="12000"/>
+            </a:srgbClr>
           </a:solidFill>
-          <a:ln w="12700">
+          <a:ln w="9525">
             <a:solidFill>
-              <a:srgbClr val="2A4060"/>
+              <a:srgbClr val="5EEAD4">
+                <a:alpha val="30000"/>
+              </a:srgbClr>
             </a:solidFill>
             <a:prstDash val="solid"/>
           </a:ln>
@@ -12416,7 +13063,7 @@
       </p:sp>
       <p:sp>
         <p:nvSpPr>
-          <p:cNvPr id="16" name="Shape 12"/>
+          <p:cNvPr id="18" name="Shape 14"/>
           <p:cNvSpPr/>
           <p:nvPr/>
         </p:nvSpPr>
@@ -12436,7 +13083,7 @@
       </p:sp>
       <p:pic>
         <p:nvPicPr>
-          <p:cNvPr id="17" name="Image 2" descr="preencoded.png">    </p:cNvPr>
+          <p:cNvPr id="19" name="Image 2" descr="preencoded.png">    </p:cNvPr>
           <p:cNvPicPr>
             <a:picLocks noChangeAspect="1"/>
           </p:cNvPicPr>
@@ -12460,7 +13107,7 @@
       </p:pic>
       <p:sp>
         <p:nvSpPr>
-          <p:cNvPr id="18" name="Text 13"/>
+          <p:cNvPr id="20" name="Text 15"/>
           <p:cNvSpPr/>
           <p:nvPr/>
         </p:nvSpPr>
@@ -12499,7 +13146,7 @@
       </p:sp>
       <p:sp>
         <p:nvSpPr>
-          <p:cNvPr id="19" name="Text 14"/>
+          <p:cNvPr id="21" name="Text 16"/>
           <p:cNvSpPr/>
           <p:nvPr/>
         </p:nvSpPr>
@@ -12538,7 +13185,7 @@
       </p:sp>
       <p:sp>
         <p:nvSpPr>
-          <p:cNvPr id="20" name="Shape 15"/>
+          <p:cNvPr id="22" name="Shape 17"/>
           <p:cNvSpPr/>
           <p:nvPr/>
         </p:nvSpPr>
@@ -12551,11 +13198,15 @@
             <a:avLst/>
           </a:prstGeom>
           <a:solidFill>
-            <a:srgbClr val="152033"/>
+            <a:srgbClr val="FFFFFF">
+              <a:alpha val="12000"/>
+            </a:srgbClr>
           </a:solidFill>
-          <a:ln w="12700">
+          <a:ln w="9525">
             <a:solidFill>
-              <a:srgbClr val="2A4060"/>
+              <a:srgbClr val="5EEAD4">
+                <a:alpha val="30000"/>
+              </a:srgbClr>
             </a:solidFill>
             <a:prstDash val="solid"/>
           </a:ln>
@@ -12570,7 +13221,7 @@
       </p:sp>
       <p:sp>
         <p:nvSpPr>
-          <p:cNvPr id="21" name="Shape 16"/>
+          <p:cNvPr id="23" name="Shape 18"/>
           <p:cNvSpPr/>
           <p:nvPr/>
         </p:nvSpPr>
@@ -12590,7 +13241,7 @@
       </p:sp>
       <p:pic>
         <p:nvPicPr>
-          <p:cNvPr id="22" name="Image 3" descr="preencoded.png">    </p:cNvPr>
+          <p:cNvPr id="24" name="Image 3" descr="preencoded.png">    </p:cNvPr>
           <p:cNvPicPr>
             <a:picLocks noChangeAspect="1"/>
           </p:cNvPicPr>
@@ -12614,7 +13265,7 @@
       </p:pic>
       <p:sp>
         <p:nvSpPr>
-          <p:cNvPr id="23" name="Text 17"/>
+          <p:cNvPr id="25" name="Text 19"/>
           <p:cNvSpPr/>
           <p:nvPr/>
         </p:nvSpPr>
@@ -12653,7 +13304,7 @@
       </p:sp>
       <p:sp>
         <p:nvSpPr>
-          <p:cNvPr id="24" name="Text 18"/>
+          <p:cNvPr id="26" name="Text 20"/>
           <p:cNvSpPr/>
           <p:nvPr/>
         </p:nvSpPr>
@@ -12692,7 +13343,7 @@
       </p:sp>
       <p:sp>
         <p:nvSpPr>
-          <p:cNvPr id="25" name="Shape 19"/>
+          <p:cNvPr id="27" name="Shape 21"/>
           <p:cNvSpPr/>
           <p:nvPr/>
         </p:nvSpPr>
@@ -12705,11 +13356,15 @@
             <a:avLst/>
           </a:prstGeom>
           <a:solidFill>
-            <a:srgbClr val="152033"/>
+            <a:srgbClr val="FFFFFF">
+              <a:alpha val="12000"/>
+            </a:srgbClr>
           </a:solidFill>
-          <a:ln w="12700">
+          <a:ln w="9525">
             <a:solidFill>
-              <a:srgbClr val="2A4060"/>
+              <a:srgbClr val="5EEAD4">
+                <a:alpha val="30000"/>
+              </a:srgbClr>
             </a:solidFill>
             <a:prstDash val="solid"/>
           </a:ln>
@@ -12724,7 +13379,7 @@
       </p:sp>
       <p:sp>
         <p:nvSpPr>
-          <p:cNvPr id="26" name="Shape 20"/>
+          <p:cNvPr id="28" name="Shape 22"/>
           <p:cNvSpPr/>
           <p:nvPr/>
         </p:nvSpPr>
@@ -12744,7 +13399,7 @@
       </p:sp>
       <p:pic>
         <p:nvPicPr>
-          <p:cNvPr id="27" name="Image 4" descr="preencoded.png">    </p:cNvPr>
+          <p:cNvPr id="29" name="Image 4" descr="preencoded.png">    </p:cNvPr>
           <p:cNvPicPr>
             <a:picLocks noChangeAspect="1"/>
           </p:cNvPicPr>
@@ -12768,7 +13423,7 @@
       </p:pic>
       <p:sp>
         <p:nvSpPr>
-          <p:cNvPr id="28" name="Text 21"/>
+          <p:cNvPr id="30" name="Text 23"/>
           <p:cNvSpPr/>
           <p:nvPr/>
         </p:nvSpPr>
@@ -12807,7 +13462,7 @@
       </p:sp>
       <p:sp>
         <p:nvSpPr>
-          <p:cNvPr id="29" name="Text 22"/>
+          <p:cNvPr id="31" name="Text 24"/>
           <p:cNvSpPr/>
           <p:nvPr/>
         </p:nvSpPr>
@@ -12846,7 +13501,7 @@
       </p:sp>
       <p:sp>
         <p:nvSpPr>
-          <p:cNvPr id="30" name="Shape 23"/>
+          <p:cNvPr id="32" name="Shape 25"/>
           <p:cNvSpPr/>
           <p:nvPr/>
         </p:nvSpPr>
@@ -12859,11 +13514,15 @@
             <a:avLst/>
           </a:prstGeom>
           <a:solidFill>
-            <a:srgbClr val="152033"/>
+            <a:srgbClr val="FFFFFF">
+              <a:alpha val="12000"/>
+            </a:srgbClr>
           </a:solidFill>
-          <a:ln w="12700">
+          <a:ln w="9525">
             <a:solidFill>
-              <a:srgbClr val="2A4060"/>
+              <a:srgbClr val="5EEAD4">
+                <a:alpha val="30000"/>
+              </a:srgbClr>
             </a:solidFill>
             <a:prstDash val="solid"/>
           </a:ln>
@@ -12878,7 +13537,7 @@
       </p:sp>
       <p:sp>
         <p:nvSpPr>
-          <p:cNvPr id="31" name="Shape 24"/>
+          <p:cNvPr id="33" name="Shape 26"/>
           <p:cNvSpPr/>
           <p:nvPr/>
         </p:nvSpPr>
@@ -12898,7 +13557,7 @@
       </p:sp>
       <p:pic>
         <p:nvPicPr>
-          <p:cNvPr id="32" name="Image 5" descr="preencoded.png">    </p:cNvPr>
+          <p:cNvPr id="34" name="Image 5" descr="preencoded.png">    </p:cNvPr>
           <p:cNvPicPr>
             <a:picLocks noChangeAspect="1"/>
           </p:cNvPicPr>
@@ -12922,7 +13581,7 @@
       </p:pic>
       <p:sp>
         <p:nvSpPr>
-          <p:cNvPr id="33" name="Text 25"/>
+          <p:cNvPr id="35" name="Text 27"/>
           <p:cNvSpPr/>
           <p:nvPr/>
         </p:nvSpPr>
@@ -12961,7 +13620,7 @@
       </p:sp>
       <p:sp>
         <p:nvSpPr>
-          <p:cNvPr id="34" name="Text 26"/>
+          <p:cNvPr id="36" name="Text 28"/>
           <p:cNvSpPr/>
           <p:nvPr/>
         </p:nvSpPr>
@@ -13000,7 +13659,7 @@
       </p:sp>
       <p:sp>
         <p:nvSpPr>
-          <p:cNvPr id="35" name="Text 27"/>
+          <p:cNvPr id="37" name="Text 29"/>
           <p:cNvSpPr/>
           <p:nvPr/>
         </p:nvSpPr>
@@ -13039,7 +13698,7 @@
       </p:sp>
       <p:sp>
         <p:nvSpPr>
-          <p:cNvPr id="36" name="Text 28"/>
+          <p:cNvPr id="38" name="Text 30"/>
           <p:cNvSpPr/>
           <p:nvPr/>
         </p:nvSpPr>

</xml_diff>

<commit_message>
docs: retarget executive proposal to BAC Guatemala
HTML and PPTX now address BAC Credomatic Guatemala (Spanish first line,
America/Guatemala calendar, local DID piloto). Cost/benefit ranges stay
illustrative. Tests require BAC + Guatemala in both artifacts.
</commit_message>
<xml_diff>
--- a/docs/Propuesta_Callcenter_Bancario.pptx
+++ b/docs/Propuesta_Callcenter_Bancario.pptx
@@ -3142,23 +3142,23 @@
         <p:spPr>
           <a:xfrm>
             <a:off x="1115568" y="457200"/>
-            <a:ext cx="9144000" cy="292608"/>
-          </a:xfrm>
-          <a:prstGeom prst="rect">
-            <a:avLst/>
-          </a:prstGeom>
-          <a:noFill/>
-          <a:ln/>
-        </p:spPr>
-        <p:txBody>
-          <a:bodyPr wrap="square" lIns="0" tIns="0" rIns="0" bIns="0" rtlCol="0" anchor="ctr"/>
-          <a:lstStyle/>
-          <a:p>
-            <a:pPr indent="0" marL="0">
-              <a:buNone/>
-            </a:pPr>
-            <a:r>
-              <a:rPr lang="en-US" sz="1200" b="1" spc="160" kern="0" dirty="0">
+            <a:ext cx="10058400" cy="292608"/>
+          </a:xfrm>
+          <a:prstGeom prst="rect">
+            <a:avLst/>
+          </a:prstGeom>
+          <a:noFill/>
+          <a:ln/>
+        </p:spPr>
+        <p:txBody>
+          <a:bodyPr wrap="square" lIns="0" tIns="0" rIns="0" bIns="0" rtlCol="0" anchor="ctr"/>
+          <a:lstStyle/>
+          <a:p>
+            <a:pPr indent="0" marL="0">
+              <a:buNone/>
+            </a:pPr>
+            <a:r>
+              <a:rPr lang="en-US" sz="1200" b="1" spc="140" kern="0" dirty="0">
                 <a:solidFill>
                   <a:srgbClr val="5EEAD4"/>
                 </a:solidFill>
@@ -3166,7 +3166,7 @@
                 <a:ea typeface="Calibri" pitchFamily="34" charset="-122"/>
                 <a:cs typeface="Calibri" pitchFamily="34" charset="-120"/>
               </a:rPr>
-              <a:t>PROPUESTA EJECUTIVA  ·  CALLCENTER BANCARIO</a:t>
+              <a:t>PROPUESTA EJECUTIVA  ·  BAC GUATEMALA  ·  CALLCENTER BANCARIO</a:t>
             </a:r>
             <a:endParaRPr lang="en-US" sz="1200" dirty="0"/>
           </a:p>
@@ -3181,23 +3181,23 @@
         <p:spPr>
           <a:xfrm>
             <a:off x="640080" y="1234440"/>
-            <a:ext cx="8595360" cy="1737360"/>
-          </a:xfrm>
-          <a:prstGeom prst="rect">
-            <a:avLst/>
-          </a:prstGeom>
-          <a:noFill/>
-          <a:ln/>
-        </p:spPr>
-        <p:txBody>
-          <a:bodyPr wrap="square" lIns="0" tIns="0" rIns="0" bIns="0" rtlCol="0" anchor="ctr"/>
-          <a:lstStyle/>
-          <a:p>
-            <a:pPr indent="0" marL="0">
-              <a:buNone/>
-            </a:pPr>
-            <a:r>
-              <a:rPr lang="en-US" sz="3400" b="1" dirty="0">
+            <a:ext cx="8778240" cy="1737360"/>
+          </a:xfrm>
+          <a:prstGeom prst="rect">
+            <a:avLst/>
+          </a:prstGeom>
+          <a:noFill/>
+          <a:ln/>
+        </p:spPr>
+        <p:txBody>
+          <a:bodyPr wrap="square" lIns="0" tIns="0" rIns="0" bIns="0" rtlCol="0" anchor="ctr"/>
+          <a:lstStyle/>
+          <a:p>
+            <a:pPr indent="0" marL="0">
+              <a:buNone/>
+            </a:pPr>
+            <a:r>
+              <a:rPr lang="en-US" sz="3200" b="1" dirty="0">
                 <a:solidFill>
                   <a:srgbClr val="F8FAFC"/>
                 </a:solidFill>
@@ -3205,16 +3205,16 @@
                 <a:ea typeface="Calibri" pitchFamily="34" charset="-122"/>
                 <a:cs typeface="Calibri" pitchFamily="34" charset="-120"/>
               </a:rPr>
-              <a:t>Menos costo de primera línea.</a:t>
-            </a:r>
-            <a:endParaRPr lang="en-US" sz="3400" dirty="0"/>
-          </a:p>
-          <a:p>
-            <a:pPr indent="0" marL="0">
-              <a:buNone/>
-            </a:pPr>
-            <a:r>
-              <a:rPr lang="en-US" sz="3400" b="1" dirty="0">
+              <a:t>Primera línea de voz para</a:t>
+            </a:r>
+            <a:endParaRPr lang="en-US" sz="3200" dirty="0"/>
+          </a:p>
+          <a:p>
+            <a:pPr indent="0" marL="0">
+              <a:buNone/>
+            </a:pPr>
+            <a:r>
+              <a:rPr lang="en-US" sz="3200" b="1" dirty="0">
                 <a:solidFill>
                   <a:srgbClr val="F8FAFC"/>
                 </a:solidFill>
@@ -3222,9 +3222,9 @@
                 <a:ea typeface="Calibri" pitchFamily="34" charset="-122"/>
                 <a:cs typeface="Calibri" pitchFamily="34" charset="-120"/>
               </a:rPr>
-              <a:t>Más control. Misma voz de marca.</a:t>
-            </a:r>
-            <a:endParaRPr lang="en-US" sz="3400" dirty="0"/>
+              <a:t>BAC Credomatic Guatemala.</a:t>
+            </a:r>
+            <a:endParaRPr lang="en-US" sz="3200" dirty="0"/>
           </a:p>
         </p:txBody>
       </p:sp>
@@ -3236,24 +3236,24 @@
         </p:nvSpPr>
         <p:spPr>
           <a:xfrm>
-            <a:off x="640080" y="3154680"/>
-            <a:ext cx="7863840" cy="777240"/>
-          </a:xfrm>
-          <a:prstGeom prst="rect">
-            <a:avLst/>
-          </a:prstGeom>
-          <a:noFill/>
-          <a:ln/>
-        </p:spPr>
-        <p:txBody>
-          <a:bodyPr wrap="square" lIns="0" tIns="0" rIns="0" bIns="0" rtlCol="0" anchor="ctr"/>
-          <a:lstStyle/>
-          <a:p>
-            <a:pPr indent="0" marL="0">
-              <a:buNone/>
-            </a:pPr>
-            <a:r>
-              <a:rPr lang="en-US" sz="1600" dirty="0">
+            <a:off x="640080" y="3108960"/>
+            <a:ext cx="8046720" cy="822960"/>
+          </a:xfrm>
+          <a:prstGeom prst="rect">
+            <a:avLst/>
+          </a:prstGeom>
+          <a:noFill/>
+          <a:ln/>
+        </p:spPr>
+        <p:txBody>
+          <a:bodyPr wrap="square" lIns="0" tIns="0" rIns="0" bIns="0" rtlCol="0" anchor="ctr"/>
+          <a:lstStyle/>
+          <a:p>
+            <a:pPr indent="0" marL="0">
+              <a:buNone/>
+            </a:pPr>
+            <a:r>
+              <a:rPr lang="en-US" sz="1500" dirty="0">
                 <a:solidFill>
                   <a:srgbClr val="CBD5E1"/>
                 </a:solidFill>
@@ -3261,9 +3261,9 @@
                 <a:ea typeface="Calibri" pitchFamily="34" charset="-122"/>
                 <a:cs typeface="Calibri" pitchFamily="34" charset="-120"/>
               </a:rPr>
-              <a:t>Call Management atiende llamadas inbound por telefonía SIP con Grok Voice Think Fast 2.0, opera banking_support (identidad, cuenta, tarjeta) y deja rastro en CRM, supervisor y grabación.</a:t>
-            </a:r>
-            <a:endParaRPr lang="en-US" sz="1600" dirty="0"/>
+              <a:t>Call Management atiende llamadas inbound por telefonía SIP con Grok Voice Think Fast 2.0, opera banking_support (identidad, cuenta BAC, tarjeta) y deja rastro en CRM, supervisor y grabación — día calendario America/Guatemala.</a:t>
+            </a:r>
+            <a:endParaRPr lang="en-US" sz="1500" dirty="0"/>
           </a:p>
         </p:txBody>
       </p:sp>
@@ -3532,7 +3532,7 @@
                 <a:ea typeface="Calibri" pitchFamily="34" charset="-122"/>
                 <a:cs typeface="Calibri" pitchFamily="34" charset="-120"/>
               </a:rPr>
-              <a:t>Cobertura de voz sin</a:t>
+              <a:t>Cobertura de voz en horario</a:t>
             </a:r>
             <a:endParaRPr lang="en-US" sz="1300" dirty="0"/>
           </a:p>
@@ -3549,7 +3549,7 @@
                 <a:ea typeface="Calibri" pitchFamily="34" charset="-122"/>
                 <a:cs typeface="Calibri" pitchFamily="34" charset="-120"/>
               </a:rPr>
-              <a:t>abrir un segundo turno</a:t>
+              <a:t>de Guatemala, sin segundo turno</a:t>
             </a:r>
             <a:endParaRPr lang="en-US" sz="1300" dirty="0"/>
           </a:p>
@@ -3676,7 +3676,7 @@
                 <a:ea typeface="Calibri" pitchFamily="34" charset="-122"/>
                 <a:cs typeface="Calibri" pitchFamily="34" charset="-120"/>
               </a:rPr>
-              <a:t>Aislamiento por empresa</a:t>
+              <a:t>Tenant BAC Guatemala aislado:</a:t>
             </a:r>
             <a:endParaRPr lang="en-US" sz="1300" dirty="0"/>
           </a:p>
@@ -3693,7 +3693,7 @@
                 <a:ea typeface="Calibri" pitchFamily="34" charset="-122"/>
                 <a:cs typeface="Calibri" pitchFamily="34" charset="-120"/>
               </a:rPr>
-              <a:t>sin mezclar clientes</a:t>
+              <a:t>clientes y grabaciones propios</a:t>
             </a:r>
             <a:endParaRPr lang="en-US" sz="1300" dirty="0"/>
           </a:p>
@@ -4577,7 +4577,7 @@
                 <a:ea typeface="Calibri" pitchFamily="34" charset="-122"/>
                 <a:cs typeface="Calibri" pitchFamily="34" charset="-120"/>
               </a:rPr>
-              <a:t>Call Management  ·  propuesta ejecutiva  ·  rangos ilustrativos, no ROI auditado</a:t>
+              <a:t>Call Management  ·  BAC Guatemala  ·  rangos ilustrativos, no ROI auditado</a:t>
             </a:r>
             <a:endParaRPr lang="en-US" sz="1000" dirty="0"/>
           </a:p>
@@ -5415,7 +5415,7 @@
                 <a:ea typeface="Calibri" pitchFamily="34" charset="-122"/>
                 <a:cs typeface="Calibri" pitchFamily="34" charset="-120"/>
               </a:rPr>
-              <a:t>max_calls_per_day + timezone</a:t>
+              <a:t>max_calls_per_day + America/Guatemala</a:t>
             </a:r>
             <a:endParaRPr lang="en-US" sz="1600" dirty="0"/>
           </a:p>
@@ -5454,7 +5454,7 @@
                 <a:ea typeface="Calibri" pitchFamily="34" charset="-122"/>
                 <a:cs typeface="Calibri" pitchFamily="34" charset="-120"/>
               </a:rPr>
-              <a:t>Día calendario de la empresa, no UTC a ciegas.</a:t>
+              <a:t>El tope diario sigue el calendario de Guatemala, no UTC.</a:t>
             </a:r>
             <a:endParaRPr lang="en-US" sz="1400" dirty="0"/>
           </a:p>
@@ -5493,7 +5493,7 @@
                 <a:ea typeface="Calibri" pitchFamily="34" charset="-122"/>
                 <a:cs typeface="Calibri" pitchFamily="34" charset="-120"/>
               </a:rPr>
-              <a:t>Call Management  ·  propuesta ejecutiva  ·  rangos ilustrativos, no ROI auditado</a:t>
+              <a:t>Call Management  ·  BAC Guatemala  ·  rangos ilustrativos, no ROI auditado</a:t>
             </a:r>
             <a:endParaRPr lang="en-US" sz="1000" dirty="0"/>
           </a:p>
@@ -5638,23 +5638,23 @@
         <p:spPr>
           <a:xfrm>
             <a:off x="640080" y="777240"/>
-            <a:ext cx="7498080" cy="1371600"/>
-          </a:xfrm>
-          <a:prstGeom prst="rect">
-            <a:avLst/>
-          </a:prstGeom>
-          <a:noFill/>
-          <a:ln/>
-        </p:spPr>
-        <p:txBody>
-          <a:bodyPr wrap="square" lIns="0" tIns="0" rIns="0" bIns="0" rtlCol="0" anchor="ctr"/>
-          <a:lstStyle/>
-          <a:p>
-            <a:pPr indent="0" marL="0">
-              <a:buNone/>
-            </a:pPr>
-            <a:r>
-              <a:rPr lang="en-US" sz="2800" b="1" dirty="0">
+            <a:ext cx="7680960" cy="1371600"/>
+          </a:xfrm>
+          <a:prstGeom prst="rect">
+            <a:avLst/>
+          </a:prstGeom>
+          <a:noFill/>
+          <a:ln/>
+        </p:spPr>
+        <p:txBody>
+          <a:bodyPr wrap="square" lIns="0" tIns="0" rIns="0" bIns="0" rtlCol="0" anchor="ctr"/>
+          <a:lstStyle/>
+          <a:p>
+            <a:pPr indent="0" marL="0">
+              <a:buNone/>
+            </a:pPr>
+            <a:r>
+              <a:rPr lang="en-US" sz="2600" b="1" dirty="0">
                 <a:solidFill>
                   <a:srgbClr val="F8FAFC"/>
                 </a:solidFill>
@@ -5664,14 +5664,14 @@
               </a:rPr>
               <a:t>Autorizar un piloto de 30 días</a:t>
             </a:r>
-            <a:endParaRPr lang="en-US" sz="2800" dirty="0"/>
-          </a:p>
-          <a:p>
-            <a:pPr indent="0" marL="0">
-              <a:buNone/>
-            </a:pPr>
-            <a:r>
-              <a:rPr lang="en-US" sz="2800" b="1" dirty="0">
+            <a:endParaRPr lang="en-US" sz="2600" dirty="0"/>
+          </a:p>
+          <a:p>
+            <a:pPr indent="0" marL="0">
+              <a:buNone/>
+            </a:pPr>
+            <a:r>
+              <a:rPr lang="en-US" sz="2600" b="1" dirty="0">
                 <a:solidFill>
                   <a:srgbClr val="F8FAFC"/>
                 </a:solidFill>
@@ -5679,9 +5679,9 @@
                 <a:ea typeface="Calibri" pitchFamily="34" charset="-122"/>
                 <a:cs typeface="Calibri" pitchFamily="34" charset="-120"/>
               </a:rPr>
-              <a:t>y medir costo, mix y calidad.</a:t>
-            </a:r>
-            <a:endParaRPr lang="en-US" sz="2800" dirty="0"/>
+              <a:t>en el callcenter de BAC Guatemala.</a:t>
+            </a:r>
+            <a:endParaRPr lang="en-US" sz="2600" dirty="0"/>
           </a:p>
         </p:txBody>
       </p:sp>
@@ -5777,7 +5777,7 @@
                 <a:ea typeface="Calibri" pitchFamily="34" charset="-122"/>
                 <a:cs typeface="Calibri" pitchFamily="34" charset="-120"/>
               </a:rPr>
-              <a:t>DID de prueba + instancia banking_support activa.</a:t>
+              <a:t>DID de prueba de BAC Guatemala + instancia banking_support activa.</a:t>
             </a:r>
             <a:endParaRPr lang="en-US" sz="1600" dirty="0"/>
           </a:p>
@@ -5875,7 +5875,7 @@
                 <a:ea typeface="Calibri" pitchFamily="34" charset="-122"/>
                 <a:cs typeface="Calibri" pitchFamily="34" charset="-120"/>
               </a:rPr>
-              <a:t>Playground xAI y LiveKit con operaciones y cumplimiento.</a:t>
+              <a:t>Playground xAI y LiveKit con operaciones y cumplimiento de BAC.</a:t>
             </a:r>
             <a:endParaRPr lang="en-US" sz="1600" dirty="0"/>
           </a:p>
@@ -6071,7 +6071,7 @@
                 <a:ea typeface="Calibri" pitchFamily="34" charset="-122"/>
                 <a:cs typeface="Calibri" pitchFamily="34" charset="-120"/>
               </a:rPr>
-              <a:t>Decisión de producción con horarios, voz de marca y webhooks.</a:t>
+              <a:t>Producción con horario America/Guatemala, voz de marca y webhooks.</a:t>
             </a:r>
             <a:endParaRPr lang="en-US" sz="1600" dirty="0"/>
           </a:p>
@@ -6198,7 +6198,7 @@
                 <a:ea typeface="Calibri" pitchFamily="34" charset="-122"/>
                 <a:cs typeface="Calibri" pitchFamily="34" charset="-120"/>
               </a:rPr>
-              <a:t>Una línea bancaria,</a:t>
+              <a:t>Una línea de BAC Guatemala,</a:t>
             </a:r>
             <a:endParaRPr lang="en-US" sz="1400" dirty="0"/>
           </a:p>
@@ -6486,7 +6486,7 @@
                 <a:ea typeface="Calibri" pitchFamily="34" charset="-122"/>
                 <a:cs typeface="Calibri" pitchFamily="34" charset="-120"/>
               </a:rPr>
-              <a:t>Dirección autoriza</a:t>
+              <a:t>Dirección de BAC Guatemala</a:t>
             </a:r>
             <a:endParaRPr lang="en-US" sz="1400" dirty="0"/>
           </a:p>
@@ -6503,7 +6503,7 @@
                 <a:ea typeface="Calibri" pitchFamily="34" charset="-122"/>
                 <a:cs typeface="Calibri" pitchFamily="34" charset="-120"/>
               </a:rPr>
-              <a:t>y nombra un sponsor</a:t>
+              <a:t>autoriza y nombra sponsor</a:t>
             </a:r>
             <a:endParaRPr lang="en-US" sz="1400" dirty="0"/>
           </a:p>
@@ -6542,7 +6542,7 @@
                 <a:ea typeface="Calibri" pitchFamily="34" charset="-122"/>
                 <a:cs typeface="Calibri" pitchFamily="34" charset="-120"/>
               </a:rPr>
-              <a:t>Call Management  ·  propuesta ejecutiva para callcenter bancario</a:t>
+              <a:t>Call Management  ·  propuesta ejecutiva para el callcenter bancario de BAC Guatemala</a:t>
             </a:r>
             <a:endParaRPr lang="en-US" sz="1100" dirty="0"/>
           </a:p>
@@ -6755,7 +6755,7 @@
                 <a:ea typeface="Calibri" pitchFamily="34" charset="-122"/>
                 <a:cs typeface="Calibri" pitchFamily="34" charset="-120"/>
               </a:rPr>
-              <a:t>El callcenter bancario paga de más por trabajo repetible</a:t>
+              <a:t>El callcenter bancario de BAC Guatemala paga de más por trabajo repetible</a:t>
             </a:r>
             <a:endParaRPr lang="en-US" sz="2600" dirty="0"/>
           </a:p>
@@ -6794,7 +6794,7 @@
                 <a:ea typeface="Calibri" pitchFamily="34" charset="-122"/>
                 <a:cs typeface="Calibri" pitchFamily="34" charset="-120"/>
               </a:rPr>
-              <a:t>Hoy el costo se va a espera, repetición de datos, turnos extra y retrabajo. No a la conversación que sí requiere un humano.</a:t>
+              <a:t>Hoy el costo se va a espera, repetición de datos, turnos extra y retrabajo. No a la conversación que sí requiere un humano de BAC.</a:t>
             </a:r>
             <a:endParaRPr lang="en-US" sz="1400" dirty="0"/>
           </a:p>
@@ -7208,7 +7208,7 @@
                 <a:ea typeface="Calibri" pitchFamily="34" charset="-122"/>
                 <a:cs typeface="Calibri" pitchFamily="34" charset="-120"/>
               </a:rPr>
-              <a:t>Un segundo turno humano es el renglón más caro del P&amp;L.</a:t>
+              <a:t>Noche y feriados en America/Guatemala: un segundo turno humano es el renglón más caro.</a:t>
             </a:r>
             <a:endParaRPr lang="en-US" sz="1300" dirty="0"/>
           </a:p>
@@ -7440,7 +7440,7 @@
                 <a:ea typeface="Calibri" pitchFamily="34" charset="-122"/>
                 <a:cs typeface="Calibri" pitchFamily="34" charset="-120"/>
               </a:rPr>
-              <a:t>Call Management  ·  propuesta ejecutiva  ·  rangos ilustrativos, no ROI auditado</a:t>
+              <a:t>Call Management  ·  BAC Guatemala  ·  rangos ilustrativos, no ROI auditado</a:t>
             </a:r>
             <a:endParaRPr lang="en-US" sz="1000" dirty="0"/>
           </a:p>
@@ -7653,7 +7653,7 @@
                 <a:ea typeface="Calibri" pitchFamily="34" charset="-122"/>
                 <a:cs typeface="Calibri" pitchFamily="34" charset="-120"/>
               </a:rPr>
-              <a:t>Call Management: voz, banca, CRM y control en un sistema</a:t>
+              <a:t>Call Management para el contact center de BAC Guatemala</a:t>
             </a:r>
             <a:endParaRPr lang="en-US" sz="2600" dirty="0"/>
           </a:p>
@@ -8172,7 +8172,7 @@
                 <a:ea typeface="Calibri" pitchFamily="34" charset="-122"/>
                 <a:cs typeface="Calibri" pitchFamily="34" charset="-120"/>
               </a:rPr>
-              <a:t>Identidad, cuenta BAC, tarjeta débito, bloqueo temporal, resumen de productos, escalación.</a:t>
+              <a:t>Identidad, cuenta BAC, tarjeta débito, bloqueo temporal, resumen y escalación en español.</a:t>
             </a:r>
             <a:endParaRPr lang="en-US" sz="1500" dirty="0"/>
           </a:p>
@@ -8384,7 +8384,7 @@
                 <a:ea typeface="Calibri" pitchFamily="34" charset="-122"/>
                 <a:cs typeface="Calibri" pitchFamily="34" charset="-120"/>
               </a:rPr>
-              <a:t>Call Management  ·  propuesta ejecutiva  ·  rangos ilustrativos, no ROI auditado</a:t>
+              <a:t>Call Management  ·  BAC Guatemala  ·  rangos ilustrativos, no ROI auditado</a:t>
             </a:r>
             <a:endParaRPr lang="en-US" sz="1000" dirty="0"/>
           </a:p>
@@ -9176,7 +9176,7 @@
                 <a:ea typeface="Calibri" pitchFamily="34" charset="-122"/>
                 <a:cs typeface="Calibri" pitchFamily="34" charset="-120"/>
               </a:rPr>
-              <a:t>Día calendario del tenant + 3 capas SQLite.</a:t>
+              <a:t>Día calendario America/Guatemala + 3 capas SQLite.</a:t>
             </a:r>
             <a:endParaRPr lang="en-US" sz="1400" dirty="0"/>
           </a:p>
@@ -9581,7 +9581,7 @@
                 <a:ea typeface="Calibri" pitchFamily="34" charset="-122"/>
                 <a:cs typeface="Calibri" pitchFamily="34" charset="-120"/>
               </a:rPr>
-              <a:t>Call Management  ·  propuesta ejecutiva  ·  rangos ilustrativos, no ROI auditado</a:t>
+              <a:t>Call Management  ·  BAC Guatemala  ·  rangos ilustrativos, no ROI auditado</a:t>
             </a:r>
             <a:endParaRPr lang="en-US" sz="1000" dirty="0"/>
           </a:p>
@@ -9833,7 +9833,7 @@
                 <a:ea typeface="Calibri" pitchFamily="34" charset="-122"/>
                 <a:cs typeface="Calibri" pitchFamily="34" charset="-120"/>
               </a:rPr>
-              <a:t>Apertura: «BAC Credomatic, buenos días, ¿en qué le puedo ayudar?»  El agente no asume identidad. lookup_customer usa el teléfono que el caller dicta.</a:t>
+              <a:t>Apertura de la instancia Guatemala: «BAC Credomatic Guatemala, buenos días, ¿en qué le puedo ayudar?» El agente no asume identidad. lookup_customer usa el teléfono que el caller dicta.</a:t>
             </a:r>
             <a:endParaRPr lang="en-US" sz="1400" dirty="0"/>
           </a:p>
@@ -10700,7 +10700,7 @@
                 <a:ea typeface="Calibri" pitchFamily="34" charset="-122"/>
                 <a:cs typeface="Calibri" pitchFamily="34" charset="-120"/>
               </a:rPr>
-              <a:t>Call Management  ·  propuesta ejecutiva  ·  rangos ilustrativos, no ROI auditado</a:t>
+              <a:t>Call Management  ·  BAC Guatemala  ·  rangos ilustrativos, no ROI auditado</a:t>
             </a:r>
             <a:endParaRPr lang="en-US" sz="1000" dirty="0"/>
           </a:p>
@@ -11349,7 +11349,7 @@
                 <a:ea typeface="Calibri" pitchFamily="34" charset="-122"/>
                 <a:cs typeface="Calibri" pitchFamily="34" charset="-120"/>
               </a:rPr>
-              <a:t>Call Management  ·  propuesta ejecutiva  ·  rangos ilustrativos, no ROI auditado</a:t>
+              <a:t>Call Management  ·  BAC Guatemala  ·  rangos ilustrativos, no ROI auditado</a:t>
             </a:r>
             <a:endParaRPr lang="en-US" sz="1000" dirty="0"/>
           </a:p>
@@ -11601,7 +11601,7 @@
                 <a:ea typeface="Calibri" pitchFamily="34" charset="-122"/>
                 <a:cs typeface="Calibri" pitchFamily="34" charset="-120"/>
               </a:rPr>
-              <a:t>Rango ilustrativo de operación bancaria de primer nivel. Calibrar con un piloto de 2–4 semanas.</a:t>
+              <a:t>Rango ilustrativo de primer nivel en el contact center de BAC Guatemala. Calibrar con un piloto de 2–4 semanas.</a:t>
             </a:r>
             <a:endParaRPr lang="en-US" sz="1400" dirty="0"/>
           </a:p>
@@ -11845,7 +11845,7 @@
                 <a:ea typeface="Calibri" pitchFamily="34" charset="-122"/>
                 <a:cs typeface="Calibri" pitchFamily="34" charset="-120"/>
               </a:rPr>
-              <a:t>DID bancario con instancia, voz e instrucciones de la empresa — no un default genérico</a:t>
+              <a:t>DID de BAC Guatemala con instancia, voz e instrucciones locales</a:t>
             </a:r>
             <a:endParaRPr lang="en-US" sz="1400" dirty="0"/>
           </a:p>
@@ -11998,7 +11998,7 @@
                 <a:ea typeface="Calibri" pitchFamily="34" charset="-122"/>
                 <a:cs typeface="Calibri" pitchFamily="34" charset="-120"/>
               </a:rPr>
-              <a:t>Call Management  ·  propuesta ejecutiva  ·  rangos ilustrativos, no ROI auditado</a:t>
+              <a:t>Call Management  ·  BAC Guatemala  ·  rangos ilustrativos, no ROI auditado</a:t>
             </a:r>
             <a:endParaRPr lang="en-US" sz="1000" dirty="0"/>
           </a:p>
@@ -12490,7 +12490,7 @@
                 <a:ea typeface="Calibri" pitchFamily="34" charset="-122"/>
                 <a:cs typeface="Calibri" pitchFamily="34" charset="-120"/>
               </a:rPr>
-              <a:t>Call Management  ·  propuesta ejecutiva  ·  rangos ilustrativos, no ROI auditado</a:t>
+              <a:t>Call Management  ·  BAC Guatemala  ·  rangos ilustrativos, no ROI auditado</a:t>
             </a:r>
             <a:endParaRPr lang="en-US" sz="1000" dirty="0"/>
           </a:p>
@@ -12703,7 +12703,7 @@
                 <a:ea typeface="Calibri" pitchFamily="34" charset="-122"/>
                 <a:cs typeface="Calibri" pitchFamily="34" charset="-120"/>
               </a:rPr>
-              <a:t>Lo que gana dirección, operaciones y cumplimiento</a:t>
+              <a:t>Lo que gana dirección de canales y cumplimiento en BAC Guatemala</a:t>
             </a:r>
             <a:endParaRPr lang="en-US" sz="2600" dirty="0"/>
           </a:p>
@@ -13493,7 +13493,7 @@
                 <a:ea typeface="Calibri" pitchFamily="34" charset="-122"/>
                 <a:cs typeface="Calibri" pitchFamily="34" charset="-120"/>
               </a:rPr>
-              <a:t>Español natural, una pregunta, voz de marca (26 voces xAI).</a:t>
+              <a:t>Español de Guatemala, una pregunta, voz de marca BAC (26 voces xAI).</a:t>
             </a:r>
             <a:endParaRPr lang="en-US" sz="1400" dirty="0"/>
           </a:p>
@@ -13612,7 +13612,7 @@
                 <a:ea typeface="Calibri" pitchFamily="34" charset="-122"/>
                 <a:cs typeface="Calibri" pitchFamily="34" charset="-120"/>
               </a:rPr>
-              <a:t>Multi-empresa</a:t>
+              <a:t>Aislamiento</a:t>
             </a:r>
             <a:endParaRPr lang="en-US" sz="1600" dirty="0"/>
           </a:p>
@@ -13651,7 +13651,7 @@
                 <a:ea typeface="Calibri" pitchFamily="34" charset="-122"/>
                 <a:cs typeface="Calibri" pitchFamily="34" charset="-120"/>
               </a:rPr>
-              <a:t>Varios bancos o marcas en un stack, CRM aislado, cupos independientes.</a:t>
+              <a:t>Tenant BAC Guatemala con CRM propio; otras marcas no ven esos clientes.</a:t>
             </a:r>
             <a:endParaRPr lang="en-US" sz="1400" dirty="0"/>
           </a:p>
@@ -13690,7 +13690,7 @@
                 <a:ea typeface="Calibri" pitchFamily="34" charset="-122"/>
                 <a:cs typeface="Calibri" pitchFamily="34" charset="-120"/>
               </a:rPr>
-              <a:t>Call Management  ·  propuesta ejecutiva  ·  rangos ilustrativos, no ROI auditado</a:t>
+              <a:t>Call Management  ·  BAC Guatemala  ·  rangos ilustrativos, no ROI auditado</a:t>
             </a:r>
             <a:endParaRPr lang="en-US" sz="1000" dirty="0"/>
           </a:p>

</xml_diff>